<commit_message>
Retire Matthieu 22 (le denier) de la prédication « À l'image de Christ-Jésus »
- Plan : nouvelle accroche tirée de l'arrière-plan (le roi, « image » du
  dieu; Genèse 1.27 l'accorde à tout être humain); application du point V
  sans renvoi au denier; PDF régénéré.
- Recherche : sermon 2356, renvoi Matthieu 22.19-21 et mentions du denier
  retirés; sources ramenées à dix-huit sermons; PDF, MD et HTML régénérés.
- Présentation : diapositive 3 refaite (le pharaon, puis la personne),
  notes des diapositives 3 et 8 révisées.

Co-Authored-By: Claude Opus 5.5 <noreply@anthropic.com>
</commit_message>
<xml_diff>
--- a/Presentation-A-l-image-de-Christ.pptx
+++ b/Presentation-A-l-image-de-Christ.pptx
@@ -775,7 +775,7 @@
           <a:p>
             <a:r>
               <a:rPr lang="en-US" dirty="0"/>
-              <a:t>3 min. Matthieu 22.20 : « De qui porte-t-il l'effigie et l'inscription? » Le grec eikôn veut dire image. « Comme l'image de César était frappée sur la pièce pour être rendue à César, l'image de Dieu est frappée sur une vie pour être rendue à Dieu » (2356). Question : vous aussi, vous portez une image. Laquelle? Qu'est-il arrivé à cette image, et que Dieu en fait-il?</a:t>
+              <a:t>3 min. Dans l'Antiquité, l'« image » d'un dieu, c'était le roi : Toutânkhamon signifie « image vivante d'Amon »; en Mésopotamie, le roi dressait son effigie aux confins de ses territoires. Genèse 1.27 accorde ce titre à l'être humain comme tel, homme et femme, sans rang ni lignée. Tselem désigne ailleurs les statues cultuelles. Question : vous aussi, vous portez une image. Laquelle? Qu'est-il arrivé à cette image, et que Dieu en fait-il?</a:t>
             </a:r>
             <a:endParaRPr lang="en-US" dirty="0"/>
           </a:p>
@@ -1215,7 +1215,7 @@
           <a:p>
             <a:r>
               <a:rPr lang="en-US" dirty="0"/>
-              <a:t>7 min. A. Le piège des 613 commandements; Jésus répond par le Shema (Dt 6.5) et Lv 19.18 (2358). « Quand vous aimez Dieu comme il faut, vous aimez les gens comme il faut » (2358). B. « Parce que nous n'avons pas aimé ainsi, nous avons besoin du pardon, et parce que nous ne pouvons pas aimer ainsi, nous avons besoin d'une capacité nouvelle » (2358). C. Lire Jérémie 31.33 (NBS). La nouvelle alliance : « le pardon de tous nos péchés et l'écriture de la loi de Dieu sur nos cœurs » (80-286). Le cœur (1 Ch 28.9) : rationnel, moral, relationnel. Application : nous l'aimons parce qu'il nous a aimés le premier (1 Jn 4.19); lui rendre la vie qui porte son image (retour au denier).</a:t>
+              <a:t>7 min. A. Le piège des 613 commandements; Jésus répond par le Shema (Dt 6.5) et Lv 19.18 (2358). « Quand vous aimez Dieu comme il faut, vous aimez les gens comme il faut » (2358). B. « Parce que nous n'avons pas aimé ainsi, nous avons besoin du pardon, et parce que nous ne pouvons pas aimer ainsi, nous avons besoin d'une capacité nouvelle » (2358). C. Lire Jérémie 31.33 (NBS). La nouvelle alliance : « le pardon de tous nos péchés et l'écriture de la loi de Dieu sur nos cœurs » (80-286). Le cœur (1 Ch 28.9) : rationnel, moral, relationnel. Application : nous l'aimons parce qu'il nous a aimés le premier (1 Jn 4.19), et cet amour se prouve par l'obéissance (Jn 14.15).</a:t>
             </a:r>
             <a:endParaRPr lang="en-US" dirty="0"/>
           </a:p>
@@ -3866,7 +3866,7 @@
                 <a:ea typeface="Calibri" pitchFamily="34" charset="-122"/>
                 <a:cs typeface="Calibri" pitchFamily="34" charset="-120"/>
               </a:rPr>
-              <a:t>INTRODUCTION · MATTHIEU 22.20-21</a:t>
+              <a:t>INTRODUCTION · GENÈSE 1.27</a:t>
             </a:r>
             <a:endParaRPr lang="en-US" sz="1300" dirty="0"/>
           </a:p>
@@ -3905,7 +3905,7 @@
                 <a:ea typeface="Cambria" pitchFamily="34" charset="-122"/>
                 <a:cs typeface="Cambria" pitchFamily="34" charset="-120"/>
               </a:rPr>
-              <a:t>De qui porte-t-il l'image?</a:t>
+              <a:t>Qui porte l'image de Dieu?</a:t>
             </a:r>
             <a:endParaRPr lang="en-US" sz="3800" dirty="0"/>
           </a:p>
@@ -3944,7 +3944,7 @@
                 <a:ea typeface="Calibri" pitchFamily="34" charset="-122"/>
                 <a:cs typeface="Calibri" pitchFamily="34" charset="-120"/>
               </a:rPr>
-              <a:t>« Rendez donc à César ce qui est à César, et à Dieu ce qui est à Dieu. »</a:t>
+              <a:t>L'image représentait, et rendait présent, celui qu'elle figurait.</a:t>
             </a:r>
             <a:endParaRPr lang="en-US" sz="1900" dirty="0"/>
           </a:p>
@@ -3952,7 +3952,7 @@
       </p:sp>
       <p:pic>
         <p:nvPicPr>
-          <p:cNvPr id="5" name="Image 0" descr="Le denier à l'effigie de César, à côté d'une pièce à l'effigie d'une personne">    </p:cNvPr>
+          <p:cNvPr id="5" name="Image 0" descr="Le pharaon, « image vivante » du dieu, puis une personne à l'image de Dieu">    </p:cNvPr>
           <p:cNvPicPr>
             <a:picLocks noChangeAspect="1"/>
           </p:cNvPicPr>
@@ -3982,8 +3982,8 @@
         </p:nvSpPr>
         <p:spPr>
           <a:xfrm>
-            <a:off x="548640" y="5120640"/>
-            <a:ext cx="3108960" cy="685800"/>
+            <a:off x="365760" y="5120640"/>
+            <a:ext cx="3474720" cy="685800"/>
           </a:xfrm>
           <a:prstGeom prst="rect">
             <a:avLst/>
@@ -4001,13 +4001,69 @@
             <a:r>
               <a:rPr lang="en-US" sz="1600" b="1" dirty="0">
                 <a:solidFill>
+                  <a:srgbClr val="F4EDE4"/>
+                </a:solidFill>
+                <a:latin typeface="Calibri" pitchFamily="34" charset="0"/>
+                <a:ea typeface="Calibri" pitchFamily="34" charset="-122"/>
+                <a:cs typeface="Calibri" pitchFamily="34" charset="-120"/>
+              </a:rPr>
+              <a:t>Autour d'Israël : le roi seul</a:t>
+            </a:r>
+            <a:endParaRPr lang="en-US" sz="1600" dirty="0"/>
+          </a:p>
+          <a:p>
+            <a:pPr algn="ctr" indent="0" marL="0">
+              <a:buNone/>
+            </a:pPr>
+            <a:r>
+              <a:rPr lang="en-US" sz="1600" dirty="0">
+                <a:solidFill>
+                  <a:srgbClr val="A89A8C"/>
+                </a:solidFill>
+                <a:latin typeface="Calibri" pitchFamily="34" charset="0"/>
+                <a:ea typeface="Calibri" pitchFamily="34" charset="-122"/>
+                <a:cs typeface="Calibri" pitchFamily="34" charset="-120"/>
+              </a:rPr>
+              <a:t>le pharaon, « image vivante » du dieu</a:t>
+            </a:r>
+            <a:endParaRPr lang="en-US" sz="1600" dirty="0"/>
+          </a:p>
+        </p:txBody>
+      </p:sp>
+      <p:sp>
+        <p:nvSpPr>
+          <p:cNvPr id="7" name="Text 4"/>
+          <p:cNvSpPr txBox="1"/>
+          <p:nvPr/>
+        </p:nvSpPr>
+        <p:spPr>
+          <a:xfrm>
+            <a:off x="3657600" y="5120640"/>
+            <a:ext cx="3474720" cy="685800"/>
+          </a:xfrm>
+          <a:prstGeom prst="rect">
+            <a:avLst/>
+          </a:prstGeom>
+          <a:noFill/>
+          <a:ln/>
+        </p:spPr>
+        <p:txBody>
+          <a:bodyPr wrap="square" lIns="0" tIns="0" rIns="0" bIns="0" rtlCol="0" anchor="t"/>
+          <a:lstStyle/>
+          <a:p>
+            <a:pPr algn="ctr" indent="0" marL="0">
+              <a:buNone/>
+            </a:pPr>
+            <a:r>
+              <a:rPr lang="en-US" sz="1600" b="1" dirty="0">
+                <a:solidFill>
                   <a:srgbClr val="E8742A"/>
                 </a:solidFill>
                 <a:latin typeface="Calibri" pitchFamily="34" charset="0"/>
                 <a:ea typeface="Calibri" pitchFamily="34" charset="-122"/>
                 <a:cs typeface="Calibri" pitchFamily="34" charset="-120"/>
               </a:rPr>
-              <a:t>L'image de César</a:t>
+              <a:t>Genèse 1.27 : tout être humain</a:t>
             </a:r>
             <a:endParaRPr lang="en-US" sz="1600" dirty="0"/>
           </a:p>
@@ -4018,69 +4074,13 @@
             <a:r>
               <a:rPr lang="en-US" sz="1600" dirty="0">
                 <a:solidFill>
-                  <a:srgbClr val="F4EDE4"/>
-                </a:solidFill>
-                <a:latin typeface="Calibri" pitchFamily="34" charset="0"/>
-                <a:ea typeface="Calibri" pitchFamily="34" charset="-122"/>
-                <a:cs typeface="Calibri" pitchFamily="34" charset="-120"/>
-              </a:rPr>
-              <a:t>frappée sur la pièce, rendue à César</a:t>
-            </a:r>
-            <a:endParaRPr lang="en-US" sz="1600" dirty="0"/>
-          </a:p>
-        </p:txBody>
-      </p:sp>
-      <p:sp>
-        <p:nvSpPr>
-          <p:cNvPr id="7" name="Text 4"/>
-          <p:cNvSpPr txBox="1"/>
-          <p:nvPr/>
-        </p:nvSpPr>
-        <p:spPr>
-          <a:xfrm>
-            <a:off x="3840480" y="5120640"/>
-            <a:ext cx="3108960" cy="685800"/>
-          </a:xfrm>
-          <a:prstGeom prst="rect">
-            <a:avLst/>
-          </a:prstGeom>
-          <a:noFill/>
-          <a:ln/>
-        </p:spPr>
-        <p:txBody>
-          <a:bodyPr wrap="square" lIns="0" tIns="0" rIns="0" bIns="0" rtlCol="0" anchor="t"/>
-          <a:lstStyle/>
-          <a:p>
-            <a:pPr algn="ctr" indent="0" marL="0">
-              <a:buNone/>
-            </a:pPr>
-            <a:r>
-              <a:rPr lang="en-US" sz="1600" b="1" dirty="0">
-                <a:solidFill>
-                  <a:srgbClr val="E8742A"/>
-                </a:solidFill>
-                <a:latin typeface="Calibri" pitchFamily="34" charset="0"/>
-                <a:ea typeface="Calibri" pitchFamily="34" charset="-122"/>
-                <a:cs typeface="Calibri" pitchFamily="34" charset="-120"/>
-              </a:rPr>
-              <a:t>L'image de Dieu</a:t>
-            </a:r>
-            <a:endParaRPr lang="en-US" sz="1600" dirty="0"/>
-          </a:p>
-          <a:p>
-            <a:pPr algn="ctr" indent="0" marL="0">
-              <a:buNone/>
-            </a:pPr>
-            <a:r>
-              <a:rPr lang="en-US" sz="1600" dirty="0">
-                <a:solidFill>
-                  <a:srgbClr val="F4EDE4"/>
-                </a:solidFill>
-                <a:latin typeface="Calibri" pitchFamily="34" charset="0"/>
-                <a:ea typeface="Calibri" pitchFamily="34" charset="-122"/>
-                <a:cs typeface="Calibri" pitchFamily="34" charset="-120"/>
-              </a:rPr>
-              <a:t>frappée sur une vie, rendue à Dieu</a:t>
+                  <a:srgbClr val="A89A8C"/>
+                </a:solidFill>
+                <a:latin typeface="Calibri" pitchFamily="34" charset="0"/>
+                <a:ea typeface="Calibri" pitchFamily="34" charset="-122"/>
+                <a:cs typeface="Calibri" pitchFamily="34" charset="-120"/>
+              </a:rPr>
+              <a:t>homme et femme, sans rang ni lignée</a:t>
             </a:r>
             <a:endParaRPr lang="en-US" sz="1600" dirty="0"/>
           </a:p>
@@ -4185,7 +4185,7 @@
                 <a:ea typeface="Calibri" pitchFamily="34" charset="-122"/>
                 <a:cs typeface="Calibri" pitchFamily="34" charset="-120"/>
               </a:rPr>
-              <a:t>eikôn</a:t>
+              <a:t>tselem</a:t>
             </a:r>
             <a:pPr indent="0" marL="0">
               <a:buNone/>

</xml_diff>

<commit_message>
Retire 2 Corinthiens 3.18 de la conclusion « À l'image de Christ-Jésus »
- Plan : plus de texte pour « Conclusion et appel » dans le tableau des
  étapes; ligne « Verset final » supprimée. PDF régénéré, listes des
  points I, II, IV et V désormais rendues en listes.
- Présentation : diapositive 10 titrée « Conclusion et appel », citation
  finale de 3.18 et mention « Verset final » des notes retirées.

Co-Authored-By: Claude Opus 5.5 <noreply@anthropic.com>
</commit_message>
<xml_diff>
--- a/Presentation-A-l-image-de-Christ.pptx
+++ b/Presentation-A-l-image-de-Christ.pptx
@@ -599,7 +599,7 @@
           <a:p>
             <a:r>
               <a:rPr lang="en-US" dirty="0"/>
-              <a:t>3 min. Récapitulation : créés à son image, ternis par le péché, restaurés en Christ, promis à sa ressemblance, transformés par l'Esprit, renouvelés au cœur, envoyés en son nom. Appel à l'incroyant, puis au croyant. Verset final : 2 Corinthiens 3.18.</a:t>
+              <a:t>3 min. Récapitulation : créés à son image, ternis par le péché, restaurés en Christ, promis à sa ressemblance, transformés par l'Esprit, renouvelés au cœur, envoyés en son nom. Appel à l'incroyant, puis au croyant.</a:t>
             </a:r>
             <a:endParaRPr lang="en-US" dirty="0"/>
           </a:p>
@@ -2020,7 +2020,7 @@
                 <a:ea typeface="Calibri" pitchFamily="34" charset="-122"/>
                 <a:cs typeface="Calibri" pitchFamily="34" charset="-120"/>
               </a:rPr>
-              <a:t>CONCLUSION · 2 CORINTHIENS 3.18</a:t>
+              <a:t>CONCLUSION ET APPEL</a:t>
             </a:r>
             <a:endParaRPr lang="en-US" sz="1300" dirty="0"/>
           </a:p>
@@ -2948,45 +2948,6 @@
                 <a:cs typeface="Calibri" pitchFamily="34" charset="-120"/>
               </a:rPr>
               <a:t>Dieu achèvera ce qu'il a résolu : nous serons semblables à lui (1 Jn 3.2). Contemplez Christ dans sa Parole. Et allez : faites des disciples.</a:t>
-            </a:r>
-            <a:endParaRPr lang="en-US" sz="1500" dirty="0"/>
-          </a:p>
-        </p:txBody>
-      </p:sp>
-      <p:sp>
-        <p:nvSpPr>
-          <p:cNvPr id="28" name="Text 26"/>
-          <p:cNvSpPr txBox="1"/>
-          <p:nvPr/>
-        </p:nvSpPr>
-        <p:spPr>
-          <a:xfrm>
-            <a:off x="548640" y="6053328"/>
-            <a:ext cx="11064240" cy="365760"/>
-          </a:xfrm>
-          <a:prstGeom prst="rect">
-            <a:avLst/>
-          </a:prstGeom>
-          <a:noFill/>
-          <a:ln/>
-        </p:spPr>
-        <p:txBody>
-          <a:bodyPr wrap="square" lIns="0" tIns="0" rIns="0" bIns="0" rtlCol="0" anchor="t"/>
-          <a:lstStyle/>
-          <a:p>
-            <a:pPr algn="ctr" indent="0" marL="0">
-              <a:buNone/>
-            </a:pPr>
-            <a:r>
-              <a:rPr lang="en-US" sz="1500" i="1" dirty="0">
-                <a:solidFill>
-                  <a:srgbClr val="A89A8C"/>
-                </a:solidFill>
-                <a:latin typeface="Calibri" pitchFamily="34" charset="0"/>
-                <a:ea typeface="Calibri" pitchFamily="34" charset="-122"/>
-                <a:cs typeface="Calibri" pitchFamily="34" charset="-120"/>
-              </a:rPr>
-              <a:t>« … nous sommes transformés en la même image, de gloire en gloire, par l'Esprit du Seigneur. »  2 Corinthiens 3.18</a:t>
             </a:r>
             <a:endParaRPr lang="en-US" sz="1500" dirty="0"/>
           </a:p>

</xml_diff>

<commit_message>
Harmonise la présentation « À l'image de Christ-Jésus » avec le plan
- Diapositive 6 : référence ramenée à Romains 8.29, comme le plan et la
  recherche.
- Notes des diapositives 4 à 9 : transitions du plan, Éphésiens 1.4,
  bara', Jacques 3.9, le terme de la transformation (47-21), la
  seigneurie de Christ et la promesse de Matthieu 28.20.
- Diapositive 10 : appel au croyant repris du plan; cartes d'appel
  alignées par le haut.

Co-Authored-By: Claude Opus 5.5 <noreply@anthropic.com>
</commit_message>
<xml_diff>
--- a/Presentation-A-l-image-de-Christ.pptx
+++ b/Presentation-A-l-image-de-Christ.pptx
@@ -863,7 +863,7 @@
           <a:p>
             <a:r>
               <a:rPr lang="en-US" dirty="0"/>
-              <a:t>8 min. A. « Faisons » : jusqu'au verset 24, Dieu commande; au verset 26, « jamais Dieu n'a parlé au pluriel » (90-218). Première indication claire de la Trinité (3.22; 11.7). Périchorèse : le mot nomme, il ne spécule pas. B. Tselem et demuth sont synonymes (90-218). Par la raison, l'homme est comme Dieu; moralement, il était comme Dieu. Centre : « la capacité de relations personnelles et, par-dessus tout, d'une relation personnelle avec Dieu » (90-218). C. Domination : roi de la terre (90-219; Ps 8.7-9). Homme et femme égaux en dignité, rôles distincts (Gn 2.18-23; 1 Tm 2.13); montrer le pluriel « qu'ils dominent » que la NEG79 efface. Application : la dignité repose sur l'acte créateur, non sur l'utilité. Transition : Gn 5.3; l'image demeure (Gn 9.6), la ressemblance morale est perdue.</a:t>
+              <a:t>8 min. A. « Faisons » : jusqu'au verset 24, Dieu commande; au verset 26, « jamais Dieu n'a parlé au pluriel » (90-218). Première indication claire de la Trinité (3.22; 11.7). Périchorèse (Jn 14.10-11; 17.21) : le mot nomme, il ne spécule pas. Ce conseil exécute un dessein arrêté avant la fondation du monde (Ép 1.4) : pierre d'attente du point III. B. Tselem et demuth sont synonymes (90-218). Par la raison, l'homme est comme Dieu; moralement, il était comme Dieu. Centre : « la capacité de relations personnelles et, par-dessus tout, d'une relation personnelle avec Dieu » (90-218) : pierre d'attente du point V. Bara' trois fois au verset 27 : Dieu seul crée, et l'homme est le seul être vivant fait sur le modèle divin (90-219). C. Domination : roi de la terre, chargé de la cultiver et de la garder (90-219; Ps 8.7-9). Homme et femme égaux en dignité, rôles distincts (Gn 2.18-23; 1 Tm 2.13); montrer le pluriel « qu'ils dominent » que la NEG79 efface. Application : la dignité repose sur l'acte créateur, non sur l'utilité. Transition, l'image ternie : Adam déchu engendre « à sa ressemblance » (Gn 5.3); l'image demeure (Gn 9.6; Jc 3.9), mais la ressemblance morale est perdue et l'homme ne peut la restaurer. Où voir encore l'image telle que Dieu l'a voulue?</a:t>
             </a:r>
             <a:endParaRPr lang="en-US" dirty="0"/>
           </a:p>
@@ -951,7 +951,7 @@
           <a:p>
             <a:r>
               <a:rPr lang="en-US" dirty="0"/>
-              <a:t>6 min. La Septante rend l'image de Gn 1.27 par eikôn, le mot que Paul applique à Christ (aussi 2 Co 4.4). Mais en un autre sens : l'homme porte l'image comme créature; Christ est, de toute éternité, la ressemblance parfaite de Dieu, une reproduction exacte, sans rien de manquant ni d'altéré (2135; Hé 1.3; Ph 2.6; Jn 14.9). Premier-né : le rang d'héritier, non la naissance (Ex 4.22; Jr 31.9, Éphraïm avant Manassé). Il a créé toutes choses (1.16). Application : qui veut connaître Dieu le voit en Christ.</a:t>
+              <a:t>6 min. La Septante rend l'image de Gn 1.27 par eikôn, le mot que Paul applique à Christ (aussi 2 Co 4.4). Mais en un autre sens : l'homme porte l'image comme créature; Christ est, de toute éternité, la ressemblance parfaite de Dieu, une reproduction exacte, sans rien de manquant ni d'altéré (2135; Hé 1.3; Ph 2.6; Jn 14.9). Premier-né : le rang d'héritier, non la naissance (Ex 4.22; Jr 31.9, Éphraïm avant Manassé). Il a créé toutes choses (1.16). Application : qui veut savoir ce qu'est l'homme tel que Dieu l'a voulu regarde Christ; qui veut connaître Dieu le voit en Christ, sans intermédiaire. Transition : si Christ est l'image parfaite, que Dieu fait-il de ceux qu'il sauve?</a:t>
             </a:r>
             <a:endParaRPr lang="en-US" dirty="0"/>
           </a:p>
@@ -1039,7 +1039,7 @@
           <a:p>
             <a:r>
               <a:rPr lang="en-US" dirty="0"/>
-              <a:t>5 min. « Connus d'avance » : non une simple prévision de qui croirait, mais le choix d'aimer, l'élection (Ac 2.23; 1 P 1.2, 20). Le même conseil éternel que le « Faisons ». « Le but de votre salut était que vous soyez rendus semblables à l'image de son Fils » (90-180). Premier-né de beaucoup de frères : la fin dernière est la gloire du Fils. Application : ce que Dieu a décrété, il l'achèvera (8.30); les épreuves de 8.28 servent ce but.</a:t>
+              <a:t>5 min. « Connus d'avance » : non une simple prévision de qui croirait, mais le choix d'aimer, l'élection (Ac 2.23; 1 P 1.2, 20). Le même conseil éternel que le « Faisons ». « Le but de votre salut était que vous soyez rendus semblables à l'image de son Fils » (90-180). Premier-né de beaucoup de frères : la fin dernière est la gloire du Fils. Application : ce que Dieu a décrété, il l'achèvera (8.30); les épreuves de 8.28 servent ce but. Transition : nous ne voyons pas encore cette ressemblance achevée. Comment Dieu nous y conduit-il, aujourd'hui?</a:t>
             </a:r>
             <a:endParaRPr lang="en-US" dirty="0"/>
           </a:p>
@@ -1127,7 +1127,7 @@
           <a:p>
             <a:r>
               <a:rPr lang="en-US" dirty="0"/>
-              <a:t>6 min. A. Moïse voilait son visage (Ex 34.29-35); en Christ, le voile est ôté. « Nous tous » : tous les croyants (47-22). B. La NEG79 dit « reflète »; le grec, avec la S21, la LSG, Darby et la KJF, dit contempler comme dans un miroir. Le miroir, c'est l'Écriture, où la gloire de Dieu se voit sur la face de Jésus-Christ (90-75; 4.6). Relier au Rappel. C. Metamorphoô, présent passif : « une action de transformation continue et progressive » (47-21). « C'est là toute la sanctification progressive » (90-75). Application : celui qui délaisse l'Écriture se prive du miroir.</a:t>
+              <a:t>6 min. A. Moïse voilait son visage (Ex 34.29-35); en Christ, le voile est ôté. « Nous tous » : tous les croyants (47-22). B. La NEG79 dit « reflète »; le grec, avec la S21, la LSG, Darby et la KJF, dit contempler comme dans un miroir. Le miroir, c'est l'Écriture, où la gloire de Dieu se voit sur la face de Jésus-Christ (90-75; 4.6). Relier au Rappel. C. Metamorphoô, présent passif : « une action de transformation continue et progressive » (47-21). « C'est là toute la sanctification progressive » (90-75). Le terme : « Le dessein salvateur de Dieu était de créer une humanité rachetée qui serait semblable à son Fils » (47-21). Application : contempler Christ dans sa Parole, et l'Esprit fait l'œuvre; celui qui délaisse l'Écriture se prive du miroir. Transition : à quoi reconnaît-on cette image qui grandit? À ce que Dieu avait mis au centre : le cœur qui aime.</a:t>
             </a:r>
             <a:endParaRPr lang="en-US" dirty="0"/>
           </a:p>
@@ -1215,7 +1215,7 @@
           <a:p>
             <a:r>
               <a:rPr lang="en-US" dirty="0"/>
-              <a:t>7 min. A. Le piège des 613 commandements; Jésus répond par le Shema (Dt 6.5) et Lv 19.18 (2358). « Quand vous aimez Dieu comme il faut, vous aimez les gens comme il faut » (2358). B. « Parce que nous n'avons pas aimé ainsi, nous avons besoin du pardon, et parce que nous ne pouvons pas aimer ainsi, nous avons besoin d'une capacité nouvelle » (2358). C. Lire Jérémie 31.33 (NBS). La nouvelle alliance : « le pardon de tous nos péchés et l'écriture de la loi de Dieu sur nos cœurs » (80-286). Le cœur (1 Ch 28.9) : rationnel, moral, relationnel. Application : nous l'aimons parce qu'il nous a aimés le premier (1 Jn 4.19), et cet amour se prouve par l'obéissance (Jn 14.15).</a:t>
+              <a:t>7 min. A. Le piège des 613 commandements; Jésus répond par le Shema (Dt 6.5) et Lv 19.18 (2358). « Quand vous aimez Dieu comme il faut, vous aimez les gens comme il faut » (2358). B. « Parce que nous n'avons pas aimé ainsi, nous avons besoin du pardon, et parce que nous ne pouvons pas aimer ainsi, nous avons besoin d'une capacité nouvelle » (2358). C. Lire Jérémie 31.33 (NBS). La nouvelle alliance : « le pardon de tous nos péchés et l'écriture de la loi de Dieu sur nos cœurs » (80-286). Le cœur (1 Ch 28.9) : rationnel, moral, relationnel. Application : nous l'aimons parce qu'il nous a aimés le premier (1 Jn 4.19), et cet amour se prouve par l'obéissance (Jn 14.15). Transition : et le prochain que nous aimons, que lui devons-nous d'abord?</a:t>
             </a:r>
             <a:endParaRPr lang="en-US" dirty="0"/>
           </a:p>
@@ -1303,7 +1303,7 @@
           <a:p>
             <a:r>
               <a:rPr lang="en-US" dirty="0"/>
-              <a:t>5 min. Un seul impératif : « faites des disciples »; aller, baptiser, enseigner en décrivent le chemin (2405). Le disciple : « un croyant qui apprend »; « on ne peut être disciple de Christ sans un cœur obéissant » (2405). « Au nom » : « un seul nom et trois personnes » (2405); le Dieu du « Faisons ». Le baptême, signe extérieur d'une foi déjà reçue. « Tout ce que je vous ai prescrit » inclut le grand commandement. Application : aimer son prochain, c'est d'abord lui annoncer Christ.</a:t>
+              <a:t>5 min. Un seul impératif : « faites des disciples »; aller, baptiser, enseigner en décrivent le chemin (2405). Le disciple : « un croyant qui apprend »; « on ne peut être disciple de Christ sans un cœur obéissant » (2405); la foi salvatrice se soumet à Christ comme Seigneur. « Au nom » : « un seul nom et trois personnes » (2405); le Dieu du « Faisons ». Le baptême, signe extérieur d'une foi déjà reçue. « Tout ce que je vous ai prescrit » inclut le grand commandement : faire des disciples, c'est former d'autres porteurs de l'image restaurée. « Je suis avec vous tous les jours » : jusqu'à son retour (2405). Application : aimer son prochain, c'est d'abord lui annoncer Christ.</a:t>
             </a:r>
             <a:endParaRPr lang="en-US" dirty="0"/>
           </a:p>
@@ -2796,11 +2796,11 @@
         <p:spPr>
           <a:xfrm>
             <a:off x="548640" y="4526280"/>
-            <a:ext cx="5422392" cy="1371600"/>
+            <a:ext cx="5422392" cy="1600200"/>
           </a:xfrm>
           <a:prstGeom prst="roundRect">
             <a:avLst>
-              <a:gd name="adj" fmla="val 8000"/>
+              <a:gd name="adj" fmla="val 6857"/>
             </a:avLst>
           </a:prstGeom>
           <a:solidFill>
@@ -2822,17 +2822,17 @@
         </p:nvSpPr>
         <p:spPr>
           <a:xfrm>
-            <a:off x="777240" y="4617720"/>
-            <a:ext cx="4983480" cy="1234440"/>
-          </a:xfrm>
-          <a:prstGeom prst="rect">
-            <a:avLst/>
-          </a:prstGeom>
-          <a:noFill/>
-          <a:ln/>
-        </p:spPr>
-        <p:txBody>
-          <a:bodyPr wrap="square" lIns="0" tIns="0" rIns="0" bIns="0" rtlCol="0" anchor="ctr"/>
+            <a:off x="777240" y="4663440"/>
+            <a:ext cx="4983480" cy="1371600"/>
+          </a:xfrm>
+          <a:prstGeom prst="rect">
+            <a:avLst/>
+          </a:prstGeom>
+          <a:noFill/>
+          <a:ln/>
+        </p:spPr>
+        <p:txBody>
+          <a:bodyPr wrap="square" lIns="0" tIns="0" rIns="0" bIns="0" rtlCol="0" anchor="t"/>
           <a:lstStyle/>
           <a:p>
             <a:pPr indent="0" marL="0">
@@ -2879,11 +2879,11 @@
         <p:spPr>
           <a:xfrm>
             <a:off x="6217920" y="4526280"/>
-            <a:ext cx="5422392" cy="1371600"/>
+            <a:ext cx="5422392" cy="1600200"/>
           </a:xfrm>
           <a:prstGeom prst="roundRect">
             <a:avLst>
-              <a:gd name="adj" fmla="val 8000"/>
+              <a:gd name="adj" fmla="val 6857"/>
             </a:avLst>
           </a:prstGeom>
           <a:solidFill>
@@ -2905,17 +2905,17 @@
         </p:nvSpPr>
         <p:spPr>
           <a:xfrm>
-            <a:off x="6446520" y="4617720"/>
-            <a:ext cx="4983480" cy="1234440"/>
-          </a:xfrm>
-          <a:prstGeom prst="rect">
-            <a:avLst/>
-          </a:prstGeom>
-          <a:noFill/>
-          <a:ln/>
-        </p:spPr>
-        <p:txBody>
-          <a:bodyPr wrap="square" lIns="0" tIns="0" rIns="0" bIns="0" rtlCol="0" anchor="ctr"/>
+            <a:off x="6446520" y="4663440"/>
+            <a:ext cx="4983480" cy="1371600"/>
+          </a:xfrm>
+          <a:prstGeom prst="rect">
+            <a:avLst/>
+          </a:prstGeom>
+          <a:noFill/>
+          <a:ln/>
+        </p:spPr>
+        <p:txBody>
+          <a:bodyPr wrap="square" lIns="0" tIns="0" rIns="0" bIns="0" rtlCol="0" anchor="t"/>
           <a:lstStyle/>
           <a:p>
             <a:pPr indent="0" marL="0">
@@ -2947,7 +2947,7 @@
                 <a:ea typeface="Calibri" pitchFamily="34" charset="-122"/>
                 <a:cs typeface="Calibri" pitchFamily="34" charset="-120"/>
               </a:rPr>
-              <a:t>Dieu achèvera ce qu'il a résolu : nous serons semblables à lui (1 Jn 3.2). Contemplez Christ dans sa Parole. Et allez : faites des disciples.</a:t>
+              <a:t>Dieu achèvera ce qu'il a décidé avant la fondation du monde : nous serons semblables à lui (1 Jn 3.2). Contemplez Christ dans sa Parole; ainsi l'Esprit vous transforme. Et allez : faites des disciples.</a:t>
             </a:r>
             <a:endParaRPr lang="en-US" sz="1500" dirty="0"/>
           </a:p>
@@ -7112,7 +7112,7 @@
                 <a:ea typeface="Calibri" pitchFamily="34" charset="-122"/>
                 <a:cs typeface="Calibri" pitchFamily="34" charset="-120"/>
               </a:rPr>
-              <a:t>III · ROMAINS 8.29-30</a:t>
+              <a:t>III · ROMAINS 8.29</a:t>
             </a:r>
             <a:endParaRPr lang="en-US" sz="1300" dirty="0"/>
           </a:p>

</xml_diff>

<commit_message>
Retire 2 Corinthiens 3.18 de la frise de conclusion
Diapositive 10 : le nœud « Transformés » de la frise récapitulative
n'affiche plus de référence; les autres nœuds sont inchangés.

Co-Authored-By: Claude Opus 5.5 <noreply@anthropic.com>
</commit_message>
<xml_diff>
--- a/Presentation-A-l-image-de-Christ.pptx
+++ b/Presentation-A-l-image-de-Christ.pptx
@@ -2606,23 +2606,6 @@
             </a:r>
             <a:endParaRPr lang="en-US" sz="1600" dirty="0"/>
           </a:p>
-          <a:p>
-            <a:pPr algn="ctr" indent="0" marL="0">
-              <a:buNone/>
-            </a:pPr>
-            <a:r>
-              <a:rPr lang="en-US" sz="1300" dirty="0">
-                <a:solidFill>
-                  <a:srgbClr val="A89A8C"/>
-                </a:solidFill>
-                <a:latin typeface="Calibri" pitchFamily="34" charset="0"/>
-                <a:ea typeface="Calibri" pitchFamily="34" charset="-122"/>
-                <a:cs typeface="Calibri" pitchFamily="34" charset="-120"/>
-              </a:rPr>
-              <a:t>2 Co 3.18</a:t>
-            </a:r>
-            <a:endParaRPr lang="en-US" sz="1600" dirty="0"/>
-          </a:p>
         </p:txBody>
       </p:sp>
       <p:sp>

</xml_diff>

<commit_message>
Ajoute « (Kénose - Philippiens 2) » à la diapositive 5
Sur la ligne de la phrase clé « Christ est ce que l'homme n'est plus. »,
en gris pour se lire comme une annotation.

Co-Authored-By: Claude Opus 5.5 <noreply@anthropic.com>
</commit_message>
<xml_diff>
--- a/Presentation-A-l-image-de-Christ.pptx
+++ b/Presentation-A-l-image-de-Christ.pptx
@@ -6227,7 +6227,21 @@
                 <a:ea typeface="Calibri" pitchFamily="34" charset="-122"/>
                 <a:cs typeface="Calibri" pitchFamily="34" charset="-120"/>
               </a:rPr>
-              <a:t>Christ est ce que l'homme n'est plus.</a:t>
+              <a:t>Christ est ce que l'homme n'est plus. </a:t>
+            </a:r>
+            <a:pPr indent="0" marL="0">
+              <a:buNone/>
+            </a:pPr>
+            <a:r>
+              <a:rPr lang="en-US" sz="1900" i="1" dirty="0">
+                <a:solidFill>
+                  <a:srgbClr val="A89A8C"/>
+                </a:solidFill>
+                <a:latin typeface="Calibri" pitchFamily="34" charset="0"/>
+                <a:ea typeface="Calibri" pitchFamily="34" charset="-122"/>
+                <a:cs typeface="Calibri" pitchFamily="34" charset="-120"/>
+              </a:rPr>
+              <a:t>(Kénose - Philippiens 2)</a:t>
             </a:r>
             <a:endParaRPr lang="en-US" sz="1900" dirty="0"/>
           </a:p>

</xml_diff>

<commit_message>
Ajoute la kénose aux notes de la diapositive 5
Philippiens 2.6-7 : dépouillé de sa gloire céleste et de l'usage
volontaire de ses prérogatives, jamais de sa divinité (50-16), dans les
termes du plan.

Co-Authored-By: Claude Opus 5.5 <noreply@anthropic.com>
</commit_message>
<xml_diff>
--- a/Presentation-A-l-image-de-Christ.pptx
+++ b/Presentation-A-l-image-de-Christ.pptx
@@ -4,9 +4,6 @@
   <p:sldMasterIdLst>
     <p:sldMasterId id="2147483648" r:id="rId1"/>
   </p:sldMasterIdLst>
-  <p:notesMasterIdLst>
-    <p:notesMasterId r:id="rId12"/>
-  </p:notesMasterIdLst>
   <p:sldIdLst>
     <p:sldId id="256" r:id="rId2"/>
     <p:sldId id="257" r:id="rId3"/>
@@ -19,6 +16,9 @@
     <p:sldId id="264" r:id="rId10"/>
     <p:sldId id="265" r:id="rId11"/>
   </p:sldIdLst>
+  <p:notesMasterIdLst>
+    <p:notesMasterId r:id="rId12"/>
+  </p:notesMasterIdLst>
   <p:sldSz cx="12192000" cy="6858000"/>
   <p:notesSz cx="6858000" cy="12192000"/>
   <p:defaultTextStyle>
@@ -113,72 +113,7 @@
       </a:defRPr>
     </a:lvl9pPr>
   </p:defaultTextStyle>
-  <p:extLst>
-    <p:ext uri="{EFAFB233-063F-42B5-8137-9DF3F51BA10A}">
-      <p15:sldGuideLst xmlns:p15="http://schemas.microsoft.com/office/powerpoint/2012/main"/>
-    </p:ext>
-  </p:extLst>
 </p:presentation>
-</file>
-
-<file path=ppt/revisionInfo.xml><?xml version="1.0" encoding="utf-8"?>
-<p1510:revInfo xmlns:a="http://schemas.openxmlformats.org/drawingml/2006/main" xmlns:r="http://schemas.openxmlformats.org/officeDocument/2006/relationships" xmlns:p1510="http://schemas.microsoft.com/office/powerpoint/2015/10/main">
-  <p1510:revLst>
-    <p1510:client id="{E0A287C0-9FC5-4D7A-B26A-5C34583FEB53}" v="1" dt="2026-09-28T10:12:22.879"/>
-  </p1510:revLst>
-</p1510:revInfo>
-</file>
-
-<file path=ppt/changesInfos/changesInfo1.xml><?xml version="1.0" encoding="utf-8"?>
-<pc:chgInfo xmlns:a="http://schemas.openxmlformats.org/drawingml/2006/main" xmlns:r="http://schemas.openxmlformats.org/officeDocument/2006/relationships" xmlns:ac="http://schemas.microsoft.com/office/drawing/2013/main/command" xmlns:pc="http://schemas.microsoft.com/office/powerpoint/2013/main/command">
-  <pc:docChgLst>
-    <pc:chgData name="André-Guy Bruneau" userId="c9f3b82d5570fc32" providerId="LiveId" clId="{C4496A7D-9A64-4B82-9835-F710A7718518}"/>
-    <pc:docChg chg="custSel modSld">
-      <pc:chgData name="André-Guy Bruneau" userId="c9f3b82d5570fc32" providerId="LiveId" clId="{C4496A7D-9A64-4B82-9835-F710A7718518}" dt="2026-09-28T16:32:26.014" v="4"/>
-      <pc:docMkLst>
-        <pc:docMk/>
-      </pc:docMkLst>
-      <pc:sldChg chg="modSp mod">
-        <pc:chgData name="André-Guy Bruneau" userId="c9f3b82d5570fc32" providerId="LiveId" clId="{C4496A7D-9A64-4B82-9835-F710A7718518}" dt="2026-09-28T16:32:26" v="3"/>
-        <pc:sldMkLst>
-          <pc:docMk/>
-          <pc:sldMk cId="0" sldId="258"/>
-        </pc:sldMkLst>
-        <pc:spChg chg="mod">
-          <ac:chgData name="André-Guy Bruneau" userId="c9f3b82d5570fc32" providerId="LiveId" clId="{C4496A7D-9A64-4B82-9835-F710A7718518}" dt="2026-09-28T16:32:26" v="1"/>
-          <ac:spMkLst>
-            <pc:docMk/>
-            <pc:sldMk cId="0" sldId="258"/>
-            <ac:spMk id="6" creationId="{00000000-0000-0000-0000-000000000000}"/>
-          </ac:spMkLst>
-        </pc:spChg>
-        <pc:spChg chg="mod">
-          <ac:chgData name="André-Guy Bruneau" userId="c9f3b82d5570fc32" providerId="LiveId" clId="{C4496A7D-9A64-4B82-9835-F710A7718518}" dt="2026-09-28T16:32:26" v="3"/>
-          <ac:spMkLst>
-            <pc:docMk/>
-            <pc:sldMk cId="0" sldId="258"/>
-            <ac:spMk id="7" creationId="{00000000-0000-0000-0000-000000000000}"/>
-          </ac:spMkLst>
-        </pc:spChg>
-      </pc:sldChg>
-      <pc:sldChg chg="modSp mod">
-        <pc:chgData name="André-Guy Bruneau" userId="c9f3b82d5570fc32" providerId="LiveId" clId="{C4496A7D-9A64-4B82-9835-F710A7718518}" dt="2026-09-28T16:32:26.014" v="4"/>
-        <pc:sldMkLst>
-          <pc:docMk/>
-          <pc:sldMk cId="0" sldId="259"/>
-        </pc:sldMkLst>
-        <pc:spChg chg="mod">
-          <ac:chgData name="André-Guy Bruneau" userId="c9f3b82d5570fc32" providerId="LiveId" clId="{C4496A7D-9A64-4B82-9835-F710A7718518}" dt="2026-09-28T16:32:26.014" v="4"/>
-          <ac:spMkLst>
-            <pc:docMk/>
-            <pc:sldMk cId="0" sldId="259"/>
-            <ac:spMk id="12" creationId="{00000000-0000-0000-0000-000000000000}"/>
-          </ac:spMkLst>
-        </pc:spChg>
-      </pc:sldChg>
-    </pc:docChg>
-  </pc:docChgLst>
-</pc:chgInfo>
 </file>
 
 <file path=ppt/notesMasters/notesMaster1.xml><?xml version="1.0" encoding="utf-8"?>
@@ -203,10 +138,234 @@
           <a:chExt cx="0" cy="0"/>
         </a:xfrm>
       </p:grpSpPr>
+      <p:sp>
+        <p:nvSpPr>
+          <p:cNvPr id="2" name="Header Placeholder 1"/>
+          <p:cNvSpPr>
+            <a:spLocks noGrp="1"/>
+          </p:cNvSpPr>
+          <p:nvPr>
+            <p:ph type="hdr" sz="quarter"/>
+          </p:nvPr>
+        </p:nvSpPr>
+        <p:spPr>
+          <a:xfrm>
+            <a:off x="0" y="0"/>
+            <a:ext cx="2971800" cy="458788"/>
+          </a:xfrm>
+          <a:prstGeom prst="rect">
+            <a:avLst/>
+          </a:prstGeom>
+        </p:spPr>
+        <p:txBody>
+          <a:bodyPr vert="horz" lIns="91440" tIns="45720" rIns="91440" bIns="45720" rtlCol="0"/>
+          <a:lstStyle>
+            <a:lvl1pPr algn="l">
+              <a:defRPr sz="1200"/>
+            </a:lvl1pPr>
+          </a:lstStyle>
+          <a:p>
+            <a:endParaRPr lang="en-US"/>
+          </a:p>
+        </p:txBody>
+      </p:sp>
+      <p:sp>
+        <p:nvSpPr>
+          <p:cNvPr id="3" name="Date Placeholder 2"/>
+          <p:cNvSpPr>
+            <a:spLocks noGrp="1"/>
+          </p:cNvSpPr>
+          <p:nvPr>
+            <p:ph type="dt" idx="1"/>
+          </p:nvPr>
+        </p:nvSpPr>
+        <p:spPr>
+          <a:xfrm>
+            <a:off x="3884613" y="0"/>
+            <a:ext cx="2971800" cy="458788"/>
+          </a:xfrm>
+          <a:prstGeom prst="rect">
+            <a:avLst/>
+          </a:prstGeom>
+        </p:spPr>
+        <p:txBody>
+          <a:bodyPr vert="horz" lIns="91440" tIns="45720" rIns="91440" bIns="45720" rtlCol="0"/>
+          <a:lstStyle>
+            <a:lvl1pPr algn="r">
+              <a:defRPr sz="1200"/>
+            </a:lvl1pPr>
+          </a:lstStyle>
+          <a:p>
+            <a:fld id="{5282F153-3F37-0F45-9E97-73ACFA13230C}" type="datetimeFigureOut">
+              <a:rPr lang="en-US"/>
+              <a:t>7/23/19</a:t>
+            </a:fld>
+            <a:endParaRPr lang="en-US"/>
+          </a:p>
+        </p:txBody>
+      </p:sp>
+      <p:sp>
+        <p:nvSpPr>
+          <p:cNvPr id="4" name="Slide Image Placeholder 3"/>
+          <p:cNvSpPr>
+            <a:spLocks noGrp="1" noRot="1" noChangeAspect="1"/>
+          </p:cNvSpPr>
+          <p:nvPr>
+            <p:ph type="sldImg" idx="2"/>
+          </p:nvPr>
+        </p:nvSpPr>
+        <p:spPr>
+          <a:xfrm>
+            <a:off x="685800" y="1143000"/>
+            <a:ext cx="5486400" cy="3086100"/>
+          </a:xfrm>
+          <a:prstGeom prst="rect">
+            <a:avLst/>
+          </a:prstGeom>
+          <a:noFill/>
+          <a:ln w="12700">
+            <a:solidFill>
+              <a:prstClr val="black"/>
+            </a:solidFill>
+          </a:ln>
+        </p:spPr>
+        <p:txBody>
+          <a:bodyPr vert="horz" lIns="91440" tIns="45720" rIns="91440" bIns="45720" rtlCol="0" anchor="ctr"/>
+          <a:lstStyle/>
+          <a:p>
+            <a:endParaRPr lang="en-US"/>
+          </a:p>
+        </p:txBody>
+      </p:sp>
+      <p:sp>
+        <p:nvSpPr>
+          <p:cNvPr id="5" name="Notes Placeholder 4"/>
+          <p:cNvSpPr>
+            <a:spLocks noGrp="1"/>
+          </p:cNvSpPr>
+          <p:nvPr>
+            <p:ph type="body" sz="quarter" idx="3"/>
+          </p:nvPr>
+        </p:nvSpPr>
+        <p:spPr>
+          <a:xfrm>
+            <a:off x="685800" y="4400550"/>
+            <a:ext cx="5486400" cy="3600450"/>
+          </a:xfrm>
+          <a:prstGeom prst="rect">
+            <a:avLst/>
+          </a:prstGeom>
+        </p:spPr>
+        <p:txBody>
+          <a:bodyPr vert="horz" lIns="91440" tIns="45720" rIns="91440" bIns="45720" rtlCol="0"/>
+          <a:lstStyle/>
+          <a:p>
+            <a:pPr lvl="0"/>
+            <a:r>
+              <a:rPr lang="en-US"/>
+              <a:t>Click to edit Master text styles</a:t>
+            </a:r>
+          </a:p>
+          <a:p>
+            <a:pPr lvl="1"/>
+            <a:r>
+              <a:rPr lang="en-US"/>
+              <a:t>Second level</a:t>
+            </a:r>
+          </a:p>
+          <a:p>
+            <a:pPr lvl="2"/>
+            <a:r>
+              <a:rPr lang="en-US"/>
+              <a:t>Third level</a:t>
+            </a:r>
+          </a:p>
+          <a:p>
+            <a:pPr lvl="3"/>
+            <a:r>
+              <a:rPr lang="en-US"/>
+              <a:t>Fourth level</a:t>
+            </a:r>
+          </a:p>
+          <a:p>
+            <a:pPr lvl="4"/>
+            <a:r>
+              <a:rPr lang="en-US"/>
+              <a:t>Fifth level</a:t>
+            </a:r>
+          </a:p>
+        </p:txBody>
+      </p:sp>
+      <p:sp>
+        <p:nvSpPr>
+          <p:cNvPr id="6" name="Footer Placeholder 5"/>
+          <p:cNvSpPr>
+            <a:spLocks noGrp="1"/>
+          </p:cNvSpPr>
+          <p:nvPr>
+            <p:ph type="ftr" sz="quarter" idx="4"/>
+          </p:nvPr>
+        </p:nvSpPr>
+        <p:spPr>
+          <a:xfrm>
+            <a:off x="0" y="8685213"/>
+            <a:ext cx="2971800" cy="458787"/>
+          </a:xfrm>
+          <a:prstGeom prst="rect">
+            <a:avLst/>
+          </a:prstGeom>
+        </p:spPr>
+        <p:txBody>
+          <a:bodyPr vert="horz" lIns="91440" tIns="45720" rIns="91440" bIns="45720" rtlCol="0" anchor="b"/>
+          <a:lstStyle>
+            <a:lvl1pPr algn="l">
+              <a:defRPr sz="1200"/>
+            </a:lvl1pPr>
+          </a:lstStyle>
+          <a:p>
+            <a:endParaRPr lang="en-US"/>
+          </a:p>
+        </p:txBody>
+      </p:sp>
+      <p:sp>
+        <p:nvSpPr>
+          <p:cNvPr id="7" name="Slide Number Placeholder 6"/>
+          <p:cNvSpPr>
+            <a:spLocks noGrp="1"/>
+          </p:cNvSpPr>
+          <p:nvPr>
+            <p:ph type="sldNum" sz="quarter" idx="5"/>
+          </p:nvPr>
+        </p:nvSpPr>
+        <p:spPr>
+          <a:xfrm>
+            <a:off x="3884613" y="8685213"/>
+            <a:ext cx="2971800" cy="458787"/>
+          </a:xfrm>
+          <a:prstGeom prst="rect">
+            <a:avLst/>
+          </a:prstGeom>
+        </p:spPr>
+        <p:txBody>
+          <a:bodyPr vert="horz" lIns="91440" tIns="45720" rIns="91440" bIns="45720" rtlCol="0" anchor="b"/>
+          <a:lstStyle>
+            <a:lvl1pPr algn="r">
+              <a:defRPr sz="1200"/>
+            </a:lvl1pPr>
+          </a:lstStyle>
+          <a:p>
+            <a:fld id="{CE5E9CC1-C706-0F49-92D6-E571CC5EEA8F}" type="slidenum">
+              <a:rPr lang="en-US"/>
+              <a:t>‹#›</a:t>
+            </a:fld>
+            <a:endParaRPr lang="en-US"/>
+          </a:p>
+        </p:txBody>
+      </p:sp>
     </p:spTree>
     <p:extLst>
       <p:ext uri="{BB962C8B-B14F-4D97-AF65-F5344CB8AC3E}">
-        <p14:creationId xmlns:p14="http://schemas.microsoft.com/office/powerpoint/2010/main" val="1531706130"/>
+        <p14:creationId xmlns:p14="http://schemas.microsoft.com/office/powerpoint/2010/main" val="1024086991"/>
       </p:ext>
     </p:extLst>
   </p:cSld>
@@ -354,6 +513,7 @@
               <a:rPr lang="en-US" dirty="0"/>
               <a:t>Lecture publique : Genèse 1.26-28 et Romains 8.28-30. Durée visée : 45 minutes.</a:t>
             </a:r>
+            <a:endParaRPr lang="en-US" dirty="0"/>
           </a:p>
         </p:txBody>
       </p:sp>
@@ -441,6 +601,7 @@
               <a:rPr lang="en-US" dirty="0"/>
               <a:t>3 min. Récapitulation : créés à son image, ternis par le péché, restaurés en Christ, promis à sa ressemblance, transformés par l'Esprit, renouvelés au cœur, envoyés en son nom. Appel à l'incroyant, puis au croyant.</a:t>
             </a:r>
+            <a:endParaRPr lang="en-US" dirty="0"/>
           </a:p>
         </p:txBody>
       </p:sp>
@@ -528,6 +689,7 @@
               <a:rPr lang="en-US" dirty="0"/>
               <a:t>2 min. Lire 2 Timothée 3.16-17. Theopneustos : « soufflée par Dieu ». « Ce que l'Écriture dit, Dieu le dit » (55-17). Enseigner, convaincre, corriger, instruire dans la justice (55-19). Pierre d'attente : au point IV, l'Écriture est le miroir.</a:t>
             </a:r>
+            <a:endParaRPr lang="en-US" dirty="0"/>
           </a:p>
         </p:txBody>
       </p:sp>
@@ -615,6 +777,7 @@
               <a:rPr lang="en-US" dirty="0"/>
               <a:t>3 min. Dans l'Antiquité, l'« image » d'un dieu, c'était le roi : Toutânkhamon signifie « image vivante d'Amon »; en Mésopotamie, le roi dressait son effigie aux confins de ses territoires. Genèse 1.27 accorde ce titre à l'être humain comme tel, homme et femme, sans rang ni lignée. Tselem désigne ailleurs les statues cultuelles. Question : vous aussi, vous portez une image. Laquelle? Qu'est-il arrivé à cette image, et que Dieu en fait-il?</a:t>
             </a:r>
+            <a:endParaRPr lang="en-US" dirty="0"/>
           </a:p>
         </p:txBody>
       </p:sp>
@@ -702,6 +865,7 @@
               <a:rPr lang="en-US" dirty="0"/>
               <a:t>8 min. A. « Faisons » : jusqu'au verset 24, Dieu commande; au verset 26, « jamais Dieu n'a parlé au pluriel » (90-218). Première indication claire de la Trinité (3.22; 11.7). Périchorèse (Jn 14.10-11; 17.21) : le mot nomme, il ne spécule pas. Ce conseil exécute un dessein arrêté avant la fondation du monde (Ép 1.4) : pierre d'attente du point III. B. Tselem et demuth sont synonymes (90-218). Par la raison, l'homme est comme Dieu; moralement, il était comme Dieu. Centre : « la capacité de relations personnelles et, par-dessus tout, d'une relation personnelle avec Dieu » (90-218) : pierre d'attente du point V. Bara' trois fois au verset 27 : Dieu seul crée, et l'homme est le seul être vivant fait sur le modèle divin (90-219). C. Domination : roi de la terre, chargé de la cultiver et de la garder (90-219; Ps 8.7-9). Homme et femme égaux en dignité, rôles distincts (Gn 2.18-23; 1 Tm 2.13); montrer le pluriel « qu'ils dominent » que la NEG79 efface. Application : la dignité repose sur l'acte créateur, non sur l'utilité. Transition, l'image ternie : Adam déchu engendre « à sa ressemblance » (Gn 5.3); l'image demeure (Gn 9.6; Jc 3.9), mais la ressemblance morale est perdue et l'homme ne peut la restaurer. Où voir encore l'image telle que Dieu l'a voulue?</a:t>
             </a:r>
+            <a:endParaRPr lang="en-US" dirty="0"/>
           </a:p>
         </p:txBody>
       </p:sp>
@@ -787,8 +951,9 @@
           <a:p>
             <a:r>
               <a:rPr lang="en-US" dirty="0"/>
-              <a:t>6 min. La Septante rend l'image de Gn 1.27 par eikôn, le mot que Paul applique à Christ (aussi 2 Co 4.4). Mais en un autre sens : l'homme porte l'image comme créature; Christ est, de toute éternité, la ressemblance parfaite de Dieu, une reproduction exacte, sans rien de manquant ni d'altéré (2135; Hé 1.3; Ph 2.6; Jn 14.9). Premier-né : le rang d'héritier, non la naissance (Ex 4.22; Jr 31.9, Éphraïm avant Manassé). Il a créé toutes choses (1.16). Application : qui veut savoir ce qu'est l'homme tel que Dieu l'a voulu regarde Christ; qui veut connaître Dieu le voit en Christ, sans intermédiaire. Transition : si Christ est l'image parfaite, que Dieu fait-il de ceux qu'il sauve?</a:t>
-            </a:r>
+              <a:t>6 min. La Septante rend l'image de Gn 1.27 par eikôn, le mot que Paul applique à Christ (aussi 2 Co 4.4). Mais en un autre sens : l'homme porte l'image comme créature; Christ est, de toute éternité, la ressemblance parfaite de Dieu, une reproduction exacte, sans rien de manquant ni d'altéré (2135; Hé 1.3; Ph 2.6; Jn 14.9). Kénose (Ph 2.6-7) : « il s'est dépouillé lui-même, en prenant une forme de serviteur »; non de sa divinité, « il n'a jamais cessé d'être Dieu » (50-16), mais de sa gloire céleste et de l'usage volontaire de ses prérogatives. Premier-né : le rang d'héritier, non la naissance (Ex 4.22; Jr 31.9, Éphraïm avant Manassé). Il a créé toutes choses (1.16). Application : qui veut savoir ce qu'est l'homme tel que Dieu l'a voulu regarde Christ; qui veut connaître Dieu le voit en Christ, sans intermédiaire. Transition : si Christ est l'image parfaite, que Dieu fait-il de ceux qu'il sauve?</a:t>
+            </a:r>
+            <a:endParaRPr lang="en-US" dirty="0"/>
           </a:p>
         </p:txBody>
       </p:sp>
@@ -876,6 +1041,7 @@
               <a:rPr lang="en-US" dirty="0"/>
               <a:t>5 min. « Connus d'avance » : non une simple prévision de qui croirait, mais le choix d'aimer, l'élection (Ac 2.23; 1 P 1.2, 20). Le même conseil éternel que le « Faisons ». « Le but de votre salut était que vous soyez rendus semblables à l'image de son Fils » (90-180). Premier-né de beaucoup de frères : la fin dernière est la gloire du Fils. Application : ce que Dieu a décrété, il l'achèvera (8.30); les épreuves de 8.28 servent ce but. Transition : nous ne voyons pas encore cette ressemblance achevée. Comment Dieu nous y conduit-il, aujourd'hui?</a:t>
             </a:r>
+            <a:endParaRPr lang="en-US" dirty="0"/>
           </a:p>
         </p:txBody>
       </p:sp>
@@ -963,6 +1129,7 @@
               <a:rPr lang="en-US" dirty="0"/>
               <a:t>6 min. A. Moïse voilait son visage (Ex 34.29-35); en Christ, le voile est ôté. « Nous tous » : tous les croyants (47-22). B. La NEG79 dit « reflète »; le grec, avec la S21, la LSG, Darby et la KJF, dit contempler comme dans un miroir. Le miroir, c'est l'Écriture, où la gloire de Dieu se voit sur la face de Jésus-Christ (90-75; 4.6). Relier au Rappel. C. Metamorphoô, présent passif : « une action de transformation continue et progressive » (47-21). « C'est là toute la sanctification progressive » (90-75). Le terme : « Le dessein salvateur de Dieu était de créer une humanité rachetée qui serait semblable à son Fils » (47-21). Application : contempler Christ dans sa Parole, et l'Esprit fait l'œuvre; celui qui délaisse l'Écriture se prive du miroir. Transition : à quoi reconnaît-on cette image qui grandit? À ce que Dieu avait mis au centre : le cœur qui aime.</a:t>
             </a:r>
+            <a:endParaRPr lang="en-US" dirty="0"/>
           </a:p>
         </p:txBody>
       </p:sp>
@@ -1050,6 +1217,7 @@
               <a:rPr lang="en-US" dirty="0"/>
               <a:t>7 min. A. Le piège des 613 commandements; Jésus répond par le Shema (Dt 6.5) et Lv 19.18 (2358). « Quand vous aimez Dieu comme il faut, vous aimez les gens comme il faut » (2358). B. « Parce que nous n'avons pas aimé ainsi, nous avons besoin du pardon, et parce que nous ne pouvons pas aimer ainsi, nous avons besoin d'une capacité nouvelle » (2358). C. Lire Jérémie 31.33 (NBS). La nouvelle alliance : « le pardon de tous nos péchés et l'écriture de la loi de Dieu sur nos cœurs » (80-286). Le cœur (1 Ch 28.9) : rationnel, moral, relationnel. Application : nous l'aimons parce qu'il nous a aimés le premier (1 Jn 4.19), et cet amour se prouve par l'obéissance (Jn 14.15). Transition : et le prochain que nous aimons, que lui devons-nous d'abord?</a:t>
             </a:r>
+            <a:endParaRPr lang="en-US" dirty="0"/>
           </a:p>
         </p:txBody>
       </p:sp>
@@ -1137,6 +1305,7 @@
               <a:rPr lang="en-US" dirty="0"/>
               <a:t>5 min. Un seul impératif : « faites des disciples »; aller, baptiser, enseigner en décrivent le chemin (2405). Le disciple : « un croyant qui apprend »; « on ne peut être disciple de Christ sans un cœur obéissant » (2405); la foi salvatrice se soumet à Christ comme Seigneur. « Au nom » : « un seul nom et trois personnes » (2405); le Dieu du « Faisons ». Le baptême, signe extérieur d'une foi déjà reçue. « Tout ce que je vous ai prescrit » inclut le grand commandement : faire des disciples, c'est former d'autres porteurs de l'image restaurée. « Je suis avec vous tous les jours » : jusqu'à son retour (2405). Application : aimer son prochain, c'est d'abord lui annoncer Christ.</a:t>
             </a:r>
+            <a:endParaRPr lang="en-US" dirty="0"/>
           </a:p>
         </p:txBody>
       </p:sp>
@@ -1209,11 +1378,6 @@
 <file path=ppt/slideMasters/slideMaster1.xml><?xml version="1.0" encoding="utf-8"?>
 <p:sldMaster xmlns:a="http://schemas.openxmlformats.org/drawingml/2006/main" xmlns:r="http://schemas.openxmlformats.org/officeDocument/2006/relationships" xmlns:p="http://schemas.openxmlformats.org/presentationml/2006/main">
   <p:cSld>
-    <p:bg>
-      <p:bgRef idx="1001">
-        <a:schemeClr val="bg1"/>
-      </p:bgRef>
-    </p:bg>
     <p:spTree>
       <p:nvGrpSpPr>
         <p:cNvPr id="1" name=""/>
@@ -1494,7 +1658,7 @@
     <p:bg>
       <p:bgPr>
         <a:blipFill dpi="0" rotWithShape="1">
-          <a:blip r:embed="rId3">
+          <a:blip r:embed="rId1">
             <a:lum/>
           </a:blip>
           <a:srcRect/>
@@ -1521,14 +1685,14 @@
       </p:grpSpPr>
       <p:pic>
         <p:nvPicPr>
-          <p:cNvPr id="2" name="Image 0" descr="Une personne frappée comme l'effigie d'une pièce"/>
+          <p:cNvPr id="2" name="Image 0" descr="Une personne frappée comme l'effigie d'une pièce">    </p:cNvPr>
           <p:cNvPicPr>
             <a:picLocks noChangeAspect="1"/>
           </p:cNvPicPr>
           <p:nvPr/>
         </p:nvPicPr>
         <p:blipFill>
-          <a:blip r:embed="rId4"/>
+          <a:blip r:embed="rId2"/>
           <a:stretch>
             <a:fillRect/>
           </a:stretch>
@@ -1564,11 +1728,11 @@
           <a:bodyPr wrap="square" lIns="0" tIns="0" rIns="0" bIns="0" rtlCol="0" anchor="t"/>
           <a:lstStyle/>
           <a:p>
-            <a:pPr marL="0" indent="0">
-              <a:buNone/>
-            </a:pPr>
-            <a:r>
-              <a:rPr lang="en-US" sz="1400" b="1" kern="0" spc="300" dirty="0">
+            <a:pPr indent="0" marL="0">
+              <a:buNone/>
+            </a:pPr>
+            <a:r>
+              <a:rPr lang="en-US" sz="1400" b="1" spc="300" kern="0" dirty="0">
                 <a:solidFill>
                   <a:srgbClr val="E8742A"/>
                 </a:solidFill>
@@ -1603,7 +1767,7 @@
           <a:bodyPr wrap="square" lIns="0" tIns="0" rIns="0" bIns="0" rtlCol="0" anchor="t"/>
           <a:lstStyle/>
           <a:p>
-            <a:pPr marL="0" indent="0">
+            <a:pPr indent="0" marL="0">
               <a:lnSpc>
                 <a:spcPct val="95000"/>
               </a:lnSpc>
@@ -1623,7 +1787,7 @@
             <a:endParaRPr lang="en-US" sz="5600" dirty="0"/>
           </a:p>
           <a:p>
-            <a:pPr marL="0" indent="0">
+            <a:pPr indent="0" marL="0">
               <a:lnSpc>
                 <a:spcPct val="95000"/>
               </a:lnSpc>
@@ -1665,7 +1829,7 @@
           <a:bodyPr wrap="square" lIns="0" tIns="0" rIns="0" bIns="0" rtlCol="0" anchor="t"/>
           <a:lstStyle/>
           <a:p>
-            <a:pPr marL="0" indent="0">
+            <a:pPr indent="0" marL="0">
               <a:buNone/>
             </a:pPr>
             <a:r>
@@ -1704,7 +1868,7 @@
           <a:bodyPr wrap="square" lIns="0" tIns="0" rIns="0" bIns="0" rtlCol="0" anchor="t"/>
           <a:lstStyle/>
           <a:p>
-            <a:pPr marL="0" indent="0">
+            <a:pPr indent="0" marL="0">
               <a:spcAft>
                 <a:spcPts val="400"/>
               </a:spcAft>
@@ -1724,7 +1888,7 @@
             <a:endParaRPr lang="en-US" sz="1700" dirty="0"/>
           </a:p>
           <a:p>
-            <a:pPr marL="0" indent="0">
+            <a:pPr indent="0" marL="0">
               <a:spcAft>
                 <a:spcPts val="400"/>
               </a:spcAft>
@@ -1766,7 +1930,7 @@
           <a:bodyPr wrap="square" lIns="0" tIns="0" rIns="0" bIns="0" rtlCol="0" anchor="t"/>
           <a:lstStyle/>
           <a:p>
-            <a:pPr marL="0" indent="0">
+            <a:pPr indent="0" marL="0">
               <a:buNone/>
             </a:pPr>
             <a:r>
@@ -1798,7 +1962,7 @@
     <p:bg>
       <p:bgPr>
         <a:blipFill dpi="0" rotWithShape="1">
-          <a:blip r:embed="rId3">
+          <a:blip r:embed="rId1">
             <a:lum/>
           </a:blip>
           <a:srcRect/>
@@ -1844,11 +2008,11 @@
           <a:bodyPr wrap="square" lIns="0" tIns="0" rIns="0" bIns="0" rtlCol="0" anchor="t"/>
           <a:lstStyle/>
           <a:p>
-            <a:pPr marL="0" indent="0">
-              <a:buNone/>
-            </a:pPr>
-            <a:r>
-              <a:rPr lang="en-US" sz="1300" b="1" kern="0" spc="300" dirty="0">
+            <a:pPr indent="0" marL="0">
+              <a:buNone/>
+            </a:pPr>
+            <a:r>
+              <a:rPr lang="en-US" sz="1300" b="1" spc="300" kern="0" dirty="0">
                 <a:solidFill>
                   <a:srgbClr val="E8742A"/>
                 </a:solidFill>
@@ -1883,7 +2047,7 @@
           <a:bodyPr wrap="square" lIns="0" tIns="0" rIns="0" bIns="0" rtlCol="0" anchor="t"/>
           <a:lstStyle/>
           <a:p>
-            <a:pPr marL="0" indent="0">
+            <a:pPr indent="0" marL="0">
               <a:buNone/>
             </a:pPr>
             <a:r>
@@ -1900,7 +2064,7 @@
             <a:endParaRPr lang="en-US" sz="3000" dirty="0"/>
           </a:p>
           <a:p>
-            <a:pPr marL="0" indent="0">
+            <a:pPr indent="0" marL="0">
               <a:buNone/>
             </a:pPr>
             <a:r>
@@ -1940,13 +2104,6 @@
             <a:prstDash val="dash"/>
           </a:ln>
         </p:spPr>
-        <p:txBody>
-          <a:bodyPr/>
-          <a:lstStyle/>
-          <a:p>
-            <a:endParaRPr lang="fr-CA"/>
-          </a:p>
-        </p:txBody>
       </p:sp>
       <p:sp>
         <p:nvSpPr>
@@ -1970,13 +2127,6 @@
             <a:prstDash val="solid"/>
           </a:ln>
         </p:spPr>
-        <p:txBody>
-          <a:bodyPr/>
-          <a:lstStyle/>
-          <a:p>
-            <a:endParaRPr lang="fr-CA"/>
-          </a:p>
-        </p:txBody>
       </p:sp>
       <p:sp>
         <p:nvSpPr>
@@ -2000,13 +2150,6 @@
             <a:prstDash val="solid"/>
           </a:ln>
         </p:spPr>
-        <p:txBody>
-          <a:bodyPr/>
-          <a:lstStyle/>
-          <a:p>
-            <a:endParaRPr lang="fr-CA"/>
-          </a:p>
-        </p:txBody>
       </p:sp>
       <p:sp>
         <p:nvSpPr>
@@ -2030,13 +2173,6 @@
             <a:prstDash val="solid"/>
           </a:ln>
         </p:spPr>
-        <p:txBody>
-          <a:bodyPr/>
-          <a:lstStyle/>
-          <a:p>
-            <a:endParaRPr lang="fr-CA"/>
-          </a:p>
-        </p:txBody>
       </p:sp>
       <p:sp>
         <p:nvSpPr>
@@ -2060,13 +2196,6 @@
             <a:prstDash val="solid"/>
           </a:ln>
         </p:spPr>
-        <p:txBody>
-          <a:bodyPr/>
-          <a:lstStyle/>
-          <a:p>
-            <a:endParaRPr lang="fr-CA"/>
-          </a:p>
-        </p:txBody>
       </p:sp>
       <p:sp>
         <p:nvSpPr>
@@ -2090,13 +2219,6 @@
             <a:prstDash val="solid"/>
           </a:ln>
         </p:spPr>
-        <p:txBody>
-          <a:bodyPr/>
-          <a:lstStyle/>
-          <a:p>
-            <a:endParaRPr lang="fr-CA"/>
-          </a:p>
-        </p:txBody>
       </p:sp>
       <p:sp>
         <p:nvSpPr>
@@ -2122,13 +2244,6 @@
             <a:prstDash val="solid"/>
           </a:ln>
         </p:spPr>
-        <p:txBody>
-          <a:bodyPr/>
-          <a:lstStyle/>
-          <a:p>
-            <a:endParaRPr lang="fr-CA"/>
-          </a:p>
-        </p:txBody>
       </p:sp>
       <p:sp>
         <p:nvSpPr>
@@ -2151,7 +2266,7 @@
           <a:bodyPr wrap="square" lIns="0" tIns="0" rIns="0" bIns="0" rtlCol="0" anchor="t"/>
           <a:lstStyle/>
           <a:p>
-            <a:pPr marL="0" indent="0" algn="ctr">
+            <a:pPr algn="ctr" indent="0" marL="0">
               <a:buNone/>
             </a:pPr>
             <a:r>
@@ -2168,7 +2283,7 @@
             <a:endParaRPr lang="en-US" sz="1600" dirty="0"/>
           </a:p>
           <a:p>
-            <a:pPr marL="0" indent="0" algn="ctr">
+            <a:pPr algn="ctr" indent="0" marL="0">
               <a:buNone/>
             </a:pPr>
             <a:r>
@@ -2210,13 +2325,6 @@
             <a:prstDash val="solid"/>
           </a:ln>
         </p:spPr>
-        <p:txBody>
-          <a:bodyPr/>
-          <a:lstStyle/>
-          <a:p>
-            <a:endParaRPr lang="fr-CA"/>
-          </a:p>
-        </p:txBody>
       </p:sp>
       <p:sp>
         <p:nvSpPr>
@@ -2239,7 +2347,7 @@
           <a:bodyPr wrap="square" lIns="0" tIns="0" rIns="0" bIns="0" rtlCol="0" anchor="t"/>
           <a:lstStyle/>
           <a:p>
-            <a:pPr marL="0" indent="0" algn="ctr">
+            <a:pPr algn="ctr" indent="0" marL="0">
               <a:buNone/>
             </a:pPr>
             <a:r>
@@ -2256,7 +2364,7 @@
             <a:endParaRPr lang="en-US" sz="1600" dirty="0"/>
           </a:p>
           <a:p>
-            <a:pPr marL="0" indent="0" algn="ctr">
+            <a:pPr algn="ctr" indent="0" marL="0">
               <a:buNone/>
             </a:pPr>
             <a:r>
@@ -2298,13 +2406,6 @@
             <a:prstDash val="solid"/>
           </a:ln>
         </p:spPr>
-        <p:txBody>
-          <a:bodyPr/>
-          <a:lstStyle/>
-          <a:p>
-            <a:endParaRPr lang="fr-CA"/>
-          </a:p>
-        </p:txBody>
       </p:sp>
       <p:sp>
         <p:nvSpPr>
@@ -2327,7 +2428,7 @@
           <a:bodyPr wrap="square" lIns="0" tIns="0" rIns="0" bIns="0" rtlCol="0" anchor="t"/>
           <a:lstStyle/>
           <a:p>
-            <a:pPr marL="0" indent="0" algn="ctr">
+            <a:pPr algn="ctr" indent="0" marL="0">
               <a:buNone/>
             </a:pPr>
             <a:r>
@@ -2344,7 +2445,7 @@
             <a:endParaRPr lang="en-US" sz="1600" dirty="0"/>
           </a:p>
           <a:p>
-            <a:pPr marL="0" indent="0" algn="ctr">
+            <a:pPr algn="ctr" indent="0" marL="0">
               <a:buNone/>
             </a:pPr>
             <a:r>
@@ -2386,13 +2487,6 @@
             <a:prstDash val="solid"/>
           </a:ln>
         </p:spPr>
-        <p:txBody>
-          <a:bodyPr/>
-          <a:lstStyle/>
-          <a:p>
-            <a:endParaRPr lang="fr-CA"/>
-          </a:p>
-        </p:txBody>
       </p:sp>
       <p:sp>
         <p:nvSpPr>
@@ -2415,7 +2509,7 @@
           <a:bodyPr wrap="square" lIns="0" tIns="0" rIns="0" bIns="0" rtlCol="0" anchor="t"/>
           <a:lstStyle/>
           <a:p>
-            <a:pPr marL="0" indent="0" algn="ctr">
+            <a:pPr algn="ctr" indent="0" marL="0">
               <a:buNone/>
             </a:pPr>
             <a:r>
@@ -2432,7 +2526,7 @@
             <a:endParaRPr lang="en-US" sz="1600" dirty="0"/>
           </a:p>
           <a:p>
-            <a:pPr marL="0" indent="0" algn="ctr">
+            <a:pPr algn="ctr" indent="0" marL="0">
               <a:buNone/>
             </a:pPr>
             <a:r>
@@ -2474,13 +2568,6 @@
             <a:prstDash val="solid"/>
           </a:ln>
         </p:spPr>
-        <p:txBody>
-          <a:bodyPr/>
-          <a:lstStyle/>
-          <a:p>
-            <a:endParaRPr lang="fr-CA"/>
-          </a:p>
-        </p:txBody>
       </p:sp>
       <p:sp>
         <p:nvSpPr>
@@ -2503,7 +2590,7 @@
           <a:bodyPr wrap="square" lIns="0" tIns="0" rIns="0" bIns="0" rtlCol="0" anchor="t"/>
           <a:lstStyle/>
           <a:p>
-            <a:pPr marL="0" indent="0" algn="ctr">
+            <a:pPr algn="ctr" indent="0" marL="0">
               <a:buNone/>
             </a:pPr>
             <a:r>
@@ -2545,13 +2632,6 @@
             <a:prstDash val="solid"/>
           </a:ln>
         </p:spPr>
-        <p:txBody>
-          <a:bodyPr/>
-          <a:lstStyle/>
-          <a:p>
-            <a:endParaRPr lang="fr-CA"/>
-          </a:p>
-        </p:txBody>
       </p:sp>
       <p:sp>
         <p:nvSpPr>
@@ -2574,7 +2654,7 @@
           <a:bodyPr wrap="square" lIns="0" tIns="0" rIns="0" bIns="0" rtlCol="0" anchor="t"/>
           <a:lstStyle/>
           <a:p>
-            <a:pPr marL="0" indent="0" algn="ctr">
+            <a:pPr algn="ctr" indent="0" marL="0">
               <a:buNone/>
             </a:pPr>
             <a:r>
@@ -2591,7 +2671,7 @@
             <a:endParaRPr lang="en-US" sz="1600" dirty="0"/>
           </a:p>
           <a:p>
-            <a:pPr marL="0" indent="0" algn="ctr">
+            <a:pPr algn="ctr" indent="0" marL="0">
               <a:buNone/>
             </a:pPr>
             <a:r>
@@ -2633,13 +2713,6 @@
             <a:prstDash val="solid"/>
           </a:ln>
         </p:spPr>
-        <p:txBody>
-          <a:bodyPr/>
-          <a:lstStyle/>
-          <a:p>
-            <a:endParaRPr lang="fr-CA"/>
-          </a:p>
-        </p:txBody>
       </p:sp>
       <p:sp>
         <p:nvSpPr>
@@ -2662,7 +2735,7 @@
           <a:bodyPr wrap="square" lIns="0" tIns="0" rIns="0" bIns="0" rtlCol="0" anchor="t"/>
           <a:lstStyle/>
           <a:p>
-            <a:pPr marL="0" indent="0" algn="ctr">
+            <a:pPr algn="ctr" indent="0" marL="0">
               <a:buNone/>
             </a:pPr>
             <a:r>
@@ -2679,7 +2752,7 @@
             <a:endParaRPr lang="en-US" sz="1600" dirty="0"/>
           </a:p>
           <a:p>
-            <a:pPr marL="0" indent="0" algn="ctr">
+            <a:pPr algn="ctr" indent="0" marL="0">
               <a:buNone/>
             </a:pPr>
             <a:r>
@@ -2723,13 +2796,6 @@
             <a:prstDash val="solid"/>
           </a:ln>
         </p:spPr>
-        <p:txBody>
-          <a:bodyPr/>
-          <a:lstStyle/>
-          <a:p>
-            <a:endParaRPr lang="fr-CA"/>
-          </a:p>
-        </p:txBody>
       </p:sp>
       <p:sp>
         <p:nvSpPr>
@@ -2752,7 +2818,7 @@
           <a:bodyPr wrap="square" lIns="0" tIns="0" rIns="0" bIns="0" rtlCol="0" anchor="t"/>
           <a:lstStyle/>
           <a:p>
-            <a:pPr marL="0" indent="0">
+            <a:pPr indent="0" marL="0">
               <a:buNone/>
             </a:pPr>
             <a:r>
@@ -2769,7 +2835,7 @@
             <a:endParaRPr lang="en-US" sz="1500" dirty="0"/>
           </a:p>
           <a:p>
-            <a:pPr marL="0" indent="0">
+            <a:pPr indent="0" marL="0">
               <a:buNone/>
             </a:pPr>
             <a:r>
@@ -2813,13 +2879,6 @@
             <a:prstDash val="solid"/>
           </a:ln>
         </p:spPr>
-        <p:txBody>
-          <a:bodyPr/>
-          <a:lstStyle/>
-          <a:p>
-            <a:endParaRPr lang="fr-CA"/>
-          </a:p>
-        </p:txBody>
       </p:sp>
       <p:sp>
         <p:nvSpPr>
@@ -2842,7 +2901,7 @@
           <a:bodyPr wrap="square" lIns="0" tIns="0" rIns="0" bIns="0" rtlCol="0" anchor="t"/>
           <a:lstStyle/>
           <a:p>
-            <a:pPr marL="0" indent="0">
+            <a:pPr indent="0" marL="0">
               <a:buNone/>
             </a:pPr>
             <a:r>
@@ -2859,7 +2918,7 @@
             <a:endParaRPr lang="en-US" sz="1500" dirty="0"/>
           </a:p>
           <a:p>
-            <a:pPr marL="0" indent="0">
+            <a:pPr indent="0" marL="0">
               <a:buNone/>
             </a:pPr>
             <a:r>
@@ -2893,7 +2952,6 @@
         <a:solidFill>
           <a:srgbClr val="0D0B0A"/>
         </a:solidFill>
-        <a:effectLst/>
       </p:bgPr>
     </p:bg>
     <p:spTree>
@@ -2931,11 +2989,11 @@
           <a:bodyPr wrap="square" lIns="0" tIns="0" rIns="0" bIns="0" rtlCol="0" anchor="t"/>
           <a:lstStyle/>
           <a:p>
-            <a:pPr marL="0" indent="0">
-              <a:buNone/>
-            </a:pPr>
-            <a:r>
-              <a:rPr lang="en-US" sz="1300" b="1" kern="0" spc="300" dirty="0">
+            <a:pPr indent="0" marL="0">
+              <a:buNone/>
+            </a:pPr>
+            <a:r>
+              <a:rPr lang="en-US" sz="1300" b="1" spc="300" kern="0" dirty="0">
                 <a:solidFill>
                   <a:srgbClr val="E8742A"/>
                 </a:solidFill>
@@ -2970,7 +3028,7 @@
           <a:bodyPr wrap="square" lIns="0" tIns="0" rIns="0" bIns="0" rtlCol="0" anchor="t"/>
           <a:lstStyle/>
           <a:p>
-            <a:pPr marL="0" indent="0">
+            <a:pPr indent="0" marL="0">
               <a:buNone/>
             </a:pPr>
             <a:r>
@@ -3009,7 +3067,7 @@
           <a:bodyPr wrap="square" lIns="0" tIns="0" rIns="0" bIns="0" rtlCol="0" anchor="t"/>
           <a:lstStyle/>
           <a:p>
-            <a:pPr marL="0" indent="0">
+            <a:pPr indent="0" marL="0">
               <a:buNone/>
             </a:pPr>
             <a:r>
@@ -3029,14 +3087,14 @@
       </p:sp>
       <p:pic>
         <p:nvPicPr>
-          <p:cNvPr id="5" name="Image 0" descr="Un livre ouvert d'où monte un souffle"/>
+          <p:cNvPr id="5" name="Image 0" descr="Un livre ouvert d'où monte un souffle">    </p:cNvPr>
           <p:cNvPicPr>
             <a:picLocks noChangeAspect="1"/>
           </p:cNvPicPr>
           <p:nvPr/>
         </p:nvPicPr>
         <p:blipFill>
-          <a:blip r:embed="rId3"/>
+          <a:blip r:embed="rId1"/>
           <a:stretch>
             <a:fillRect/>
           </a:stretch>
@@ -3072,7 +3130,7 @@
           <a:bodyPr wrap="square" lIns="0" tIns="0" rIns="0" bIns="0" rtlCol="0" anchor="t"/>
           <a:lstStyle/>
           <a:p>
-            <a:pPr marL="0" indent="0" algn="ctr">
+            <a:pPr algn="ctr" indent="0" marL="0">
               <a:buNone/>
             </a:pPr>
             <a:r>
@@ -3086,6 +3144,9 @@
               </a:rPr>
               <a:t>theopneustos</a:t>
             </a:r>
+            <a:pPr algn="ctr" indent="0" marL="0">
+              <a:buNone/>
+            </a:pPr>
             <a:r>
               <a:rPr lang="en-US" sz="1800" dirty="0">
                 <a:solidFill>
@@ -3123,13 +3184,6 @@
             <a:prstDash val="solid"/>
           </a:ln>
         </p:spPr>
-        <p:txBody>
-          <a:bodyPr/>
-          <a:lstStyle/>
-          <a:p>
-            <a:endParaRPr lang="fr-CA"/>
-          </a:p>
-        </p:txBody>
       </p:sp>
       <p:sp>
         <p:nvSpPr>
@@ -3155,13 +3209,6 @@
             <a:prstDash val="solid"/>
           </a:ln>
         </p:spPr>
-        <p:txBody>
-          <a:bodyPr/>
-          <a:lstStyle/>
-          <a:p>
-            <a:endParaRPr lang="fr-CA"/>
-          </a:p>
-        </p:txBody>
       </p:sp>
       <p:sp>
         <p:nvSpPr>
@@ -3184,7 +3231,7 @@
           <a:bodyPr wrap="square" lIns="0" tIns="0" rIns="0" bIns="0" rtlCol="0" anchor="ctr"/>
           <a:lstStyle/>
           <a:p>
-            <a:pPr marL="0" indent="0" algn="ctr">
+            <a:pPr algn="ctr" indent="0" marL="0">
               <a:buNone/>
             </a:pPr>
             <a:r>
@@ -3223,7 +3270,7 @@
           <a:bodyPr wrap="square" lIns="0" tIns="0" rIns="0" bIns="0" rtlCol="0" anchor="t"/>
           <a:lstStyle/>
           <a:p>
-            <a:pPr marL="0" indent="0">
+            <a:pPr indent="0" marL="0">
               <a:buNone/>
             </a:pPr>
             <a:r>
@@ -3240,7 +3287,7 @@
             <a:endParaRPr lang="en-US" sz="1700" dirty="0"/>
           </a:p>
           <a:p>
-            <a:pPr marL="0" indent="0">
+            <a:pPr indent="0" marL="0">
               <a:buNone/>
             </a:pPr>
             <a:r>
@@ -3282,13 +3329,6 @@
             <a:prstDash val="solid"/>
           </a:ln>
         </p:spPr>
-        <p:txBody>
-          <a:bodyPr/>
-          <a:lstStyle/>
-          <a:p>
-            <a:endParaRPr lang="fr-CA"/>
-          </a:p>
-        </p:txBody>
       </p:sp>
       <p:sp>
         <p:nvSpPr>
@@ -3311,7 +3351,7 @@
           <a:bodyPr wrap="square" lIns="0" tIns="0" rIns="0" bIns="0" rtlCol="0" anchor="ctr"/>
           <a:lstStyle/>
           <a:p>
-            <a:pPr marL="0" indent="0" algn="ctr">
+            <a:pPr algn="ctr" indent="0" marL="0">
               <a:buNone/>
             </a:pPr>
             <a:r>
@@ -3350,7 +3390,7 @@
           <a:bodyPr wrap="square" lIns="0" tIns="0" rIns="0" bIns="0" rtlCol="0" anchor="t"/>
           <a:lstStyle/>
           <a:p>
-            <a:pPr marL="0" indent="0">
+            <a:pPr indent="0" marL="0">
               <a:buNone/>
             </a:pPr>
             <a:r>
@@ -3367,7 +3407,7 @@
             <a:endParaRPr lang="en-US" sz="1700" dirty="0"/>
           </a:p>
           <a:p>
-            <a:pPr marL="0" indent="0">
+            <a:pPr indent="0" marL="0">
               <a:buNone/>
             </a:pPr>
             <a:r>
@@ -3409,13 +3449,6 @@
             <a:prstDash val="solid"/>
           </a:ln>
         </p:spPr>
-        <p:txBody>
-          <a:bodyPr/>
-          <a:lstStyle/>
-          <a:p>
-            <a:endParaRPr lang="fr-CA"/>
-          </a:p>
-        </p:txBody>
       </p:sp>
       <p:sp>
         <p:nvSpPr>
@@ -3438,7 +3471,7 @@
           <a:bodyPr wrap="square" lIns="0" tIns="0" rIns="0" bIns="0" rtlCol="0" anchor="ctr"/>
           <a:lstStyle/>
           <a:p>
-            <a:pPr marL="0" indent="0" algn="ctr">
+            <a:pPr algn="ctr" indent="0" marL="0">
               <a:buNone/>
             </a:pPr>
             <a:r>
@@ -3477,7 +3510,7 @@
           <a:bodyPr wrap="square" lIns="0" tIns="0" rIns="0" bIns="0" rtlCol="0" anchor="t"/>
           <a:lstStyle/>
           <a:p>
-            <a:pPr marL="0" indent="0">
+            <a:pPr indent="0" marL="0">
               <a:buNone/>
             </a:pPr>
             <a:r>
@@ -3494,7 +3527,7 @@
             <a:endParaRPr lang="en-US" sz="1700" dirty="0"/>
           </a:p>
           <a:p>
-            <a:pPr marL="0" indent="0">
+            <a:pPr indent="0" marL="0">
               <a:buNone/>
             </a:pPr>
             <a:r>
@@ -3536,13 +3569,6 @@
             <a:prstDash val="solid"/>
           </a:ln>
         </p:spPr>
-        <p:txBody>
-          <a:bodyPr/>
-          <a:lstStyle/>
-          <a:p>
-            <a:endParaRPr lang="fr-CA"/>
-          </a:p>
-        </p:txBody>
       </p:sp>
       <p:sp>
         <p:nvSpPr>
@@ -3565,7 +3591,7 @@
           <a:bodyPr wrap="square" lIns="0" tIns="0" rIns="0" bIns="0" rtlCol="0" anchor="ctr"/>
           <a:lstStyle/>
           <a:p>
-            <a:pPr marL="0" indent="0" algn="ctr">
+            <a:pPr algn="ctr" indent="0" marL="0">
               <a:buNone/>
             </a:pPr>
             <a:r>
@@ -3604,7 +3630,7 @@
           <a:bodyPr wrap="square" lIns="0" tIns="0" rIns="0" bIns="0" rtlCol="0" anchor="t"/>
           <a:lstStyle/>
           <a:p>
-            <a:pPr marL="0" indent="0">
+            <a:pPr indent="0" marL="0">
               <a:buNone/>
             </a:pPr>
             <a:r>
@@ -3621,7 +3647,7 @@
             <a:endParaRPr lang="en-US" sz="1700" dirty="0"/>
           </a:p>
           <a:p>
-            <a:pPr marL="0" indent="0">
+            <a:pPr indent="0" marL="0">
               <a:buNone/>
             </a:pPr>
             <a:r>
@@ -3665,13 +3691,6 @@
             <a:prstDash val="solid"/>
           </a:ln>
         </p:spPr>
-        <p:txBody>
-          <a:bodyPr/>
-          <a:lstStyle/>
-          <a:p>
-            <a:endParaRPr lang="fr-CA"/>
-          </a:p>
-        </p:txBody>
       </p:sp>
       <p:sp>
         <p:nvSpPr>
@@ -3694,7 +3713,7 @@
           <a:bodyPr wrap="square" lIns="0" tIns="0" rIns="0" bIns="0" rtlCol="0" anchor="ctr"/>
           <a:lstStyle/>
           <a:p>
-            <a:pPr marL="0" indent="0">
+            <a:pPr indent="0" marL="0">
               <a:buNone/>
             </a:pPr>
             <a:r>
@@ -3708,6 +3727,9 @@
               </a:rPr>
               <a:t>But : </a:t>
             </a:r>
+            <a:pPr indent="0" marL="0">
+              <a:buNone/>
+            </a:pPr>
             <a:r>
               <a:rPr lang="en-US" sz="1700" dirty="0">
                 <a:solidFill>
@@ -3739,7 +3761,6 @@
         <a:solidFill>
           <a:srgbClr val="0D0B0A"/>
         </a:solidFill>
-        <a:effectLst/>
       </p:bgPr>
     </p:bg>
     <p:spTree>
@@ -3777,11 +3798,11 @@
           <a:bodyPr wrap="square" lIns="0" tIns="0" rIns="0" bIns="0" rtlCol="0" anchor="t"/>
           <a:lstStyle/>
           <a:p>
-            <a:pPr marL="0" indent="0">
-              <a:buNone/>
-            </a:pPr>
-            <a:r>
-              <a:rPr lang="en-US" sz="1300" b="1" kern="0" spc="300" dirty="0">
+            <a:pPr indent="0" marL="0">
+              <a:buNone/>
+            </a:pPr>
+            <a:r>
+              <a:rPr lang="en-US" sz="1300" b="1" spc="300" kern="0" dirty="0">
                 <a:solidFill>
                   <a:srgbClr val="E8742A"/>
                 </a:solidFill>
@@ -3816,7 +3837,7 @@
           <a:bodyPr wrap="square" lIns="0" tIns="0" rIns="0" bIns="0" rtlCol="0" anchor="t"/>
           <a:lstStyle/>
           <a:p>
-            <a:pPr marL="0" indent="0">
+            <a:pPr indent="0" marL="0">
               <a:buNone/>
             </a:pPr>
             <a:r>
@@ -3855,7 +3876,7 @@
           <a:bodyPr wrap="square" lIns="0" tIns="0" rIns="0" bIns="0" rtlCol="0" anchor="t"/>
           <a:lstStyle/>
           <a:p>
-            <a:pPr marL="0" indent="0">
+            <a:pPr indent="0" marL="0">
               <a:buNone/>
             </a:pPr>
             <a:r>
@@ -3875,14 +3896,14 @@
       </p:sp>
       <p:pic>
         <p:nvPicPr>
-          <p:cNvPr id="5" name="Image 0" descr="Le pharaon, « image vivante » du dieu, puis une personne à l'image de Dieu"/>
+          <p:cNvPr id="5" name="Image 0" descr="Le pharaon, « image vivante » du dieu, puis une personne à l'image de Dieu">    </p:cNvPr>
           <p:cNvPicPr>
             <a:picLocks noChangeAspect="1"/>
           </p:cNvPicPr>
           <p:nvPr/>
         </p:nvPicPr>
         <p:blipFill>
-          <a:blip r:embed="rId3"/>
+          <a:blip r:embed="rId1"/>
           <a:stretch>
             <a:fillRect/>
           </a:stretch>
@@ -3905,20 +3926,20 @@
         </p:nvSpPr>
         <p:spPr>
           <a:xfrm>
-            <a:off x="508000" y="5120640"/>
-            <a:ext cx="3175000" cy="685800"/>
-          </a:xfrm>
-          <a:prstGeom prst="rect">
-            <a:avLst/>
-          </a:prstGeom>
-          <a:noFill/>
-          <a:ln/>
-        </p:spPr>
-        <p:txBody>
-          <a:bodyPr wrap="square" lIns="0" tIns="0" rIns="0" bIns="0" rtlCol="0" anchor="t"/>
-          <a:lstStyle/>
-          <a:p>
-            <a:pPr marL="0" indent="0" algn="ctr">
+            <a:off x="365760" y="5120640"/>
+            <a:ext cx="3474720" cy="685800"/>
+          </a:xfrm>
+          <a:prstGeom prst="rect">
+            <a:avLst/>
+          </a:prstGeom>
+          <a:noFill/>
+          <a:ln/>
+        </p:spPr>
+        <p:txBody>
+          <a:bodyPr wrap="square" lIns="0" tIns="0" rIns="0" bIns="0" rtlCol="0" anchor="t"/>
+          <a:lstStyle/>
+          <a:p>
+            <a:pPr algn="ctr" indent="0" marL="0">
               <a:buNone/>
             </a:pPr>
             <a:r>
@@ -3935,7 +3956,7 @@
             <a:endParaRPr lang="en-US" sz="1600" dirty="0"/>
           </a:p>
           <a:p>
-            <a:pPr marL="0" indent="0" algn="ctr">
+            <a:pPr algn="ctr" indent="0" marL="0">
               <a:buNone/>
             </a:pPr>
             <a:r>
@@ -3961,20 +3982,20 @@
         </p:nvSpPr>
         <p:spPr>
           <a:xfrm>
-            <a:off x="3810000" y="5120640"/>
-            <a:ext cx="3175000" cy="685800"/>
-          </a:xfrm>
-          <a:prstGeom prst="rect">
-            <a:avLst/>
-          </a:prstGeom>
-          <a:noFill/>
-          <a:ln/>
-        </p:spPr>
-        <p:txBody>
-          <a:bodyPr wrap="square" lIns="0" tIns="0" rIns="0" bIns="0" rtlCol="0" anchor="t"/>
-          <a:lstStyle/>
-          <a:p>
-            <a:pPr marL="0" indent="0" algn="ctr">
+            <a:off x="3657600" y="5120640"/>
+            <a:ext cx="3474720" cy="685800"/>
+          </a:xfrm>
+          <a:prstGeom prst="rect">
+            <a:avLst/>
+          </a:prstGeom>
+          <a:noFill/>
+          <a:ln/>
+        </p:spPr>
+        <p:txBody>
+          <a:bodyPr wrap="square" lIns="0" tIns="0" rIns="0" bIns="0" rtlCol="0" anchor="t"/>
+          <a:lstStyle/>
+          <a:p>
+            <a:pPr algn="ctr" indent="0" marL="0">
               <a:buNone/>
             </a:pPr>
             <a:r>
@@ -3991,7 +4012,7 @@
             <a:endParaRPr lang="en-US" sz="1600" dirty="0"/>
           </a:p>
           <a:p>
-            <a:pPr marL="0" indent="0" algn="ctr">
+            <a:pPr algn="ctr" indent="0" marL="0">
               <a:buNone/>
             </a:pPr>
             <a:r>
@@ -4030,7 +4051,7 @@
           <a:bodyPr wrap="square" lIns="0" tIns="0" rIns="0" bIns="0" rtlCol="0" anchor="t"/>
           <a:lstStyle/>
           <a:p>
-            <a:pPr marL="0" indent="0" algn="ctr">
+            <a:pPr algn="ctr" indent="0" marL="0">
               <a:buNone/>
             </a:pPr>
             <a:r>
@@ -4074,13 +4095,6 @@
             <a:prstDash val="solid"/>
           </a:ln>
         </p:spPr>
-        <p:txBody>
-          <a:bodyPr/>
-          <a:lstStyle/>
-          <a:p>
-            <a:endParaRPr lang="fr-CA"/>
-          </a:p>
-        </p:txBody>
       </p:sp>
       <p:sp>
         <p:nvSpPr>
@@ -4103,7 +4117,7 @@
           <a:bodyPr wrap="square" lIns="0" tIns="0" rIns="0" bIns="0" rtlCol="0" anchor="t"/>
           <a:lstStyle/>
           <a:p>
-            <a:pPr marL="0" indent="0">
+            <a:pPr indent="0" marL="0">
               <a:buNone/>
             </a:pPr>
             <a:r>
@@ -4117,6 +4131,9 @@
               </a:rPr>
               <a:t>tselem</a:t>
             </a:r>
+            <a:pPr indent="0" marL="0">
+              <a:buNone/>
+            </a:pPr>
             <a:r>
               <a:rPr lang="en-US" sz="1700" dirty="0">
                 <a:solidFill>
@@ -4153,11 +4170,11 @@
           <a:bodyPr wrap="square" lIns="0" tIns="0" rIns="0" bIns="0" rtlCol="0" anchor="t"/>
           <a:lstStyle/>
           <a:p>
-            <a:pPr marL="0" indent="0">
-              <a:buNone/>
-            </a:pPr>
-            <a:r>
-              <a:rPr lang="en-US" sz="1200" b="1" kern="0" spc="300" dirty="0">
+            <a:pPr indent="0" marL="0">
+              <a:buNone/>
+            </a:pPr>
+            <a:r>
+              <a:rPr lang="en-US" sz="1200" b="1" spc="300" kern="0" dirty="0">
                 <a:solidFill>
                   <a:srgbClr val="6E625A"/>
                 </a:solidFill>
@@ -4195,13 +4212,6 @@
             <a:prstDash val="solid"/>
           </a:ln>
         </p:spPr>
-        <p:txBody>
-          <a:bodyPr/>
-          <a:lstStyle/>
-          <a:p>
-            <a:endParaRPr lang="fr-CA"/>
-          </a:p>
-        </p:txBody>
       </p:sp>
       <p:sp>
         <p:nvSpPr>
@@ -4224,7 +4234,7 @@
           <a:bodyPr wrap="square" lIns="0" tIns="0" rIns="0" bIns="0" rtlCol="0" anchor="ctr"/>
           <a:lstStyle/>
           <a:p>
-            <a:pPr marL="0" indent="0" algn="ctr">
+            <a:pPr algn="ctr" indent="0" marL="0">
               <a:buNone/>
             </a:pPr>
             <a:r>
@@ -4263,7 +4273,7 @@
           <a:bodyPr wrap="square" lIns="0" tIns="0" rIns="0" bIns="0" rtlCol="0" anchor="ctr"/>
           <a:lstStyle/>
           <a:p>
-            <a:pPr marL="0" indent="0">
+            <a:pPr indent="0" marL="0">
               <a:buNone/>
             </a:pPr>
             <a:r>
@@ -4305,13 +4315,6 @@
             <a:prstDash val="solid"/>
           </a:ln>
         </p:spPr>
-        <p:txBody>
-          <a:bodyPr/>
-          <a:lstStyle/>
-          <a:p>
-            <a:endParaRPr lang="fr-CA"/>
-          </a:p>
-        </p:txBody>
       </p:sp>
       <p:sp>
         <p:nvSpPr>
@@ -4334,7 +4337,7 @@
           <a:bodyPr wrap="square" lIns="0" tIns="0" rIns="0" bIns="0" rtlCol="0" anchor="ctr"/>
           <a:lstStyle/>
           <a:p>
-            <a:pPr marL="0" indent="0" algn="ctr">
+            <a:pPr algn="ctr" indent="0" marL="0">
               <a:buNone/>
             </a:pPr>
             <a:r>
@@ -4373,7 +4376,7 @@
           <a:bodyPr wrap="square" lIns="0" tIns="0" rIns="0" bIns="0" rtlCol="0" anchor="ctr"/>
           <a:lstStyle/>
           <a:p>
-            <a:pPr marL="0" indent="0">
+            <a:pPr indent="0" marL="0">
               <a:buNone/>
             </a:pPr>
             <a:r>
@@ -4415,13 +4418,6 @@
             <a:prstDash val="solid"/>
           </a:ln>
         </p:spPr>
-        <p:txBody>
-          <a:bodyPr/>
-          <a:lstStyle/>
-          <a:p>
-            <a:endParaRPr lang="fr-CA"/>
-          </a:p>
-        </p:txBody>
       </p:sp>
       <p:sp>
         <p:nvSpPr>
@@ -4444,7 +4440,7 @@
           <a:bodyPr wrap="square" lIns="0" tIns="0" rIns="0" bIns="0" rtlCol="0" anchor="ctr"/>
           <a:lstStyle/>
           <a:p>
-            <a:pPr marL="0" indent="0" algn="ctr">
+            <a:pPr algn="ctr" indent="0" marL="0">
               <a:buNone/>
             </a:pPr>
             <a:r>
@@ -4483,7 +4479,7 @@
           <a:bodyPr wrap="square" lIns="0" tIns="0" rIns="0" bIns="0" rtlCol="0" anchor="ctr"/>
           <a:lstStyle/>
           <a:p>
-            <a:pPr marL="0" indent="0">
+            <a:pPr indent="0" marL="0">
               <a:buNone/>
             </a:pPr>
             <a:r>
@@ -4525,13 +4521,6 @@
             <a:prstDash val="solid"/>
           </a:ln>
         </p:spPr>
-        <p:txBody>
-          <a:bodyPr/>
-          <a:lstStyle/>
-          <a:p>
-            <a:endParaRPr lang="fr-CA"/>
-          </a:p>
-        </p:txBody>
       </p:sp>
       <p:sp>
         <p:nvSpPr>
@@ -4554,7 +4543,7 @@
           <a:bodyPr wrap="square" lIns="0" tIns="0" rIns="0" bIns="0" rtlCol="0" anchor="ctr"/>
           <a:lstStyle/>
           <a:p>
-            <a:pPr marL="0" indent="0" algn="ctr">
+            <a:pPr algn="ctr" indent="0" marL="0">
               <a:buNone/>
             </a:pPr>
             <a:r>
@@ -4593,7 +4582,7 @@
           <a:bodyPr wrap="square" lIns="0" tIns="0" rIns="0" bIns="0" rtlCol="0" anchor="ctr"/>
           <a:lstStyle/>
           <a:p>
-            <a:pPr marL="0" indent="0">
+            <a:pPr indent="0" marL="0">
               <a:buNone/>
             </a:pPr>
             <a:r>
@@ -4635,13 +4624,6 @@
             <a:prstDash val="solid"/>
           </a:ln>
         </p:spPr>
-        <p:txBody>
-          <a:bodyPr/>
-          <a:lstStyle/>
-          <a:p>
-            <a:endParaRPr lang="fr-CA"/>
-          </a:p>
-        </p:txBody>
       </p:sp>
       <p:sp>
         <p:nvSpPr>
@@ -4664,7 +4646,7 @@
           <a:bodyPr wrap="square" lIns="0" tIns="0" rIns="0" bIns="0" rtlCol="0" anchor="ctr"/>
           <a:lstStyle/>
           <a:p>
-            <a:pPr marL="0" indent="0" algn="ctr">
+            <a:pPr algn="ctr" indent="0" marL="0">
               <a:buNone/>
             </a:pPr>
             <a:r>
@@ -4703,7 +4685,7 @@
           <a:bodyPr wrap="square" lIns="0" tIns="0" rIns="0" bIns="0" rtlCol="0" anchor="ctr"/>
           <a:lstStyle/>
           <a:p>
-            <a:pPr marL="0" indent="0">
+            <a:pPr indent="0" marL="0">
               <a:buNone/>
             </a:pPr>
             <a:r>
@@ -4745,13 +4727,6 @@
             <a:prstDash val="solid"/>
           </a:ln>
         </p:spPr>
-        <p:txBody>
-          <a:bodyPr/>
-          <a:lstStyle/>
-          <a:p>
-            <a:endParaRPr lang="fr-CA"/>
-          </a:p>
-        </p:txBody>
       </p:sp>
       <p:sp>
         <p:nvSpPr>
@@ -4774,7 +4749,7 @@
           <a:bodyPr wrap="square" lIns="0" tIns="0" rIns="0" bIns="0" rtlCol="0" anchor="ctr"/>
           <a:lstStyle/>
           <a:p>
-            <a:pPr marL="0" indent="0" algn="ctr">
+            <a:pPr algn="ctr" indent="0" marL="0">
               <a:buNone/>
             </a:pPr>
             <a:r>
@@ -4813,7 +4788,7 @@
           <a:bodyPr wrap="square" lIns="0" tIns="0" rIns="0" bIns="0" rtlCol="0" anchor="ctr"/>
           <a:lstStyle/>
           <a:p>
-            <a:pPr marL="0" indent="0">
+            <a:pPr indent="0" marL="0">
               <a:buNone/>
             </a:pPr>
             <a:r>
@@ -4847,7 +4822,6 @@
         <a:solidFill>
           <a:srgbClr val="0D0B0A"/>
         </a:solidFill>
-        <a:effectLst/>
       </p:bgPr>
     </p:bg>
     <p:spTree>
@@ -4885,11 +4859,11 @@
           <a:bodyPr wrap="square" lIns="0" tIns="0" rIns="0" bIns="0" rtlCol="0" anchor="t"/>
           <a:lstStyle/>
           <a:p>
-            <a:pPr marL="0" indent="0">
-              <a:buNone/>
-            </a:pPr>
-            <a:r>
-              <a:rPr lang="en-US" sz="1300" b="1" kern="0" spc="300" dirty="0">
+            <a:pPr indent="0" marL="0">
+              <a:buNone/>
+            </a:pPr>
+            <a:r>
+              <a:rPr lang="en-US" sz="1300" b="1" spc="300" kern="0" dirty="0">
                 <a:solidFill>
                   <a:srgbClr val="E8742A"/>
                 </a:solidFill>
@@ -4924,7 +4898,7 @@
           <a:bodyPr wrap="square" lIns="0" tIns="0" rIns="0" bIns="0" rtlCol="0" anchor="t"/>
           <a:lstStyle/>
           <a:p>
-            <a:pPr marL="0" indent="0">
+            <a:pPr indent="0" marL="0">
               <a:buNone/>
             </a:pPr>
             <a:r>
@@ -4963,7 +4937,7 @@
           <a:bodyPr wrap="square" lIns="0" tIns="0" rIns="0" bIns="0" rtlCol="0" anchor="t"/>
           <a:lstStyle/>
           <a:p>
-            <a:pPr marL="0" indent="0">
+            <a:pPr indent="0" marL="0">
               <a:buNone/>
             </a:pPr>
             <a:r>
@@ -5002,7 +4976,7 @@
           <a:bodyPr wrap="square" lIns="0" tIns="0" rIns="0" bIns="0" rtlCol="0" anchor="t"/>
           <a:lstStyle/>
           <a:p>
-            <a:pPr marL="0" indent="0" algn="ctr">
+            <a:pPr algn="ctr" indent="0" marL="0">
               <a:buNone/>
             </a:pPr>
             <a:r>
@@ -5041,7 +5015,7 @@
           <a:bodyPr wrap="square" lIns="0" tIns="0" rIns="0" bIns="0" rtlCol="0" anchor="t"/>
           <a:lstStyle/>
           <a:p>
-            <a:pPr marL="0" indent="0" algn="ctr">
+            <a:pPr algn="ctr" indent="0" marL="0">
               <a:buNone/>
             </a:pPr>
             <a:r>
@@ -5080,7 +5054,7 @@
           <a:bodyPr wrap="square" lIns="0" tIns="0" rIns="0" bIns="0" rtlCol="0" anchor="t"/>
           <a:lstStyle/>
           <a:p>
-            <a:pPr marL="0" indent="0" algn="ctr">
+            <a:pPr algn="ctr" indent="0" marL="0">
               <a:buNone/>
             </a:pPr>
             <a:r>
@@ -5119,7 +5093,7 @@
           <a:bodyPr wrap="square" lIns="0" tIns="0" rIns="0" bIns="0" rtlCol="0" anchor="t"/>
           <a:lstStyle/>
           <a:p>
-            <a:pPr marL="0" indent="0" algn="ctr">
+            <a:pPr algn="ctr" indent="0" marL="0">
               <a:buNone/>
             </a:pPr>
             <a:r>
@@ -5158,7 +5132,7 @@
           <a:bodyPr wrap="square" lIns="0" tIns="0" rIns="0" bIns="0" rtlCol="0" anchor="t"/>
           <a:lstStyle/>
           <a:p>
-            <a:pPr marL="0" indent="0" algn="ctr">
+            <a:pPr algn="ctr" indent="0" marL="0">
               <a:buNone/>
             </a:pPr>
             <a:r>
@@ -5197,7 +5171,7 @@
           <a:bodyPr wrap="square" lIns="0" tIns="0" rIns="0" bIns="0" rtlCol="0" anchor="t"/>
           <a:lstStyle/>
           <a:p>
-            <a:pPr marL="0" indent="0" algn="ctr">
+            <a:pPr algn="ctr" indent="0" marL="0">
               <a:buNone/>
             </a:pPr>
             <a:r>
@@ -5217,14 +5191,14 @@
       </p:sp>
       <p:pic>
         <p:nvPicPr>
-          <p:cNvPr id="11" name="Image 0" descr="Père, Fils et Esprit en communion : un seul Dieu"/>
+          <p:cNvPr id="11" name="Image 0" descr="Père, Fils et Esprit en communion : un seul Dieu">    </p:cNvPr>
           <p:cNvPicPr>
             <a:picLocks noChangeAspect="1"/>
           </p:cNvPicPr>
           <p:nvPr/>
         </p:nvPicPr>
         <p:blipFill>
-          <a:blip r:embed="rId3"/>
+          <a:blip r:embed="rId1"/>
           <a:stretch>
             <a:fillRect/>
           </a:stretch>
@@ -5248,19 +5222,19 @@
         <p:spPr>
           <a:xfrm>
             <a:off x="548640" y="5440680"/>
-            <a:ext cx="3840480" cy="1066800"/>
-          </a:xfrm>
-          <a:prstGeom prst="rect">
-            <a:avLst/>
-          </a:prstGeom>
-          <a:noFill/>
-          <a:ln/>
-        </p:spPr>
-        <p:txBody>
-          <a:bodyPr wrap="square" lIns="0" tIns="0" rIns="0" bIns="0" rtlCol="0" anchor="t"/>
-          <a:lstStyle/>
-          <a:p>
-            <a:pPr marL="0" indent="0">
+            <a:ext cx="3840480" cy="868680"/>
+          </a:xfrm>
+          <a:prstGeom prst="rect">
+            <a:avLst/>
+          </a:prstGeom>
+          <a:noFill/>
+          <a:ln/>
+        </p:spPr>
+        <p:txBody>
+          <a:bodyPr wrap="square" lIns="0" tIns="0" rIns="0" bIns="0" rtlCol="0" anchor="t"/>
+          <a:lstStyle/>
+          <a:p>
+            <a:pPr indent="0" marL="0">
               <a:buNone/>
             </a:pPr>
             <a:r>
@@ -5274,6 +5248,9 @@
               </a:rPr>
               <a:t>« Faisons » (Périchorèse) : </a:t>
             </a:r>
+            <a:pPr indent="0" marL="0">
+              <a:buNone/>
+            </a:pPr>
             <a:r>
               <a:rPr lang="en-US" sz="1600" dirty="0">
                 <a:solidFill>
@@ -5310,7 +5287,7 @@
           <a:bodyPr wrap="square" lIns="0" tIns="0" rIns="0" bIns="0" rtlCol="0" anchor="t"/>
           <a:lstStyle/>
           <a:p>
-            <a:pPr marL="0" indent="0">
+            <a:pPr indent="0" marL="0">
               <a:buNone/>
             </a:pPr>
             <a:r>
@@ -5324,6 +5301,9 @@
               </a:rPr>
               <a:t>Ce qu'est l'image  </a:t>
             </a:r>
+            <a:pPr indent="0" marL="0">
+              <a:buNone/>
+            </a:pPr>
             <a:r>
               <a:rPr lang="en-US" sz="1600" i="1" dirty="0">
                 <a:solidFill>
@@ -5365,13 +5345,6 @@
             <a:prstDash val="solid"/>
           </a:ln>
         </p:spPr>
-        <p:txBody>
-          <a:bodyPr/>
-          <a:lstStyle/>
-          <a:p>
-            <a:endParaRPr lang="fr-CA"/>
-          </a:p>
-        </p:txBody>
       </p:sp>
       <p:sp>
         <p:nvSpPr>
@@ -5397,24 +5370,17 @@
             <a:prstDash val="solid"/>
           </a:ln>
         </p:spPr>
-        <p:txBody>
-          <a:bodyPr/>
-          <a:lstStyle/>
-          <a:p>
-            <a:endParaRPr lang="fr-CA"/>
-          </a:p>
-        </p:txBody>
       </p:sp>
       <p:pic>
         <p:nvPicPr>
-          <p:cNvPr id="16" name="Image 1" descr="cerveau"/>
+          <p:cNvPr id="16" name="Image 1" descr="cerveau">    </p:cNvPr>
           <p:cNvPicPr>
             <a:picLocks noChangeAspect="1"/>
           </p:cNvPicPr>
           <p:nvPr/>
         </p:nvPicPr>
         <p:blipFill>
-          <a:blip r:embed="rId4"/>
+          <a:blip r:embed="rId2"/>
           <a:stretch>
             <a:fillRect/>
           </a:stretch>
@@ -5450,7 +5416,7 @@
           <a:bodyPr wrap="square" lIns="0" tIns="0" rIns="0" bIns="0" rtlCol="0" anchor="t"/>
           <a:lstStyle/>
           <a:p>
-            <a:pPr marL="0" indent="0">
+            <a:pPr indent="0" marL="0">
               <a:buNone/>
             </a:pPr>
             <a:r>
@@ -5489,7 +5455,7 @@
           <a:bodyPr wrap="square" lIns="0" tIns="0" rIns="0" bIns="0" rtlCol="0" anchor="t"/>
           <a:lstStyle/>
           <a:p>
-            <a:pPr marL="0" indent="0">
+            <a:pPr indent="0" marL="0">
               <a:buNone/>
             </a:pPr>
             <a:r>
@@ -5533,13 +5499,6 @@
             <a:prstDash val="solid"/>
           </a:ln>
         </p:spPr>
-        <p:txBody>
-          <a:bodyPr/>
-          <a:lstStyle/>
-          <a:p>
-            <a:endParaRPr lang="fr-CA"/>
-          </a:p>
-        </p:txBody>
       </p:sp>
       <p:sp>
         <p:nvSpPr>
@@ -5565,24 +5524,17 @@
             <a:prstDash val="solid"/>
           </a:ln>
         </p:spPr>
-        <p:txBody>
-          <a:bodyPr/>
-          <a:lstStyle/>
-          <a:p>
-            <a:endParaRPr lang="fr-CA"/>
-          </a:p>
-        </p:txBody>
       </p:sp>
       <p:pic>
         <p:nvPicPr>
-          <p:cNvPr id="21" name="Image 2" descr="balance"/>
+          <p:cNvPr id="21" name="Image 2" descr="balance">    </p:cNvPr>
           <p:cNvPicPr>
             <a:picLocks noChangeAspect="1"/>
           </p:cNvPicPr>
           <p:nvPr/>
         </p:nvPicPr>
         <p:blipFill>
-          <a:blip r:embed="rId5"/>
+          <a:blip r:embed="rId3"/>
           <a:stretch>
             <a:fillRect/>
           </a:stretch>
@@ -5618,7 +5570,7 @@
           <a:bodyPr wrap="square" lIns="0" tIns="0" rIns="0" bIns="0" rtlCol="0" anchor="t"/>
           <a:lstStyle/>
           <a:p>
-            <a:pPr marL="0" indent="0">
+            <a:pPr indent="0" marL="0">
               <a:buNone/>
             </a:pPr>
             <a:r>
@@ -5657,7 +5609,7 @@
           <a:bodyPr wrap="square" lIns="0" tIns="0" rIns="0" bIns="0" rtlCol="0" anchor="t"/>
           <a:lstStyle/>
           <a:p>
-            <a:pPr marL="0" indent="0">
+            <a:pPr indent="0" marL="0">
               <a:buNone/>
             </a:pPr>
             <a:r>
@@ -5701,13 +5653,6 @@
             <a:prstDash val="solid"/>
           </a:ln>
         </p:spPr>
-        <p:txBody>
-          <a:bodyPr/>
-          <a:lstStyle/>
-          <a:p>
-            <a:endParaRPr lang="fr-CA"/>
-          </a:p>
-        </p:txBody>
       </p:sp>
       <p:sp>
         <p:nvSpPr>
@@ -5733,24 +5678,17 @@
             <a:prstDash val="solid"/>
           </a:ln>
         </p:spPr>
-        <p:txBody>
-          <a:bodyPr/>
-          <a:lstStyle/>
-          <a:p>
-            <a:endParaRPr lang="fr-CA"/>
-          </a:p>
-        </p:txBody>
       </p:sp>
       <p:pic>
         <p:nvPicPr>
-          <p:cNvPr id="26" name="Image 3" descr="relation"/>
+          <p:cNvPr id="26" name="Image 3" descr="relation">    </p:cNvPr>
           <p:cNvPicPr>
             <a:picLocks noChangeAspect="1"/>
           </p:cNvPicPr>
           <p:nvPr/>
         </p:nvPicPr>
         <p:blipFill>
-          <a:blip r:embed="rId6"/>
+          <a:blip r:embed="rId4"/>
           <a:stretch>
             <a:fillRect/>
           </a:stretch>
@@ -5786,7 +5724,7 @@
           <a:bodyPr wrap="square" lIns="0" tIns="0" rIns="0" bIns="0" rtlCol="0" anchor="t"/>
           <a:lstStyle/>
           <a:p>
-            <a:pPr marL="0" indent="0">
+            <a:pPr indent="0" marL="0">
               <a:buNone/>
             </a:pPr>
             <a:r>
@@ -5825,7 +5763,7 @@
           <a:bodyPr wrap="square" lIns="0" tIns="0" rIns="0" bIns="0" rtlCol="0" anchor="t"/>
           <a:lstStyle/>
           <a:p>
-            <a:pPr marL="0" indent="0">
+            <a:pPr indent="0" marL="0">
               <a:buNone/>
             </a:pPr>
             <a:r>
@@ -5864,7 +5802,7 @@
           <a:bodyPr wrap="square" lIns="0" tIns="0" rIns="0" bIns="0" rtlCol="0" anchor="t"/>
           <a:lstStyle/>
           <a:p>
-            <a:pPr marL="0" indent="0">
+            <a:pPr indent="0" marL="0">
               <a:buNone/>
             </a:pPr>
             <a:r>
@@ -5906,24 +5844,17 @@
             <a:prstDash val="solid"/>
           </a:ln>
         </p:spPr>
-        <p:txBody>
-          <a:bodyPr/>
-          <a:lstStyle/>
-          <a:p>
-            <a:endParaRPr lang="fr-CA"/>
-          </a:p>
-        </p:txBody>
       </p:sp>
       <p:pic>
         <p:nvPicPr>
-          <p:cNvPr id="31" name="Image 4" descr="couronne"/>
+          <p:cNvPr id="31" name="Image 4" descr="couronne">    </p:cNvPr>
           <p:cNvPicPr>
             <a:picLocks noChangeAspect="1"/>
           </p:cNvPicPr>
           <p:nvPr/>
         </p:nvPicPr>
         <p:blipFill>
-          <a:blip r:embed="rId7"/>
+          <a:blip r:embed="rId5"/>
           <a:stretch>
             <a:fillRect/>
           </a:stretch>
@@ -5959,7 +5890,7 @@
           <a:bodyPr wrap="square" lIns="0" tIns="0" rIns="0" bIns="0" rtlCol="0" anchor="t"/>
           <a:lstStyle/>
           <a:p>
-            <a:pPr marL="0" indent="0">
+            <a:pPr indent="0" marL="0">
               <a:buNone/>
             </a:pPr>
             <a:r>
@@ -6001,24 +5932,17 @@
             <a:prstDash val="solid"/>
           </a:ln>
         </p:spPr>
-        <p:txBody>
-          <a:bodyPr/>
-          <a:lstStyle/>
-          <a:p>
-            <a:endParaRPr lang="fr-CA"/>
-          </a:p>
-        </p:txBody>
       </p:sp>
       <p:pic>
         <p:nvPicPr>
-          <p:cNvPr id="34" name="Image 5" descr="couple"/>
+          <p:cNvPr id="34" name="Image 5" descr="couple">    </p:cNvPr>
           <p:cNvPicPr>
             <a:picLocks noChangeAspect="1"/>
           </p:cNvPicPr>
           <p:nvPr/>
         </p:nvPicPr>
         <p:blipFill>
-          <a:blip r:embed="rId8"/>
+          <a:blip r:embed="rId6"/>
           <a:stretch>
             <a:fillRect/>
           </a:stretch>
@@ -6054,7 +5978,7 @@
           <a:bodyPr wrap="square" lIns="0" tIns="0" rIns="0" bIns="0" rtlCol="0" anchor="t"/>
           <a:lstStyle/>
           <a:p>
-            <a:pPr marL="0" indent="0">
+            <a:pPr indent="0" marL="0">
               <a:buNone/>
             </a:pPr>
             <a:r>
@@ -6096,24 +6020,17 @@
             <a:prstDash val="solid"/>
           </a:ln>
         </p:spPr>
-        <p:txBody>
-          <a:bodyPr/>
-          <a:lstStyle/>
-          <a:p>
-            <a:endParaRPr lang="fr-CA"/>
-          </a:p>
-        </p:txBody>
       </p:sp>
       <p:pic>
         <p:nvPicPr>
-          <p:cNvPr id="37" name="Image 6" descr="enfant"/>
+          <p:cNvPr id="37" name="Image 6" descr="enfant">    </p:cNvPr>
           <p:cNvPicPr>
             <a:picLocks noChangeAspect="1"/>
           </p:cNvPicPr>
           <p:nvPr/>
         </p:nvPicPr>
         <p:blipFill>
-          <a:blip r:embed="rId9"/>
+          <a:blip r:embed="rId7"/>
           <a:stretch>
             <a:fillRect/>
           </a:stretch>
@@ -6149,7 +6066,7 @@
           <a:bodyPr wrap="square" lIns="0" tIns="0" rIns="0" bIns="0" rtlCol="0" anchor="t"/>
           <a:lstStyle/>
           <a:p>
-            <a:pPr marL="0" indent="0">
+            <a:pPr indent="0" marL="0">
               <a:buNone/>
             </a:pPr>
             <a:r>
@@ -6183,7 +6100,6 @@
         <a:solidFill>
           <a:srgbClr val="0D0B0A"/>
         </a:solidFill>
-        <a:effectLst/>
       </p:bgPr>
     </p:bg>
     <p:spTree>
@@ -6221,11 +6137,11 @@
           <a:bodyPr wrap="square" lIns="0" tIns="0" rIns="0" bIns="0" rtlCol="0" anchor="t"/>
           <a:lstStyle/>
           <a:p>
-            <a:pPr marL="0" indent="0">
-              <a:buNone/>
-            </a:pPr>
-            <a:r>
-              <a:rPr lang="en-US" sz="1300" b="1" kern="0" spc="300" dirty="0">
+            <a:pPr indent="0" marL="0">
+              <a:buNone/>
+            </a:pPr>
+            <a:r>
+              <a:rPr lang="en-US" sz="1300" b="1" spc="300" kern="0" dirty="0">
                 <a:solidFill>
                   <a:srgbClr val="E8742A"/>
                 </a:solidFill>
@@ -6260,7 +6176,7 @@
           <a:bodyPr wrap="square" lIns="0" tIns="0" rIns="0" bIns="0" rtlCol="0" anchor="t"/>
           <a:lstStyle/>
           <a:p>
-            <a:pPr marL="0" indent="0">
+            <a:pPr indent="0" marL="0">
               <a:buNone/>
             </a:pPr>
             <a:r>
@@ -6299,7 +6215,7 @@
           <a:bodyPr wrap="square" lIns="0" tIns="0" rIns="0" bIns="0" rtlCol="0" anchor="t"/>
           <a:lstStyle/>
           <a:p>
-            <a:pPr marL="0" indent="0">
+            <a:pPr indent="0" marL="0">
               <a:buNone/>
             </a:pPr>
             <a:r>
@@ -6313,6 +6229,9 @@
               </a:rPr>
               <a:t>Christ est ce que l'homme n'est plus. </a:t>
             </a:r>
+            <a:pPr indent="0" marL="0">
+              <a:buNone/>
+            </a:pPr>
             <a:r>
               <a:rPr lang="en-US" sz="1900" i="1" dirty="0">
                 <a:solidFill>
@@ -6349,7 +6268,7 @@
           <a:bodyPr wrap="square" lIns="0" tIns="0" rIns="0" bIns="0" rtlCol="0" anchor="t"/>
           <a:lstStyle/>
           <a:p>
-            <a:pPr marL="0" indent="0" algn="ctr">
+            <a:pPr algn="ctr" indent="0" marL="0">
               <a:buNone/>
             </a:pPr>
             <a:r>
@@ -6388,7 +6307,7 @@
           <a:bodyPr wrap="square" lIns="0" tIns="0" rIns="0" bIns="0" rtlCol="0" anchor="t"/>
           <a:lstStyle/>
           <a:p>
-            <a:pPr marL="0" indent="0" algn="ctr">
+            <a:pPr algn="ctr" indent="0" marL="0">
               <a:buNone/>
             </a:pPr>
             <a:r>
@@ -6427,7 +6346,7 @@
           <a:bodyPr wrap="square" lIns="0" tIns="0" rIns="0" bIns="0" rtlCol="0" anchor="t"/>
           <a:lstStyle/>
           <a:p>
-            <a:pPr marL="0" indent="0" algn="ctr">
+            <a:pPr algn="ctr" indent="0" marL="0">
               <a:buNone/>
             </a:pPr>
             <a:r>
@@ -6466,7 +6385,7 @@
           <a:bodyPr wrap="square" lIns="0" tIns="0" rIns="0" bIns="0" rtlCol="0" anchor="t"/>
           <a:lstStyle/>
           <a:p>
-            <a:pPr marL="0" indent="0" algn="ctr">
+            <a:pPr algn="ctr" indent="0" marL="0">
               <a:buNone/>
             </a:pPr>
             <a:r>
@@ -6505,7 +6424,7 @@
           <a:bodyPr wrap="square" lIns="0" tIns="0" rIns="0" bIns="0" rtlCol="0" anchor="t"/>
           <a:lstStyle/>
           <a:p>
-            <a:pPr marL="0" indent="0" algn="ctr">
+            <a:pPr algn="ctr" indent="0" marL="0">
               <a:buNone/>
             </a:pPr>
             <a:r>
@@ -6544,7 +6463,7 @@
           <a:bodyPr wrap="square" lIns="0" tIns="0" rIns="0" bIns="0" rtlCol="0" anchor="t"/>
           <a:lstStyle/>
           <a:p>
-            <a:pPr marL="0" indent="0" algn="ctr">
+            <a:pPr algn="ctr" indent="0" marL="0">
               <a:buNone/>
             </a:pPr>
             <a:r>
@@ -6564,14 +6483,14 @@
       </p:sp>
       <p:pic>
         <p:nvPicPr>
-          <p:cNvPr id="11" name="Image 0" descr="Une pièce à l'effigie humaine, fêlée et ternie"/>
+          <p:cNvPr id="11" name="Image 0" descr="Une pièce à l'effigie humaine, fêlée et ternie">    </p:cNvPr>
           <p:cNvPicPr>
             <a:picLocks noChangeAspect="1"/>
           </p:cNvPicPr>
           <p:nvPr/>
         </p:nvPicPr>
         <p:blipFill>
-          <a:blip r:embed="rId3"/>
+          <a:blip r:embed="rId1"/>
           <a:stretch>
             <a:fillRect/>
           </a:stretch>
@@ -6588,14 +6507,14 @@
       </p:pic>
       <p:pic>
         <p:nvPicPr>
-          <p:cNvPr id="12" name="Image 1" descr="Une couronne rayonnante : Christ, l'image parfaite"/>
+          <p:cNvPr id="12" name="Image 1" descr="Une couronne rayonnante : Christ, l'image parfaite">    </p:cNvPr>
           <p:cNvPicPr>
             <a:picLocks noChangeAspect="1"/>
           </p:cNvPicPr>
           <p:nvPr/>
         </p:nvPicPr>
         <p:blipFill>
-          <a:blip r:embed="rId4"/>
+          <a:blip r:embed="rId2"/>
           <a:stretch>
             <a:fillRect/>
           </a:stretch>
@@ -6633,13 +6552,6 @@
             <a:tailEnd type="triangle"/>
           </a:ln>
         </p:spPr>
-        <p:txBody>
-          <a:bodyPr/>
-          <a:lstStyle/>
-          <a:p>
-            <a:endParaRPr lang="fr-CA"/>
-          </a:p>
-        </p:txBody>
       </p:sp>
       <p:sp>
         <p:nvSpPr>
@@ -6662,7 +6574,7 @@
           <a:bodyPr wrap="square" lIns="0" tIns="0" rIns="0" bIns="0" rtlCol="0" anchor="t"/>
           <a:lstStyle/>
           <a:p>
-            <a:pPr marL="0" indent="0" algn="ctr">
+            <a:pPr algn="ctr" indent="0" marL="0">
               <a:buNone/>
             </a:pPr>
             <a:r>
@@ -6701,7 +6613,7 @@
           <a:bodyPr wrap="square" lIns="0" tIns="0" rIns="0" bIns="0" rtlCol="0" anchor="t"/>
           <a:lstStyle/>
           <a:p>
-            <a:pPr marL="0" indent="0" algn="ctr">
+            <a:pPr algn="ctr" indent="0" marL="0">
               <a:spcAft>
                 <a:spcPts val="300"/>
               </a:spcAft>
@@ -6721,7 +6633,7 @@
             <a:endParaRPr lang="en-US" sz="1600" dirty="0"/>
           </a:p>
           <a:p>
-            <a:pPr marL="0" indent="0" algn="ctr">
+            <a:pPr algn="ctr" indent="0" marL="0">
               <a:spcAft>
                 <a:spcPts val="300"/>
               </a:spcAft>
@@ -6741,7 +6653,7 @@
             <a:endParaRPr lang="en-US" sz="1600" dirty="0"/>
           </a:p>
           <a:p>
-            <a:pPr marL="0" indent="0" algn="ctr">
+            <a:pPr algn="ctr" indent="0" marL="0">
               <a:spcAft>
                 <a:spcPts val="300"/>
               </a:spcAft>
@@ -6783,7 +6695,7 @@
           <a:bodyPr wrap="square" lIns="0" tIns="0" rIns="0" bIns="0" rtlCol="0" anchor="t"/>
           <a:lstStyle/>
           <a:p>
-            <a:pPr marL="0" indent="0" algn="ctr">
+            <a:pPr algn="ctr" indent="0" marL="0">
               <a:spcAft>
                 <a:spcPts val="300"/>
               </a:spcAft>
@@ -6803,7 +6715,7 @@
             <a:endParaRPr lang="en-US" sz="1600" dirty="0"/>
           </a:p>
           <a:p>
-            <a:pPr marL="0" indent="0" algn="ctr">
+            <a:pPr algn="ctr" indent="0" marL="0">
               <a:spcAft>
                 <a:spcPts val="300"/>
               </a:spcAft>
@@ -6823,7 +6735,7 @@
             <a:endParaRPr lang="en-US" sz="1600" dirty="0"/>
           </a:p>
           <a:p>
-            <a:pPr marL="0" indent="0" algn="ctr">
+            <a:pPr algn="ctr" indent="0" marL="0">
               <a:spcAft>
                 <a:spcPts val="300"/>
               </a:spcAft>
@@ -6870,13 +6782,6 @@
             <a:prstDash val="solid"/>
           </a:ln>
         </p:spPr>
-        <p:txBody>
-          <a:bodyPr/>
-          <a:lstStyle/>
-          <a:p>
-            <a:endParaRPr lang="fr-CA"/>
-          </a:p>
-        </p:txBody>
       </p:sp>
       <p:sp>
         <p:nvSpPr>
@@ -6899,7 +6804,7 @@
           <a:bodyPr wrap="square" lIns="0" tIns="0" rIns="0" bIns="0" rtlCol="0" anchor="ctr"/>
           <a:lstStyle/>
           <a:p>
-            <a:pPr marL="0" indent="0" algn="ctr">
+            <a:pPr algn="ctr" indent="0" marL="0">
               <a:buNone/>
             </a:pPr>
             <a:r>
@@ -6913,6 +6818,9 @@
               </a:rPr>
               <a:t>tselem</a:t>
             </a:r>
+            <a:pPr algn="ctr" indent="0" marL="0">
+              <a:buNone/>
+            </a:pPr>
             <a:r>
               <a:rPr lang="en-US" sz="1400" dirty="0">
                 <a:solidFill>
@@ -6951,13 +6859,6 @@
             <a:tailEnd type="triangle"/>
           </a:ln>
         </p:spPr>
-        <p:txBody>
-          <a:bodyPr/>
-          <a:lstStyle/>
-          <a:p>
-            <a:endParaRPr lang="fr-CA"/>
-          </a:p>
-        </p:txBody>
       </p:sp>
       <p:sp>
         <p:nvSpPr>
@@ -6985,13 +6886,6 @@
             <a:prstDash val="solid"/>
           </a:ln>
         </p:spPr>
-        <p:txBody>
-          <a:bodyPr/>
-          <a:lstStyle/>
-          <a:p>
-            <a:endParaRPr lang="fr-CA"/>
-          </a:p>
-        </p:txBody>
       </p:sp>
       <p:sp>
         <p:nvSpPr>
@@ -7014,7 +6908,7 @@
           <a:bodyPr wrap="square" lIns="0" tIns="0" rIns="0" bIns="0" rtlCol="0" anchor="ctr"/>
           <a:lstStyle/>
           <a:p>
-            <a:pPr marL="0" indent="0" algn="ctr">
+            <a:pPr algn="ctr" indent="0" marL="0">
               <a:buNone/>
             </a:pPr>
             <a:r>
@@ -7028,6 +6922,9 @@
               </a:rPr>
               <a:t>eikôn</a:t>
             </a:r>
+            <a:pPr algn="ctr" indent="0" marL="0">
+              <a:buNone/>
+            </a:pPr>
             <a:r>
               <a:rPr lang="en-US" sz="1400" dirty="0">
                 <a:solidFill>
@@ -7066,13 +6963,6 @@
             <a:tailEnd type="triangle"/>
           </a:ln>
         </p:spPr>
-        <p:txBody>
-          <a:bodyPr/>
-          <a:lstStyle/>
-          <a:p>
-            <a:endParaRPr lang="fr-CA"/>
-          </a:p>
-        </p:txBody>
       </p:sp>
       <p:sp>
         <p:nvSpPr>
@@ -7100,13 +6990,6 @@
             <a:prstDash val="solid"/>
           </a:ln>
         </p:spPr>
-        <p:txBody>
-          <a:bodyPr/>
-          <a:lstStyle/>
-          <a:p>
-            <a:endParaRPr lang="fr-CA"/>
-          </a:p>
-        </p:txBody>
       </p:sp>
       <p:sp>
         <p:nvSpPr>
@@ -7129,7 +7012,7 @@
           <a:bodyPr wrap="square" lIns="0" tIns="0" rIns="0" bIns="0" rtlCol="0" anchor="ctr"/>
           <a:lstStyle/>
           <a:p>
-            <a:pPr marL="0" indent="0" algn="ctr">
+            <a:pPr algn="ctr" indent="0" marL="0">
               <a:buNone/>
             </a:pPr>
             <a:r>
@@ -7143,6 +7026,9 @@
               </a:rPr>
               <a:t>eikôn</a:t>
             </a:r>
+            <a:pPr algn="ctr" indent="0" marL="0">
+              <a:buNone/>
+            </a:pPr>
             <a:r>
               <a:rPr lang="en-US" sz="1400" dirty="0">
                 <a:solidFill>
@@ -7174,7 +7060,6 @@
         <a:solidFill>
           <a:srgbClr val="0D0B0A"/>
         </a:solidFill>
-        <a:effectLst/>
       </p:bgPr>
     </p:bg>
     <p:spTree>
@@ -7212,11 +7097,11 @@
           <a:bodyPr wrap="square" lIns="0" tIns="0" rIns="0" bIns="0" rtlCol="0" anchor="t"/>
           <a:lstStyle/>
           <a:p>
-            <a:pPr marL="0" indent="0">
-              <a:buNone/>
-            </a:pPr>
-            <a:r>
-              <a:rPr lang="en-US" sz="1300" b="1" kern="0" spc="300" dirty="0">
+            <a:pPr indent="0" marL="0">
+              <a:buNone/>
+            </a:pPr>
+            <a:r>
+              <a:rPr lang="en-US" sz="1300" b="1" spc="300" kern="0" dirty="0">
                 <a:solidFill>
                   <a:srgbClr val="E8742A"/>
                 </a:solidFill>
@@ -7251,7 +7136,7 @@
           <a:bodyPr wrap="square" lIns="0" tIns="0" rIns="0" bIns="0" rtlCol="0" anchor="t"/>
           <a:lstStyle/>
           <a:p>
-            <a:pPr marL="0" indent="0">
+            <a:pPr indent="0" marL="0">
               <a:buNone/>
             </a:pPr>
             <a:r>
@@ -7290,7 +7175,7 @@
           <a:bodyPr wrap="square" lIns="0" tIns="0" rIns="0" bIns="0" rtlCol="0" anchor="t"/>
           <a:lstStyle/>
           <a:p>
-            <a:pPr marL="0" indent="0">
+            <a:pPr indent="0" marL="0">
               <a:buNone/>
             </a:pPr>
             <a:r>
@@ -7329,7 +7214,7 @@
           <a:bodyPr wrap="square" lIns="0" tIns="0" rIns="0" bIns="0" rtlCol="0" anchor="t"/>
           <a:lstStyle/>
           <a:p>
-            <a:pPr marL="0" indent="0" algn="ctr">
+            <a:pPr algn="ctr" indent="0" marL="0">
               <a:buNone/>
             </a:pPr>
             <a:r>
@@ -7368,7 +7253,7 @@
           <a:bodyPr wrap="square" lIns="0" tIns="0" rIns="0" bIns="0" rtlCol="0" anchor="t"/>
           <a:lstStyle/>
           <a:p>
-            <a:pPr marL="0" indent="0" algn="ctr">
+            <a:pPr algn="ctr" indent="0" marL="0">
               <a:buNone/>
             </a:pPr>
             <a:r>
@@ -7407,7 +7292,7 @@
           <a:bodyPr wrap="square" lIns="0" tIns="0" rIns="0" bIns="0" rtlCol="0" anchor="t"/>
           <a:lstStyle/>
           <a:p>
-            <a:pPr marL="0" indent="0" algn="ctr">
+            <a:pPr algn="ctr" indent="0" marL="0">
               <a:buNone/>
             </a:pPr>
             <a:r>
@@ -7446,7 +7331,7 @@
           <a:bodyPr wrap="square" lIns="0" tIns="0" rIns="0" bIns="0" rtlCol="0" anchor="t"/>
           <a:lstStyle/>
           <a:p>
-            <a:pPr marL="0" indent="0" algn="ctr">
+            <a:pPr algn="ctr" indent="0" marL="0">
               <a:buNone/>
             </a:pPr>
             <a:r>
@@ -7485,7 +7370,7 @@
           <a:bodyPr wrap="square" lIns="0" tIns="0" rIns="0" bIns="0" rtlCol="0" anchor="t"/>
           <a:lstStyle/>
           <a:p>
-            <a:pPr marL="0" indent="0" algn="ctr">
+            <a:pPr algn="ctr" indent="0" marL="0">
               <a:buNone/>
             </a:pPr>
             <a:r>
@@ -7524,7 +7409,7 @@
           <a:bodyPr wrap="square" lIns="0" tIns="0" rIns="0" bIns="0" rtlCol="0" anchor="t"/>
           <a:lstStyle/>
           <a:p>
-            <a:pPr marL="0" indent="0" algn="ctr">
+            <a:pPr algn="ctr" indent="0" marL="0">
               <a:buNone/>
             </a:pPr>
             <a:r>
@@ -7570,13 +7455,6 @@
             <a:prstDash val="solid"/>
           </a:ln>
         </p:spPr>
-        <p:txBody>
-          <a:bodyPr/>
-          <a:lstStyle/>
-          <a:p>
-            <a:endParaRPr lang="fr-CA"/>
-          </a:p>
-        </p:txBody>
       </p:sp>
       <p:sp>
         <p:nvSpPr>
@@ -7599,7 +7477,7 @@
           <a:bodyPr wrap="square" lIns="0" tIns="0" rIns="0" bIns="0" rtlCol="0" anchor="ctr"/>
           <a:lstStyle/>
           <a:p>
-            <a:pPr marL="0" indent="0" algn="ctr">
+            <a:pPr algn="ctr" indent="0" marL="0">
               <a:buNone/>
             </a:pPr>
             <a:r>
@@ -7643,13 +7521,6 @@
             <a:prstDash val="solid"/>
           </a:ln>
         </p:spPr>
-        <p:txBody>
-          <a:bodyPr/>
-          <a:lstStyle/>
-          <a:p>
-            <a:endParaRPr lang="fr-CA"/>
-          </a:p>
-        </p:txBody>
       </p:sp>
       <p:sp>
         <p:nvSpPr>
@@ -7672,7 +7543,7 @@
           <a:bodyPr wrap="square" lIns="0" tIns="0" rIns="0" bIns="0" rtlCol="0" anchor="ctr"/>
           <a:lstStyle/>
           <a:p>
-            <a:pPr marL="0" indent="0" algn="ctr">
+            <a:pPr algn="ctr" indent="0" marL="0">
               <a:buNone/>
             </a:pPr>
             <a:r>
@@ -7718,13 +7589,6 @@
             <a:prstDash val="solid"/>
           </a:ln>
         </p:spPr>
-        <p:txBody>
-          <a:bodyPr/>
-          <a:lstStyle/>
-          <a:p>
-            <a:endParaRPr lang="fr-CA"/>
-          </a:p>
-        </p:txBody>
       </p:sp>
       <p:sp>
         <p:nvSpPr>
@@ -7747,7 +7611,7 @@
           <a:bodyPr wrap="square" lIns="0" tIns="0" rIns="0" bIns="0" rtlCol="0" anchor="ctr"/>
           <a:lstStyle/>
           <a:p>
-            <a:pPr marL="0" indent="0" algn="ctr">
+            <a:pPr algn="ctr" indent="0" marL="0">
               <a:buNone/>
             </a:pPr>
             <a:r>
@@ -7793,13 +7657,6 @@
             <a:prstDash val="solid"/>
           </a:ln>
         </p:spPr>
-        <p:txBody>
-          <a:bodyPr/>
-          <a:lstStyle/>
-          <a:p>
-            <a:endParaRPr lang="fr-CA"/>
-          </a:p>
-        </p:txBody>
       </p:sp>
       <p:sp>
         <p:nvSpPr>
@@ -7822,7 +7679,7 @@
           <a:bodyPr wrap="square" lIns="0" tIns="0" rIns="0" bIns="0" rtlCol="0" anchor="ctr"/>
           <a:lstStyle/>
           <a:p>
-            <a:pPr marL="0" indent="0" algn="ctr">
+            <a:pPr algn="ctr" indent="0" marL="0">
               <a:buNone/>
             </a:pPr>
             <a:r>
@@ -7868,13 +7725,6 @@
             <a:prstDash val="solid"/>
           </a:ln>
         </p:spPr>
-        <p:txBody>
-          <a:bodyPr/>
-          <a:lstStyle/>
-          <a:p>
-            <a:endParaRPr lang="fr-CA"/>
-          </a:p>
-        </p:txBody>
       </p:sp>
       <p:sp>
         <p:nvSpPr>
@@ -7897,7 +7747,7 @@
           <a:bodyPr wrap="square" lIns="0" tIns="0" rIns="0" bIns="0" rtlCol="0" anchor="ctr"/>
           <a:lstStyle/>
           <a:p>
-            <a:pPr marL="0" indent="0" algn="ctr">
+            <a:pPr algn="ctr" indent="0" marL="0">
               <a:buNone/>
             </a:pPr>
             <a:r>
@@ -7936,7 +7786,7 @@
           <a:bodyPr wrap="square" lIns="0" tIns="0" rIns="0" bIns="0" rtlCol="0" anchor="t"/>
           <a:lstStyle/>
           <a:p>
-            <a:pPr marL="0" indent="0" algn="ctr">
+            <a:pPr algn="ctr" indent="0" marL="0">
               <a:buNone/>
             </a:pPr>
             <a:r>
@@ -7956,14 +7806,14 @@
       </p:sp>
       <p:pic>
         <p:nvPicPr>
-          <p:cNvPr id="22" name="Image 0" descr="Le Fils couronné au centre, entouré de beaucoup de frères"/>
+          <p:cNvPr id="22" name="Image 0" descr="Le Fils couronné au centre, entouré de beaucoup de frères">    </p:cNvPr>
           <p:cNvPicPr>
             <a:picLocks noChangeAspect="1"/>
           </p:cNvPicPr>
           <p:nvPr/>
         </p:nvPicPr>
         <p:blipFill>
-          <a:blip r:embed="rId3"/>
+          <a:blip r:embed="rId1"/>
           <a:stretch>
             <a:fillRect/>
           </a:stretch>
@@ -8004,13 +7854,6 @@
             <a:prstDash val="solid"/>
           </a:ln>
         </p:spPr>
-        <p:txBody>
-          <a:bodyPr/>
-          <a:lstStyle/>
-          <a:p>
-            <a:endParaRPr lang="fr-CA"/>
-          </a:p>
-        </p:txBody>
       </p:sp>
       <p:sp>
         <p:nvSpPr>
@@ -8033,7 +7876,7 @@
           <a:bodyPr wrap="square" lIns="0" tIns="0" rIns="0" bIns="0" rtlCol="0" anchor="ctr"/>
           <a:lstStyle/>
           <a:p>
-            <a:pPr marL="0" indent="0">
+            <a:pPr indent="0" marL="0">
               <a:buNone/>
             </a:pPr>
             <a:r>
@@ -8050,7 +7893,7 @@
             <a:endParaRPr lang="en-US" sz="1700" dirty="0"/>
           </a:p>
           <a:p>
-            <a:pPr marL="0" indent="0">
+            <a:pPr indent="0" marL="0">
               <a:buNone/>
             </a:pPr>
             <a:r>
@@ -8094,13 +7937,6 @@
             <a:prstDash val="solid"/>
           </a:ln>
         </p:spPr>
-        <p:txBody>
-          <a:bodyPr/>
-          <a:lstStyle/>
-          <a:p>
-            <a:endParaRPr lang="fr-CA"/>
-          </a:p>
-        </p:txBody>
       </p:sp>
       <p:sp>
         <p:nvSpPr>
@@ -8123,7 +7959,7 @@
           <a:bodyPr wrap="square" lIns="0" tIns="0" rIns="0" bIns="0" rtlCol="0" anchor="ctr"/>
           <a:lstStyle/>
           <a:p>
-            <a:pPr marL="0" indent="0">
+            <a:pPr indent="0" marL="0">
               <a:buNone/>
             </a:pPr>
             <a:r>
@@ -8140,7 +7976,7 @@
             <a:endParaRPr lang="en-US" sz="1700" dirty="0"/>
           </a:p>
           <a:p>
-            <a:pPr marL="0" indent="0">
+            <a:pPr indent="0" marL="0">
               <a:buNone/>
             </a:pPr>
             <a:r>
@@ -8184,13 +8020,6 @@
             <a:prstDash val="solid"/>
           </a:ln>
         </p:spPr>
-        <p:txBody>
-          <a:bodyPr/>
-          <a:lstStyle/>
-          <a:p>
-            <a:endParaRPr lang="fr-CA"/>
-          </a:p>
-        </p:txBody>
       </p:sp>
       <p:sp>
         <p:nvSpPr>
@@ -8213,7 +8042,7 @@
           <a:bodyPr wrap="square" lIns="0" tIns="0" rIns="0" bIns="0" rtlCol="0" anchor="ctr"/>
           <a:lstStyle/>
           <a:p>
-            <a:pPr marL="0" indent="0">
+            <a:pPr indent="0" marL="0">
               <a:buNone/>
             </a:pPr>
             <a:r>
@@ -8230,7 +8059,7 @@
             <a:endParaRPr lang="en-US" sz="1700" dirty="0"/>
           </a:p>
           <a:p>
-            <a:pPr marL="0" indent="0">
+            <a:pPr indent="0" marL="0">
               <a:buNone/>
             </a:pPr>
             <a:r>
@@ -8264,7 +8093,6 @@
         <a:solidFill>
           <a:srgbClr val="0D0B0A"/>
         </a:solidFill>
-        <a:effectLst/>
       </p:bgPr>
     </p:bg>
     <p:spTree>
@@ -8302,11 +8130,11 @@
           <a:bodyPr wrap="square" lIns="0" tIns="0" rIns="0" bIns="0" rtlCol="0" anchor="t"/>
           <a:lstStyle/>
           <a:p>
-            <a:pPr marL="0" indent="0">
-              <a:buNone/>
-            </a:pPr>
-            <a:r>
-              <a:rPr lang="en-US" sz="1300" b="1" kern="0" spc="300" dirty="0">
+            <a:pPr indent="0" marL="0">
+              <a:buNone/>
+            </a:pPr>
+            <a:r>
+              <a:rPr lang="en-US" sz="1300" b="1" spc="300" kern="0" dirty="0">
                 <a:solidFill>
                   <a:srgbClr val="E8742A"/>
                 </a:solidFill>
@@ -8341,7 +8169,7 @@
           <a:bodyPr wrap="square" lIns="0" tIns="0" rIns="0" bIns="0" rtlCol="0" anchor="t"/>
           <a:lstStyle/>
           <a:p>
-            <a:pPr marL="0" indent="0">
+            <a:pPr indent="0" marL="0">
               <a:buNone/>
             </a:pPr>
             <a:r>
@@ -8380,7 +8208,7 @@
           <a:bodyPr wrap="square" lIns="0" tIns="0" rIns="0" bIns="0" rtlCol="0" anchor="t"/>
           <a:lstStyle/>
           <a:p>
-            <a:pPr marL="0" indent="0">
+            <a:pPr indent="0" marL="0">
               <a:buNone/>
             </a:pPr>
             <a:r>
@@ -8419,7 +8247,7 @@
           <a:bodyPr wrap="square" lIns="0" tIns="0" rIns="0" bIns="0" rtlCol="0" anchor="t"/>
           <a:lstStyle/>
           <a:p>
-            <a:pPr marL="0" indent="0" algn="ctr">
+            <a:pPr algn="ctr" indent="0" marL="0">
               <a:buNone/>
             </a:pPr>
             <a:r>
@@ -8458,7 +8286,7 @@
           <a:bodyPr wrap="square" lIns="0" tIns="0" rIns="0" bIns="0" rtlCol="0" anchor="t"/>
           <a:lstStyle/>
           <a:p>
-            <a:pPr marL="0" indent="0" algn="ctr">
+            <a:pPr algn="ctr" indent="0" marL="0">
               <a:buNone/>
             </a:pPr>
             <a:r>
@@ -8497,7 +8325,7 @@
           <a:bodyPr wrap="square" lIns="0" tIns="0" rIns="0" bIns="0" rtlCol="0" anchor="t"/>
           <a:lstStyle/>
           <a:p>
-            <a:pPr marL="0" indent="0" algn="ctr">
+            <a:pPr algn="ctr" indent="0" marL="0">
               <a:buNone/>
             </a:pPr>
             <a:r>
@@ -8536,7 +8364,7 @@
           <a:bodyPr wrap="square" lIns="0" tIns="0" rIns="0" bIns="0" rtlCol="0" anchor="t"/>
           <a:lstStyle/>
           <a:p>
-            <a:pPr marL="0" indent="0" algn="ctr">
+            <a:pPr algn="ctr" indent="0" marL="0">
               <a:buNone/>
             </a:pPr>
             <a:r>
@@ -8575,7 +8403,7 @@
           <a:bodyPr wrap="square" lIns="0" tIns="0" rIns="0" bIns="0" rtlCol="0" anchor="t"/>
           <a:lstStyle/>
           <a:p>
-            <a:pPr marL="0" indent="0" algn="ctr">
+            <a:pPr algn="ctr" indent="0" marL="0">
               <a:buNone/>
             </a:pPr>
             <a:r>
@@ -8614,7 +8442,7 @@
           <a:bodyPr wrap="square" lIns="0" tIns="0" rIns="0" bIns="0" rtlCol="0" anchor="t"/>
           <a:lstStyle/>
           <a:p>
-            <a:pPr marL="0" indent="0" algn="ctr">
+            <a:pPr algn="ctr" indent="0" marL="0">
               <a:buNone/>
             </a:pPr>
             <a:r>
@@ -8634,14 +8462,14 @@
       </p:sp>
       <p:pic>
         <p:nvPicPr>
-          <p:cNvPr id="11" name="Image 0" descr="Un miroir à main où brille un livre ouvert : l'Écriture"/>
+          <p:cNvPr id="11" name="Image 0" descr="Un miroir à main où brille un livre ouvert : l'Écriture">    </p:cNvPr>
           <p:cNvPicPr>
             <a:picLocks noChangeAspect="1"/>
           </p:cNvPicPr>
           <p:nvPr/>
         </p:nvPicPr>
         <p:blipFill>
-          <a:blip r:embed="rId3"/>
+          <a:blip r:embed="rId1"/>
           <a:stretch>
             <a:fillRect/>
           </a:stretch>
@@ -8677,7 +8505,7 @@
           <a:bodyPr wrap="square" lIns="0" tIns="0" rIns="0" bIns="0" rtlCol="0" anchor="t"/>
           <a:lstStyle/>
           <a:p>
-            <a:pPr marL="0" indent="0" algn="ctr">
+            <a:pPr algn="ctr" indent="0" marL="0">
               <a:buNone/>
             </a:pPr>
             <a:r>
@@ -8716,7 +8544,7 @@
           <a:bodyPr wrap="square" lIns="0" tIns="0" rIns="0" bIns="0" rtlCol="0" anchor="t"/>
           <a:lstStyle/>
           <a:p>
-            <a:pPr marL="0" indent="0">
+            <a:pPr indent="0" marL="0">
               <a:buNone/>
             </a:pPr>
             <a:r>
@@ -8733,7 +8561,7 @@
             <a:endParaRPr lang="en-US" sz="2100" dirty="0"/>
           </a:p>
           <a:p>
-            <a:pPr marL="0" indent="0">
+            <a:pPr indent="0" marL="0">
               <a:buNone/>
             </a:pPr>
             <a:r>
@@ -8777,13 +8605,6 @@
             <a:prstDash val="solid"/>
           </a:ln>
         </p:spPr>
-        <p:txBody>
-          <a:bodyPr/>
-          <a:lstStyle/>
-          <a:p>
-            <a:endParaRPr lang="fr-CA"/>
-          </a:p>
-        </p:txBody>
       </p:sp>
       <p:sp>
         <p:nvSpPr>
@@ -8809,24 +8630,17 @@
             <a:prstDash val="solid"/>
           </a:ln>
         </p:spPr>
-        <p:txBody>
-          <a:bodyPr/>
-          <a:lstStyle/>
-          <a:p>
-            <a:endParaRPr lang="fr-CA"/>
-          </a:p>
-        </p:txBody>
       </p:sp>
       <p:pic>
         <p:nvPicPr>
-          <p:cNvPr id="16" name="Image 1" descr="oeil"/>
+          <p:cNvPr id="16" name="Image 1" descr="oeil">    </p:cNvPr>
           <p:cNvPicPr>
             <a:picLocks noChangeAspect="1"/>
           </p:cNvPicPr>
           <p:nvPr/>
         </p:nvPicPr>
         <p:blipFill>
-          <a:blip r:embed="rId4"/>
+          <a:blip r:embed="rId2"/>
           <a:stretch>
             <a:fillRect/>
           </a:stretch>
@@ -8862,7 +8676,7 @@
           <a:bodyPr wrap="square" lIns="0" tIns="0" rIns="0" bIns="0" rtlCol="0" anchor="t"/>
           <a:lstStyle/>
           <a:p>
-            <a:pPr marL="0" indent="0">
+            <a:pPr indent="0" marL="0">
               <a:buNone/>
             </a:pPr>
             <a:r>
@@ -8901,7 +8715,7 @@
           <a:bodyPr wrap="square" lIns="0" tIns="0" rIns="0" bIns="0" rtlCol="0" anchor="t"/>
           <a:lstStyle/>
           <a:p>
-            <a:pPr marL="0" indent="0">
+            <a:pPr indent="0" marL="0">
               <a:buNone/>
             </a:pPr>
             <a:r>
@@ -8945,13 +8759,6 @@
             <a:prstDash val="solid"/>
           </a:ln>
         </p:spPr>
-        <p:txBody>
-          <a:bodyPr/>
-          <a:lstStyle/>
-          <a:p>
-            <a:endParaRPr lang="fr-CA"/>
-          </a:p>
-        </p:txBody>
       </p:sp>
       <p:sp>
         <p:nvSpPr>
@@ -8977,24 +8784,17 @@
             <a:prstDash val="solid"/>
           </a:ln>
         </p:spPr>
-        <p:txBody>
-          <a:bodyPr/>
-          <a:lstStyle/>
-          <a:p>
-            <a:endParaRPr lang="fr-CA"/>
-          </a:p>
-        </p:txBody>
       </p:sp>
       <p:pic>
         <p:nvPicPr>
-          <p:cNvPr id="21" name="Image 2" descr="livre"/>
+          <p:cNvPr id="21" name="Image 2" descr="livre">    </p:cNvPr>
           <p:cNvPicPr>
             <a:picLocks noChangeAspect="1"/>
           </p:cNvPicPr>
           <p:nvPr/>
         </p:nvPicPr>
         <p:blipFill>
-          <a:blip r:embed="rId5"/>
+          <a:blip r:embed="rId3"/>
           <a:stretch>
             <a:fillRect/>
           </a:stretch>
@@ -9030,7 +8830,7 @@
           <a:bodyPr wrap="square" lIns="0" tIns="0" rIns="0" bIns="0" rtlCol="0" anchor="t"/>
           <a:lstStyle/>
           <a:p>
-            <a:pPr marL="0" indent="0">
+            <a:pPr indent="0" marL="0">
               <a:buNone/>
             </a:pPr>
             <a:r>
@@ -9069,7 +8869,7 @@
           <a:bodyPr wrap="square" lIns="0" tIns="0" rIns="0" bIns="0" rtlCol="0" anchor="t"/>
           <a:lstStyle/>
           <a:p>
-            <a:pPr marL="0" indent="0">
+            <a:pPr indent="0" marL="0">
               <a:buNone/>
             </a:pPr>
             <a:r>
@@ -9113,13 +8913,6 @@
             <a:prstDash val="solid"/>
           </a:ln>
         </p:spPr>
-        <p:txBody>
-          <a:bodyPr/>
-          <a:lstStyle/>
-          <a:p>
-            <a:endParaRPr lang="fr-CA"/>
-          </a:p>
-        </p:txBody>
       </p:sp>
       <p:sp>
         <p:nvSpPr>
@@ -9145,24 +8938,17 @@
             <a:prstDash val="solid"/>
           </a:ln>
         </p:spPr>
-        <p:txBody>
-          <a:bodyPr/>
-          <a:lstStyle/>
-          <a:p>
-            <a:endParaRPr lang="fr-CA"/>
-          </a:p>
-        </p:txBody>
       </p:sp>
       <p:pic>
         <p:nvPicPr>
-          <p:cNvPr id="26" name="Image 3" descr="colombe"/>
+          <p:cNvPr id="26" name="Image 3" descr="colombe">    </p:cNvPr>
           <p:cNvPicPr>
             <a:picLocks noChangeAspect="1"/>
           </p:cNvPicPr>
           <p:nvPr/>
         </p:nvPicPr>
         <p:blipFill>
-          <a:blip r:embed="rId6"/>
+          <a:blip r:embed="rId4"/>
           <a:stretch>
             <a:fillRect/>
           </a:stretch>
@@ -9198,7 +8984,7 @@
           <a:bodyPr wrap="square" lIns="0" tIns="0" rIns="0" bIns="0" rtlCol="0" anchor="t"/>
           <a:lstStyle/>
           <a:p>
-            <a:pPr marL="0" indent="0">
+            <a:pPr indent="0" marL="0">
               <a:buNone/>
             </a:pPr>
             <a:r>
@@ -9237,7 +9023,7 @@
           <a:bodyPr wrap="square" lIns="0" tIns="0" rIns="0" bIns="0" rtlCol="0" anchor="t"/>
           <a:lstStyle/>
           <a:p>
-            <a:pPr marL="0" indent="0">
+            <a:pPr indent="0" marL="0">
               <a:buNone/>
             </a:pPr>
             <a:r>
@@ -9276,7 +9062,7 @@
           <a:bodyPr wrap="square" lIns="0" tIns="0" rIns="0" bIns="0" rtlCol="0" anchor="t"/>
           <a:lstStyle/>
           <a:p>
-            <a:pPr marL="0" indent="0">
+            <a:pPr indent="0" marL="0">
               <a:buNone/>
             </a:pPr>
             <a:r>
@@ -9293,7 +9079,7 @@
             <a:endParaRPr lang="en-US" sz="1500" dirty="0"/>
           </a:p>
           <a:p>
-            <a:pPr marL="0" indent="0">
+            <a:pPr indent="0" marL="0">
               <a:buNone/>
             </a:pPr>
             <a:r>
@@ -9327,7 +9113,6 @@
         <a:solidFill>
           <a:srgbClr val="0D0B0A"/>
         </a:solidFill>
-        <a:effectLst/>
       </p:bgPr>
     </p:bg>
     <p:spTree>
@@ -9365,11 +9150,11 @@
           <a:bodyPr wrap="square" lIns="0" tIns="0" rIns="0" bIns="0" rtlCol="0" anchor="t"/>
           <a:lstStyle/>
           <a:p>
-            <a:pPr marL="0" indent="0">
-              <a:buNone/>
-            </a:pPr>
-            <a:r>
-              <a:rPr lang="en-US" sz="1300" b="1" kern="0" spc="300" dirty="0">
+            <a:pPr indent="0" marL="0">
+              <a:buNone/>
+            </a:pPr>
+            <a:r>
+              <a:rPr lang="en-US" sz="1300" b="1" spc="300" kern="0" dirty="0">
                 <a:solidFill>
                   <a:srgbClr val="E8742A"/>
                 </a:solidFill>
@@ -9404,7 +9189,7 @@
           <a:bodyPr wrap="square" lIns="0" tIns="0" rIns="0" bIns="0" rtlCol="0" anchor="t"/>
           <a:lstStyle/>
           <a:p>
-            <a:pPr marL="0" indent="0">
+            <a:pPr indent="0" marL="0">
               <a:buNone/>
             </a:pPr>
             <a:r>
@@ -9443,7 +9228,7 @@
           <a:bodyPr wrap="square" lIns="0" tIns="0" rIns="0" bIns="0" rtlCol="0" anchor="t"/>
           <a:lstStyle/>
           <a:p>
-            <a:pPr marL="0" indent="0">
+            <a:pPr indent="0" marL="0">
               <a:buNone/>
             </a:pPr>
             <a:r>
@@ -9482,7 +9267,7 @@
           <a:bodyPr wrap="square" lIns="0" tIns="0" rIns="0" bIns="0" rtlCol="0" anchor="t"/>
           <a:lstStyle/>
           <a:p>
-            <a:pPr marL="0" indent="0" algn="ctr">
+            <a:pPr algn="ctr" indent="0" marL="0">
               <a:buNone/>
             </a:pPr>
             <a:r>
@@ -9521,7 +9306,7 @@
           <a:bodyPr wrap="square" lIns="0" tIns="0" rIns="0" bIns="0" rtlCol="0" anchor="t"/>
           <a:lstStyle/>
           <a:p>
-            <a:pPr marL="0" indent="0" algn="ctr">
+            <a:pPr algn="ctr" indent="0" marL="0">
               <a:buNone/>
             </a:pPr>
             <a:r>
@@ -9560,7 +9345,7 @@
           <a:bodyPr wrap="square" lIns="0" tIns="0" rIns="0" bIns="0" rtlCol="0" anchor="t"/>
           <a:lstStyle/>
           <a:p>
-            <a:pPr marL="0" indent="0" algn="ctr">
+            <a:pPr algn="ctr" indent="0" marL="0">
               <a:buNone/>
             </a:pPr>
             <a:r>
@@ -9599,7 +9384,7 @@
           <a:bodyPr wrap="square" lIns="0" tIns="0" rIns="0" bIns="0" rtlCol="0" anchor="t"/>
           <a:lstStyle/>
           <a:p>
-            <a:pPr marL="0" indent="0" algn="ctr">
+            <a:pPr algn="ctr" indent="0" marL="0">
               <a:buNone/>
             </a:pPr>
             <a:r>
@@ -9638,7 +9423,7 @@
           <a:bodyPr wrap="square" lIns="0" tIns="0" rIns="0" bIns="0" rtlCol="0" anchor="t"/>
           <a:lstStyle/>
           <a:p>
-            <a:pPr marL="0" indent="0" algn="ctr">
+            <a:pPr algn="ctr" indent="0" marL="0">
               <a:buNone/>
             </a:pPr>
             <a:r>
@@ -9677,7 +9462,7 @@
           <a:bodyPr wrap="square" lIns="0" tIns="0" rIns="0" bIns="0" rtlCol="0" anchor="t"/>
           <a:lstStyle/>
           <a:p>
-            <a:pPr marL="0" indent="0" algn="ctr">
+            <a:pPr algn="ctr" indent="0" marL="0">
               <a:buNone/>
             </a:pPr>
             <a:r>
@@ -9697,14 +9482,14 @@
       </p:sp>
       <p:pic>
         <p:nvPicPr>
-          <p:cNvPr id="11" name="Image 0" descr="Les tables de pierre, puis un cœur où la loi est écrite"/>
+          <p:cNvPr id="11" name="Image 0" descr="Les tables de pierre, puis un cœur où la loi est écrite">    </p:cNvPr>
           <p:cNvPicPr>
             <a:picLocks noChangeAspect="1"/>
           </p:cNvPicPr>
           <p:nvPr/>
         </p:nvPicPr>
         <p:blipFill>
-          <a:blip r:embed="rId3"/>
+          <a:blip r:embed="rId1"/>
           <a:stretch>
             <a:fillRect/>
           </a:stretch>
@@ -9740,7 +9525,7 @@
           <a:bodyPr wrap="square" lIns="0" tIns="0" rIns="0" bIns="0" rtlCol="0" anchor="t"/>
           <a:lstStyle/>
           <a:p>
-            <a:pPr marL="0" indent="0" algn="ctr">
+            <a:pPr algn="ctr" indent="0" marL="0">
               <a:buNone/>
             </a:pPr>
             <a:r>
@@ -9757,7 +9542,7 @@
             <a:endParaRPr lang="en-US" sz="1600" dirty="0"/>
           </a:p>
           <a:p>
-            <a:pPr marL="0" indent="0" algn="ctr">
+            <a:pPr algn="ctr" indent="0" marL="0">
               <a:buNone/>
             </a:pPr>
             <a:r>
@@ -9796,7 +9581,7 @@
           <a:bodyPr wrap="square" lIns="0" tIns="0" rIns="0" bIns="0" rtlCol="0" anchor="t"/>
           <a:lstStyle/>
           <a:p>
-            <a:pPr marL="0" indent="0" algn="ctr">
+            <a:pPr algn="ctr" indent="0" marL="0">
               <a:buNone/>
             </a:pPr>
             <a:r>
@@ -9813,7 +9598,7 @@
             <a:endParaRPr lang="en-US" sz="1600" dirty="0"/>
           </a:p>
           <a:p>
-            <a:pPr marL="0" indent="0" algn="ctr">
+            <a:pPr algn="ctr" indent="0" marL="0">
               <a:buNone/>
             </a:pPr>
             <a:r>
@@ -9852,7 +9637,7 @@
           <a:bodyPr wrap="square" lIns="0" tIns="0" rIns="0" bIns="0" rtlCol="0" anchor="t"/>
           <a:lstStyle/>
           <a:p>
-            <a:pPr marL="0" indent="0">
+            <a:pPr indent="0" marL="0">
               <a:buNone/>
             </a:pPr>
             <a:r>
@@ -9891,7 +9676,7 @@
           <a:bodyPr wrap="square" lIns="0" tIns="0" rIns="0" bIns="0" rtlCol="0" anchor="t"/>
           <a:lstStyle/>
           <a:p>
-            <a:pPr marL="0" indent="0">
+            <a:pPr indent="0" marL="0">
               <a:buNone/>
             </a:pPr>
             <a:r>
@@ -9935,13 +9720,6 @@
             <a:prstDash val="solid"/>
           </a:ln>
         </p:spPr>
-        <p:txBody>
-          <a:bodyPr/>
-          <a:lstStyle/>
-          <a:p>
-            <a:endParaRPr lang="fr-CA"/>
-          </a:p>
-        </p:txBody>
       </p:sp>
       <p:sp>
         <p:nvSpPr>
@@ -9967,24 +9745,17 @@
             <a:prstDash val="solid"/>
           </a:ln>
         </p:spPr>
-        <p:txBody>
-          <a:bodyPr/>
-          <a:lstStyle/>
-          <a:p>
-            <a:endParaRPr lang="fr-CA"/>
-          </a:p>
-        </p:txBody>
       </p:sp>
       <p:pic>
         <p:nvPicPr>
-          <p:cNvPr id="18" name="Image 1" descr="cerveau"/>
+          <p:cNvPr id="18" name="Image 1" descr="cerveau">    </p:cNvPr>
           <p:cNvPicPr>
             <a:picLocks noChangeAspect="1"/>
           </p:cNvPicPr>
           <p:nvPr/>
         </p:nvPicPr>
         <p:blipFill>
-          <a:blip r:embed="rId4"/>
+          <a:blip r:embed="rId2"/>
           <a:stretch>
             <a:fillRect/>
           </a:stretch>
@@ -10020,7 +9791,7 @@
           <a:bodyPr wrap="square" lIns="0" tIns="0" rIns="0" bIns="0" rtlCol="0" anchor="ctr"/>
           <a:lstStyle/>
           <a:p>
-            <a:pPr marL="0" indent="0">
+            <a:pPr indent="0" marL="0">
               <a:buNone/>
             </a:pPr>
             <a:r>
@@ -10037,7 +9808,7 @@
             <a:endParaRPr lang="en-US" sz="1500" dirty="0"/>
           </a:p>
           <a:p>
-            <a:pPr marL="0" indent="0">
+            <a:pPr indent="0" marL="0">
               <a:buNone/>
             </a:pPr>
             <a:r>
@@ -10081,13 +9852,6 @@
             <a:prstDash val="solid"/>
           </a:ln>
         </p:spPr>
-        <p:txBody>
-          <a:bodyPr/>
-          <a:lstStyle/>
-          <a:p>
-            <a:endParaRPr lang="fr-CA"/>
-          </a:p>
-        </p:txBody>
       </p:sp>
       <p:sp>
         <p:nvSpPr>
@@ -10113,24 +9877,17 @@
             <a:prstDash val="solid"/>
           </a:ln>
         </p:spPr>
-        <p:txBody>
-          <a:bodyPr/>
-          <a:lstStyle/>
-          <a:p>
-            <a:endParaRPr lang="fr-CA"/>
-          </a:p>
-        </p:txBody>
       </p:sp>
       <p:pic>
         <p:nvPicPr>
-          <p:cNvPr id="22" name="Image 2" descr="balance"/>
+          <p:cNvPr id="22" name="Image 2" descr="balance">    </p:cNvPr>
           <p:cNvPicPr>
             <a:picLocks noChangeAspect="1"/>
           </p:cNvPicPr>
           <p:nvPr/>
         </p:nvPicPr>
         <p:blipFill>
-          <a:blip r:embed="rId5"/>
+          <a:blip r:embed="rId3"/>
           <a:stretch>
             <a:fillRect/>
           </a:stretch>
@@ -10166,7 +9923,7 @@
           <a:bodyPr wrap="square" lIns="0" tIns="0" rIns="0" bIns="0" rtlCol="0" anchor="ctr"/>
           <a:lstStyle/>
           <a:p>
-            <a:pPr marL="0" indent="0">
+            <a:pPr indent="0" marL="0">
               <a:buNone/>
             </a:pPr>
             <a:r>
@@ -10183,7 +9940,7 @@
             <a:endParaRPr lang="en-US" sz="1500" dirty="0"/>
           </a:p>
           <a:p>
-            <a:pPr marL="0" indent="0">
+            <a:pPr indent="0" marL="0">
               <a:buNone/>
             </a:pPr>
             <a:r>
@@ -10227,13 +9984,6 @@
             <a:prstDash val="solid"/>
           </a:ln>
         </p:spPr>
-        <p:txBody>
-          <a:bodyPr/>
-          <a:lstStyle/>
-          <a:p>
-            <a:endParaRPr lang="fr-CA"/>
-          </a:p>
-        </p:txBody>
       </p:sp>
       <p:sp>
         <p:nvSpPr>
@@ -10259,24 +10009,17 @@
             <a:prstDash val="solid"/>
           </a:ln>
         </p:spPr>
-        <p:txBody>
-          <a:bodyPr/>
-          <a:lstStyle/>
-          <a:p>
-            <a:endParaRPr lang="fr-CA"/>
-          </a:p>
-        </p:txBody>
       </p:sp>
       <p:pic>
         <p:nvPicPr>
-          <p:cNvPr id="26" name="Image 3" descr="relation"/>
+          <p:cNvPr id="26" name="Image 3" descr="relation">    </p:cNvPr>
           <p:cNvPicPr>
             <a:picLocks noChangeAspect="1"/>
           </p:cNvPicPr>
           <p:nvPr/>
         </p:nvPicPr>
         <p:blipFill>
-          <a:blip r:embed="rId6"/>
+          <a:blip r:embed="rId4"/>
           <a:stretch>
             <a:fillRect/>
           </a:stretch>
@@ -10312,7 +10055,7 @@
           <a:bodyPr wrap="square" lIns="0" tIns="0" rIns="0" bIns="0" rtlCol="0" anchor="ctr"/>
           <a:lstStyle/>
           <a:p>
-            <a:pPr marL="0" indent="0">
+            <a:pPr indent="0" marL="0">
               <a:buNone/>
             </a:pPr>
             <a:r>
@@ -10329,7 +10072,7 @@
             <a:endParaRPr lang="en-US" sz="1500" dirty="0"/>
           </a:p>
           <a:p>
-            <a:pPr marL="0" indent="0">
+            <a:pPr indent="0" marL="0">
               <a:buNone/>
             </a:pPr>
             <a:r>
@@ -10363,7 +10106,6 @@
         <a:solidFill>
           <a:srgbClr val="0D0B0A"/>
         </a:solidFill>
-        <a:effectLst/>
       </p:bgPr>
     </p:bg>
     <p:spTree>
@@ -10401,11 +10143,11 @@
           <a:bodyPr wrap="square" lIns="0" tIns="0" rIns="0" bIns="0" rtlCol="0" anchor="t"/>
           <a:lstStyle/>
           <a:p>
-            <a:pPr marL="0" indent="0">
-              <a:buNone/>
-            </a:pPr>
-            <a:r>
-              <a:rPr lang="en-US" sz="1300" b="1" kern="0" spc="300" dirty="0">
+            <a:pPr indent="0" marL="0">
+              <a:buNone/>
+            </a:pPr>
+            <a:r>
+              <a:rPr lang="en-US" sz="1300" b="1" spc="300" kern="0" dirty="0">
                 <a:solidFill>
                   <a:srgbClr val="E8742A"/>
                 </a:solidFill>
@@ -10440,7 +10182,7 @@
           <a:bodyPr wrap="square" lIns="0" tIns="0" rIns="0" bIns="0" rtlCol="0" anchor="t"/>
           <a:lstStyle/>
           <a:p>
-            <a:pPr marL="0" indent="0">
+            <a:pPr indent="0" marL="0">
               <a:buNone/>
             </a:pPr>
             <a:r>
@@ -10479,7 +10221,7 @@
           <a:bodyPr wrap="square" lIns="0" tIns="0" rIns="0" bIns="0" rtlCol="0" anchor="t"/>
           <a:lstStyle/>
           <a:p>
-            <a:pPr marL="0" indent="0">
+            <a:pPr indent="0" marL="0">
               <a:buNone/>
             </a:pPr>
             <a:r>
@@ -10518,7 +10260,7 @@
           <a:bodyPr wrap="square" lIns="0" tIns="0" rIns="0" bIns="0" rtlCol="0" anchor="t"/>
           <a:lstStyle/>
           <a:p>
-            <a:pPr marL="0" indent="0" algn="ctr">
+            <a:pPr algn="ctr" indent="0" marL="0">
               <a:buNone/>
             </a:pPr>
             <a:r>
@@ -10557,7 +10299,7 @@
           <a:bodyPr wrap="square" lIns="0" tIns="0" rIns="0" bIns="0" rtlCol="0" anchor="t"/>
           <a:lstStyle/>
           <a:p>
-            <a:pPr marL="0" indent="0" algn="ctr">
+            <a:pPr algn="ctr" indent="0" marL="0">
               <a:buNone/>
             </a:pPr>
             <a:r>
@@ -10596,7 +10338,7 @@
           <a:bodyPr wrap="square" lIns="0" tIns="0" rIns="0" bIns="0" rtlCol="0" anchor="t"/>
           <a:lstStyle/>
           <a:p>
-            <a:pPr marL="0" indent="0" algn="ctr">
+            <a:pPr algn="ctr" indent="0" marL="0">
               <a:buNone/>
             </a:pPr>
             <a:r>
@@ -10635,7 +10377,7 @@
           <a:bodyPr wrap="square" lIns="0" tIns="0" rIns="0" bIns="0" rtlCol="0" anchor="t"/>
           <a:lstStyle/>
           <a:p>
-            <a:pPr marL="0" indent="0" algn="ctr">
+            <a:pPr algn="ctr" indent="0" marL="0">
               <a:buNone/>
             </a:pPr>
             <a:r>
@@ -10674,7 +10416,7 @@
           <a:bodyPr wrap="square" lIns="0" tIns="0" rIns="0" bIns="0" rtlCol="0" anchor="t"/>
           <a:lstStyle/>
           <a:p>
-            <a:pPr marL="0" indent="0" algn="ctr">
+            <a:pPr algn="ctr" indent="0" marL="0">
               <a:buNone/>
             </a:pPr>
             <a:r>
@@ -10713,7 +10455,7 @@
           <a:bodyPr wrap="square" lIns="0" tIns="0" rIns="0" bIns="0" rtlCol="0" anchor="t"/>
           <a:lstStyle/>
           <a:p>
-            <a:pPr marL="0" indent="0" algn="ctr">
+            <a:pPr algn="ctr" indent="0" marL="0">
               <a:buNone/>
             </a:pPr>
             <a:r>
@@ -10733,14 +10475,14 @@
       </p:sp>
       <p:pic>
         <p:nvPicPr>
-          <p:cNvPr id="11" name="Image 0" descr="La terre, avec des flèches vers toutes les nations"/>
+          <p:cNvPr id="11" name="Image 0" descr="La terre, avec des flèches vers toutes les nations">    </p:cNvPr>
           <p:cNvPicPr>
             <a:picLocks noChangeAspect="1"/>
           </p:cNvPicPr>
           <p:nvPr/>
         </p:nvPicPr>
         <p:blipFill>
-          <a:blip r:embed="rId3"/>
+          <a:blip r:embed="rId1"/>
           <a:stretch>
             <a:fillRect/>
           </a:stretch>
@@ -10776,7 +10518,7 @@
           <a:bodyPr wrap="square" lIns="0" tIns="0" rIns="0" bIns="0" rtlCol="0" anchor="t"/>
           <a:lstStyle/>
           <a:p>
-            <a:pPr marL="0" indent="0" algn="ctr">
+            <a:pPr algn="ctr" indent="0" marL="0">
               <a:buNone/>
             </a:pPr>
             <a:r>
@@ -10820,13 +10562,6 @@
             <a:prstDash val="solid"/>
           </a:ln>
         </p:spPr>
-        <p:txBody>
-          <a:bodyPr/>
-          <a:lstStyle/>
-          <a:p>
-            <a:endParaRPr lang="fr-CA"/>
-          </a:p>
-        </p:txBody>
       </p:sp>
       <p:sp>
         <p:nvSpPr>
@@ -10849,7 +10584,7 @@
           <a:bodyPr wrap="square" lIns="0" tIns="0" rIns="0" bIns="0" rtlCol="0" anchor="ctr"/>
           <a:lstStyle/>
           <a:p>
-            <a:pPr marL="0" indent="0" algn="ctr">
+            <a:pPr algn="ctr" indent="0" marL="0">
               <a:buNone/>
             </a:pPr>
             <a:r>
@@ -10888,7 +10623,7 @@
           <a:bodyPr wrap="square" lIns="0" tIns="0" rIns="0" bIns="0" rtlCol="0" anchor="t"/>
           <a:lstStyle/>
           <a:p>
-            <a:pPr marL="0" indent="0" algn="ctr">
+            <a:pPr algn="ctr" indent="0" marL="0">
               <a:buNone/>
             </a:pPr>
             <a:r>
@@ -10932,13 +10667,6 @@
             <a:prstDash val="solid"/>
           </a:ln>
         </p:spPr>
-        <p:txBody>
-          <a:bodyPr/>
-          <a:lstStyle/>
-          <a:p>
-            <a:endParaRPr lang="fr-CA"/>
-          </a:p>
-        </p:txBody>
       </p:sp>
       <p:sp>
         <p:nvSpPr>
@@ -10964,24 +10692,17 @@
             <a:prstDash val="solid"/>
           </a:ln>
         </p:spPr>
-        <p:txBody>
-          <a:bodyPr/>
-          <a:lstStyle/>
-          <a:p>
-            <a:endParaRPr lang="fr-CA"/>
-          </a:p>
-        </p:txBody>
       </p:sp>
       <p:pic>
         <p:nvPicPr>
-          <p:cNvPr id="18" name="Image 1" descr="marche"/>
+          <p:cNvPr id="18" name="Image 1" descr="marche">    </p:cNvPr>
           <p:cNvPicPr>
             <a:picLocks noChangeAspect="1"/>
           </p:cNvPicPr>
           <p:nvPr/>
         </p:nvPicPr>
         <p:blipFill>
-          <a:blip r:embed="rId4"/>
+          <a:blip r:embed="rId2"/>
           <a:stretch>
             <a:fillRect/>
           </a:stretch>
@@ -11017,7 +10738,7 @@
           <a:bodyPr wrap="square" lIns="0" tIns="0" rIns="0" bIns="0" rtlCol="0" anchor="ctr"/>
           <a:lstStyle/>
           <a:p>
-            <a:pPr marL="0" indent="0">
+            <a:pPr indent="0" marL="0">
               <a:buNone/>
             </a:pPr>
             <a:r>
@@ -11056,7 +10777,7 @@
           <a:bodyPr wrap="square" lIns="0" tIns="0" rIns="0" bIns="0" rtlCol="0" anchor="t"/>
           <a:lstStyle/>
           <a:p>
-            <a:pPr marL="0" indent="0">
+            <a:pPr indent="0" marL="0">
               <a:buNone/>
             </a:pPr>
             <a:r>
@@ -11100,13 +10821,6 @@
             <a:prstDash val="solid"/>
           </a:ln>
         </p:spPr>
-        <p:txBody>
-          <a:bodyPr/>
-          <a:lstStyle/>
-          <a:p>
-            <a:endParaRPr lang="fr-CA"/>
-          </a:p>
-        </p:txBody>
       </p:sp>
       <p:sp>
         <p:nvSpPr>
@@ -11132,24 +10846,17 @@
             <a:prstDash val="solid"/>
           </a:ln>
         </p:spPr>
-        <p:txBody>
-          <a:bodyPr/>
-          <a:lstStyle/>
-          <a:p>
-            <a:endParaRPr lang="fr-CA"/>
-          </a:p>
-        </p:txBody>
       </p:sp>
       <p:pic>
         <p:nvPicPr>
-          <p:cNvPr id="23" name="Image 2" descr="eau"/>
+          <p:cNvPr id="23" name="Image 2" descr="eau">    </p:cNvPr>
           <p:cNvPicPr>
             <a:picLocks noChangeAspect="1"/>
           </p:cNvPicPr>
           <p:nvPr/>
         </p:nvPicPr>
         <p:blipFill>
-          <a:blip r:embed="rId5"/>
+          <a:blip r:embed="rId3"/>
           <a:stretch>
             <a:fillRect/>
           </a:stretch>
@@ -11185,7 +10892,7 @@
           <a:bodyPr wrap="square" lIns="0" tIns="0" rIns="0" bIns="0" rtlCol="0" anchor="ctr"/>
           <a:lstStyle/>
           <a:p>
-            <a:pPr marL="0" indent="0">
+            <a:pPr indent="0" marL="0">
               <a:buNone/>
             </a:pPr>
             <a:r>
@@ -11224,7 +10931,7 @@
           <a:bodyPr wrap="square" lIns="0" tIns="0" rIns="0" bIns="0" rtlCol="0" anchor="t"/>
           <a:lstStyle/>
           <a:p>
-            <a:pPr marL="0" indent="0">
+            <a:pPr indent="0" marL="0">
               <a:buNone/>
             </a:pPr>
             <a:r>
@@ -11268,13 +10975,6 @@
             <a:prstDash val="solid"/>
           </a:ln>
         </p:spPr>
-        <p:txBody>
-          <a:bodyPr/>
-          <a:lstStyle/>
-          <a:p>
-            <a:endParaRPr lang="fr-CA"/>
-          </a:p>
-        </p:txBody>
       </p:sp>
       <p:sp>
         <p:nvSpPr>
@@ -11300,24 +11000,17 @@
             <a:prstDash val="solid"/>
           </a:ln>
         </p:spPr>
-        <p:txBody>
-          <a:bodyPr/>
-          <a:lstStyle/>
-          <a:p>
-            <a:endParaRPr lang="fr-CA"/>
-          </a:p>
-        </p:txBody>
       </p:sp>
       <p:pic>
         <p:nvPicPr>
-          <p:cNvPr id="28" name="Image 3" descr="enseigner"/>
+          <p:cNvPr id="28" name="Image 3" descr="enseigner">    </p:cNvPr>
           <p:cNvPicPr>
             <a:picLocks noChangeAspect="1"/>
           </p:cNvPicPr>
           <p:nvPr/>
         </p:nvPicPr>
         <p:blipFill>
-          <a:blip r:embed="rId6"/>
+          <a:blip r:embed="rId4"/>
           <a:stretch>
             <a:fillRect/>
           </a:stretch>
@@ -11353,7 +11046,7 @@
           <a:bodyPr wrap="square" lIns="0" tIns="0" rIns="0" bIns="0" rtlCol="0" anchor="ctr"/>
           <a:lstStyle/>
           <a:p>
-            <a:pPr marL="0" indent="0">
+            <a:pPr indent="0" marL="0">
               <a:buNone/>
             </a:pPr>
             <a:r>
@@ -11392,7 +11085,7 @@
           <a:bodyPr wrap="square" lIns="0" tIns="0" rIns="0" bIns="0" rtlCol="0" anchor="t"/>
           <a:lstStyle/>
           <a:p>
-            <a:pPr marL="0" indent="0">
+            <a:pPr indent="0" marL="0">
               <a:buNone/>
             </a:pPr>
             <a:r>
@@ -11436,13 +11129,6 @@
             <a:prstDash val="solid"/>
           </a:ln>
         </p:spPr>
-        <p:txBody>
-          <a:bodyPr/>
-          <a:lstStyle/>
-          <a:p>
-            <a:endParaRPr lang="fr-CA"/>
-          </a:p>
-        </p:txBody>
       </p:sp>
       <p:sp>
         <p:nvSpPr>
@@ -11468,24 +11154,17 @@
             <a:prstDash val="solid"/>
           </a:ln>
         </p:spPr>
-        <p:txBody>
-          <a:bodyPr/>
-          <a:lstStyle/>
-          <a:p>
-            <a:endParaRPr lang="fr-CA"/>
-          </a:p>
-        </p:txBody>
       </p:sp>
       <p:pic>
         <p:nvPicPr>
-          <p:cNvPr id="33" name="Image 4" descr="main"/>
+          <p:cNvPr id="33" name="Image 4" descr="main">    </p:cNvPr>
           <p:cNvPicPr>
             <a:picLocks noChangeAspect="1"/>
           </p:cNvPicPr>
           <p:nvPr/>
         </p:nvPicPr>
         <p:blipFill>
-          <a:blip r:embed="rId7"/>
+          <a:blip r:embed="rId5"/>
           <a:stretch>
             <a:fillRect/>
           </a:stretch>
@@ -11521,7 +11200,7 @@
           <a:bodyPr wrap="square" lIns="0" tIns="0" rIns="0" bIns="0" rtlCol="0" anchor="ctr"/>
           <a:lstStyle/>
           <a:p>
-            <a:pPr marL="0" indent="0">
+            <a:pPr indent="0" marL="0">
               <a:buNone/>
             </a:pPr>
             <a:r>
@@ -11560,7 +11239,7 @@
           <a:bodyPr wrap="square" lIns="0" tIns="0" rIns="0" bIns="0" rtlCol="0" anchor="t"/>
           <a:lstStyle/>
           <a:p>
-            <a:pPr marL="0" indent="0" algn="ctr">
+            <a:pPr algn="ctr" indent="0" marL="0">
               <a:buNone/>
             </a:pPr>
             <a:r>
@@ -11879,341 +11558,4 @@
     </a:ext>
   </a:extLst>
 </a:theme>
-</file>
-
-<file path=ppt/theme/theme2.xml><?xml version="1.0" encoding="utf-8"?>
-<a:theme xmlns:a="http://schemas.openxmlformats.org/drawingml/2006/main" name="Thème Office">
-  <a:themeElements>
-    <a:clrScheme name="Office">
-      <a:dk1>
-        <a:sysClr val="windowText" lastClr="000000"/>
-      </a:dk1>
-      <a:lt1>
-        <a:sysClr val="window" lastClr="FFFFFF"/>
-      </a:lt1>
-      <a:dk2>
-        <a:srgbClr val="0E2841"/>
-      </a:dk2>
-      <a:lt2>
-        <a:srgbClr val="E8E8E8"/>
-      </a:lt2>
-      <a:accent1>
-        <a:srgbClr val="156082"/>
-      </a:accent1>
-      <a:accent2>
-        <a:srgbClr val="E97132"/>
-      </a:accent2>
-      <a:accent3>
-        <a:srgbClr val="196B24"/>
-      </a:accent3>
-      <a:accent4>
-        <a:srgbClr val="0F9ED5"/>
-      </a:accent4>
-      <a:accent5>
-        <a:srgbClr val="A02B93"/>
-      </a:accent5>
-      <a:accent6>
-        <a:srgbClr val="4EA72E"/>
-      </a:accent6>
-      <a:hlink>
-        <a:srgbClr val="467886"/>
-      </a:hlink>
-      <a:folHlink>
-        <a:srgbClr val="96607D"/>
-      </a:folHlink>
-    </a:clrScheme>
-    <a:fontScheme name="Office">
-      <a:majorFont>
-        <a:latin typeface="Aptos Display" panose="02110004020202020204"/>
-        <a:ea typeface=""/>
-        <a:cs typeface=""/>
-        <a:font script="Jpan" typeface="游ゴシック Light"/>
-        <a:font script="Hang" typeface="맑은 고딕"/>
-        <a:font script="Hans" typeface="等线 Light"/>
-        <a:font script="Hant" typeface="新細明體"/>
-        <a:font script="Arab" typeface="Times New Roman"/>
-        <a:font script="Hebr" typeface="Times New Roman"/>
-        <a:font script="Thai" typeface="Angsana New"/>
-        <a:font script="Ethi" typeface="Nyala"/>
-        <a:font script="Beng" typeface="Vrinda"/>
-        <a:font script="Gujr" typeface="Shruti"/>
-        <a:font script="Khmr" typeface="MoolBoran"/>
-        <a:font script="Knda" typeface="Tunga"/>
-        <a:font script="Guru" typeface="Raavi"/>
-        <a:font script="Cans" typeface="Euphemia"/>
-        <a:font script="Cher" typeface="Plantagenet Cherokee"/>
-        <a:font script="Yiii" typeface="Microsoft Yi Baiti"/>
-        <a:font script="Tibt" typeface="Microsoft Himalaya"/>
-        <a:font script="Thaa" typeface="MV Boli"/>
-        <a:font script="Deva" typeface="Mangal"/>
-        <a:font script="Telu" typeface="Gautami"/>
-        <a:font script="Taml" typeface="Latha"/>
-        <a:font script="Syrc" typeface="Estrangelo Edessa"/>
-        <a:font script="Orya" typeface="Kalinga"/>
-        <a:font script="Mlym" typeface="Kartika"/>
-        <a:font script="Laoo" typeface="DokChampa"/>
-        <a:font script="Sinh" typeface="Iskoola Pota"/>
-        <a:font script="Mong" typeface="Mongolian Baiti"/>
-        <a:font script="Viet" typeface="Times New Roman"/>
-        <a:font script="Uigh" typeface="Microsoft Uighur"/>
-        <a:font script="Geor" typeface="Sylfaen"/>
-        <a:font script="Armn" typeface="Arial"/>
-        <a:font script="Bugi" typeface="Leelawadee UI"/>
-        <a:font script="Bopo" typeface="Microsoft JhengHei"/>
-        <a:font script="Java" typeface="Javanese Text"/>
-        <a:font script="Lisu" typeface="Segoe UI"/>
-        <a:font script="Mymr" typeface="Myanmar Text"/>
-        <a:font script="Nkoo" typeface="Ebrima"/>
-        <a:font script="Olck" typeface="Nirmala UI"/>
-        <a:font script="Osma" typeface="Ebrima"/>
-        <a:font script="Phag" typeface="Phagspa"/>
-        <a:font script="Syrn" typeface="Estrangelo Edessa"/>
-        <a:font script="Syrj" typeface="Estrangelo Edessa"/>
-        <a:font script="Syre" typeface="Estrangelo Edessa"/>
-        <a:font script="Sora" typeface="Nirmala UI"/>
-        <a:font script="Tale" typeface="Microsoft Tai Le"/>
-        <a:font script="Talu" typeface="Microsoft New Tai Lue"/>
-        <a:font script="Tfng" typeface="Ebrima"/>
-      </a:majorFont>
-      <a:minorFont>
-        <a:latin typeface="Aptos" panose="02110004020202020204"/>
-        <a:ea typeface=""/>
-        <a:cs typeface=""/>
-        <a:font script="Jpan" typeface="游ゴシック"/>
-        <a:font script="Hang" typeface="맑은 고딕"/>
-        <a:font script="Hans" typeface="等线"/>
-        <a:font script="Hant" typeface="新細明體"/>
-        <a:font script="Arab" typeface="Arial"/>
-        <a:font script="Hebr" typeface="Arial"/>
-        <a:font script="Thai" typeface="Cordia New"/>
-        <a:font script="Ethi" typeface="Nyala"/>
-        <a:font script="Beng" typeface="Vrinda"/>
-        <a:font script="Gujr" typeface="Shruti"/>
-        <a:font script="Khmr" typeface="DaunPenh"/>
-        <a:font script="Knda" typeface="Tunga"/>
-        <a:font script="Guru" typeface="Raavi"/>
-        <a:font script="Cans" typeface="Euphemia"/>
-        <a:font script="Cher" typeface="Plantagenet Cherokee"/>
-        <a:font script="Yiii" typeface="Microsoft Yi Baiti"/>
-        <a:font script="Tibt" typeface="Microsoft Himalaya"/>
-        <a:font script="Thaa" typeface="MV Boli"/>
-        <a:font script="Deva" typeface="Mangal"/>
-        <a:font script="Telu" typeface="Gautami"/>
-        <a:font script="Taml" typeface="Latha"/>
-        <a:font script="Syrc" typeface="Estrangelo Edessa"/>
-        <a:font script="Orya" typeface="Kalinga"/>
-        <a:font script="Mlym" typeface="Kartika"/>
-        <a:font script="Laoo" typeface="DokChampa"/>
-        <a:font script="Sinh" typeface="Iskoola Pota"/>
-        <a:font script="Mong" typeface="Mongolian Baiti"/>
-        <a:font script="Viet" typeface="Arial"/>
-        <a:font script="Uigh" typeface="Microsoft Uighur"/>
-        <a:font script="Geor" typeface="Sylfaen"/>
-        <a:font script="Armn" typeface="Arial"/>
-        <a:font script="Bugi" typeface="Leelawadee UI"/>
-        <a:font script="Bopo" typeface="Microsoft JhengHei"/>
-        <a:font script="Java" typeface="Javanese Text"/>
-        <a:font script="Lisu" typeface="Segoe UI"/>
-        <a:font script="Mymr" typeface="Myanmar Text"/>
-        <a:font script="Nkoo" typeface="Ebrima"/>
-        <a:font script="Olck" typeface="Nirmala UI"/>
-        <a:font script="Osma" typeface="Ebrima"/>
-        <a:font script="Phag" typeface="Phagspa"/>
-        <a:font script="Syrn" typeface="Estrangelo Edessa"/>
-        <a:font script="Syrj" typeface="Estrangelo Edessa"/>
-        <a:font script="Syre" typeface="Estrangelo Edessa"/>
-        <a:font script="Sora" typeface="Nirmala UI"/>
-        <a:font script="Tale" typeface="Microsoft Tai Le"/>
-        <a:font script="Talu" typeface="Microsoft New Tai Lue"/>
-        <a:font script="Tfng" typeface="Ebrima"/>
-      </a:minorFont>
-    </a:fontScheme>
-    <a:fmtScheme name="Office">
-      <a:fillStyleLst>
-        <a:solidFill>
-          <a:schemeClr val="phClr"/>
-        </a:solidFill>
-        <a:gradFill rotWithShape="1">
-          <a:gsLst>
-            <a:gs pos="0">
-              <a:schemeClr val="phClr">
-                <a:lumMod val="110000"/>
-                <a:satMod val="105000"/>
-                <a:tint val="67000"/>
-              </a:schemeClr>
-            </a:gs>
-            <a:gs pos="50000">
-              <a:schemeClr val="phClr">
-                <a:lumMod val="105000"/>
-                <a:satMod val="103000"/>
-                <a:tint val="73000"/>
-              </a:schemeClr>
-            </a:gs>
-            <a:gs pos="100000">
-              <a:schemeClr val="phClr">
-                <a:lumMod val="105000"/>
-                <a:satMod val="109000"/>
-                <a:tint val="81000"/>
-              </a:schemeClr>
-            </a:gs>
-          </a:gsLst>
-          <a:lin ang="5400000" scaled="0"/>
-        </a:gradFill>
-        <a:gradFill rotWithShape="1">
-          <a:gsLst>
-            <a:gs pos="0">
-              <a:schemeClr val="phClr">
-                <a:satMod val="103000"/>
-                <a:lumMod val="102000"/>
-                <a:tint val="94000"/>
-              </a:schemeClr>
-            </a:gs>
-            <a:gs pos="50000">
-              <a:schemeClr val="phClr">
-                <a:satMod val="110000"/>
-                <a:lumMod val="100000"/>
-                <a:shade val="100000"/>
-              </a:schemeClr>
-            </a:gs>
-            <a:gs pos="100000">
-              <a:schemeClr val="phClr">
-                <a:lumMod val="99000"/>
-                <a:satMod val="120000"/>
-                <a:shade val="78000"/>
-              </a:schemeClr>
-            </a:gs>
-          </a:gsLst>
-          <a:lin ang="5400000" scaled="0"/>
-        </a:gradFill>
-      </a:fillStyleLst>
-      <a:lnStyleLst>
-        <a:ln w="12700" cap="flat" cmpd="sng" algn="ctr">
-          <a:solidFill>
-            <a:schemeClr val="phClr"/>
-          </a:solidFill>
-          <a:prstDash val="solid"/>
-          <a:miter lim="800000"/>
-        </a:ln>
-        <a:ln w="19050" cap="flat" cmpd="sng" algn="ctr">
-          <a:solidFill>
-            <a:schemeClr val="phClr"/>
-          </a:solidFill>
-          <a:prstDash val="solid"/>
-          <a:miter lim="800000"/>
-        </a:ln>
-        <a:ln w="25400" cap="flat" cmpd="sng" algn="ctr">
-          <a:solidFill>
-            <a:schemeClr val="phClr"/>
-          </a:solidFill>
-          <a:prstDash val="solid"/>
-          <a:miter lim="800000"/>
-        </a:ln>
-      </a:lnStyleLst>
-      <a:effectStyleLst>
-        <a:effectStyle>
-          <a:effectLst/>
-        </a:effectStyle>
-        <a:effectStyle>
-          <a:effectLst/>
-        </a:effectStyle>
-        <a:effectStyle>
-          <a:effectLst>
-            <a:outerShdw blurRad="57150" dist="19050" dir="5400000" algn="ctr" rotWithShape="0">
-              <a:srgbClr val="000000">
-                <a:alpha val="63000"/>
-              </a:srgbClr>
-            </a:outerShdw>
-          </a:effectLst>
-        </a:effectStyle>
-      </a:effectStyleLst>
-      <a:bgFillStyleLst>
-        <a:solidFill>
-          <a:schemeClr val="phClr"/>
-        </a:solidFill>
-        <a:solidFill>
-          <a:schemeClr val="phClr">
-            <a:tint val="95000"/>
-            <a:satMod val="170000"/>
-          </a:schemeClr>
-        </a:solidFill>
-        <a:gradFill rotWithShape="1">
-          <a:gsLst>
-            <a:gs pos="0">
-              <a:schemeClr val="phClr">
-                <a:tint val="93000"/>
-                <a:satMod val="150000"/>
-                <a:shade val="98000"/>
-                <a:lumMod val="102000"/>
-              </a:schemeClr>
-            </a:gs>
-            <a:gs pos="50000">
-              <a:schemeClr val="phClr">
-                <a:tint val="98000"/>
-                <a:satMod val="130000"/>
-                <a:shade val="90000"/>
-                <a:lumMod val="103000"/>
-              </a:schemeClr>
-            </a:gs>
-            <a:gs pos="100000">
-              <a:schemeClr val="phClr">
-                <a:shade val="63000"/>
-                <a:satMod val="120000"/>
-              </a:schemeClr>
-            </a:gs>
-          </a:gsLst>
-          <a:lin ang="5400000" scaled="0"/>
-        </a:gradFill>
-      </a:bgFillStyleLst>
-    </a:fmtScheme>
-  </a:themeElements>
-  <a:objectDefaults>
-    <a:lnDef>
-      <a:spPr/>
-      <a:bodyPr/>
-      <a:lstStyle/>
-      <a:style>
-        <a:lnRef idx="2">
-          <a:schemeClr val="accent1"/>
-        </a:lnRef>
-        <a:fillRef idx="0">
-          <a:schemeClr val="accent1"/>
-        </a:fillRef>
-        <a:effectRef idx="1">
-          <a:schemeClr val="accent1"/>
-        </a:effectRef>
-        <a:fontRef idx="minor">
-          <a:schemeClr val="tx1"/>
-        </a:fontRef>
-      </a:style>
-    </a:lnDef>
-  </a:objectDefaults>
-  <a:extraClrSchemeLst/>
-  <a:extLst>
-    <a:ext uri="{05A4C25C-085E-4340-85A3-A5531E510DB2}">
-      <thm15:themeFamily xmlns:thm15="http://schemas.microsoft.com/office/thememl/2012/main" name="Office Theme" id="{2E142A2C-CD16-42D6-873A-C26D2A0506FA}" vid="{1BDDFF52-6CD6-40A5-AB3C-68EB2F1E4D0A}"/>
-    </a:ext>
-  </a:extLst>
-</a:theme>
-</file>
-
-<file path=ppt/webextensions/taskpanes.xml><?xml version="1.0" encoding="utf-8"?>
-<wetp:taskpanes xmlns:wetp="http://schemas.microsoft.com/office/webextensions/taskpanes/2010/11">
-  <wetp:taskpane dockstate="right" visibility="0" width="526" row="1">
-    <wetp:webextensionref xmlns:r="http://schemas.openxmlformats.org/officeDocument/2006/relationships" r:id="rId1"/>
-  </wetp:taskpane>
-</wetp:taskpanes>
-</file>
-
-<file path=ppt/webextensions/webextension1.xml><?xml version="1.0" encoding="utf-8"?>
-<we:webextension xmlns:we="http://schemas.microsoft.com/office/webextensions/webextension/2010/11" id="{6314F62E-2EBF-4E6A-88FE-9112D995ECA7}">
-  <we:reference id="wa200010001" version="1.0.0.1" store="en-US" storeType="OMEX"/>
-  <we:alternateReferences>
-    <we:reference id="WA200010001" version="1.0.0.1" store="" storeType="OMEX"/>
-  </we:alternateReferences>
-  <we:properties>
-    <we:property name="claude.fileId" value="&quot;e74a2d0c-8482-4e28-904b-5ff186743d16&quot;"/>
-  </we:properties>
-  <we:bindings/>
-  <we:snapshot xmlns:r="http://schemas.openxmlformats.org/officeDocument/2006/relationships"/>
-</we:webextension>
 </file>
</xml_diff>

<commit_message>
Reprend dans deck.js les retouches manuelles de la présentation
Le commit 56fc32a ajustait la présentation dans PowerPoint; la
régénération suivante (a2debfd) les avait écrasées. deck.js les porte
désormais :
- diapositive 3 : légendes sous l'illustration recentrées (x 0,556 et
  4,167 po, largeur 3,472 po);
- diapositive 4 : zone « Faisons » (Périchorèse) haute de 1,167 po.
Rendu identique à la version 56fc32a; notes de la diapositive 5 avec la
kénose conservées.

Co-Authored-By: Claude Opus 5.5 <noreply@anthropic.com>
</commit_message>
<xml_diff>
--- a/Presentation-A-l-image-de-Christ.pptx
+++ b/Presentation-A-l-image-de-Christ.pptx
@@ -3926,8 +3926,8 @@
         </p:nvSpPr>
         <p:spPr>
           <a:xfrm>
-            <a:off x="365760" y="5120640"/>
-            <a:ext cx="3474720" cy="685800"/>
+            <a:off x="508041" y="5120640"/>
+            <a:ext cx="3174980" cy="685800"/>
           </a:xfrm>
           <a:prstGeom prst="rect">
             <a:avLst/>
@@ -3982,8 +3982,8 @@
         </p:nvSpPr>
         <p:spPr>
           <a:xfrm>
-            <a:off x="3657600" y="5120640"/>
-            <a:ext cx="3474720" cy="685800"/>
+            <a:off x="3810030" y="5120640"/>
+            <a:ext cx="3174980" cy="685800"/>
           </a:xfrm>
           <a:prstGeom prst="rect">
             <a:avLst/>
@@ -5222,7 +5222,7 @@
         <p:spPr>
           <a:xfrm>
             <a:off x="548640" y="5440680"/>
-            <a:ext cx="3840480" cy="868680"/>
+            <a:ext cx="3840480" cy="1066830"/>
           </a:xfrm>
           <a:prstGeom prst="rect">
             <a:avLst/>

</xml_diff>

<commit_message>
Rétablit 2 Co 3.18 sous « Transformés » dans la frise de conclusion
Diapositive 10 : chaque nœud de la frise renvoie de nouveau au texte de
son point (IV, 2 Corinthiens 3.18).

Co-Authored-By: Claude Opus 5.5 <noreply@anthropic.com>
</commit_message>
<xml_diff>
--- a/Presentation-A-l-image-de-Christ.pptx
+++ b/Presentation-A-l-image-de-Christ.pptx
@@ -2606,6 +2606,23 @@
             </a:r>
             <a:endParaRPr lang="en-US" sz="1600" dirty="0"/>
           </a:p>
+          <a:p>
+            <a:pPr algn="ctr" indent="0" marL="0">
+              <a:buNone/>
+            </a:pPr>
+            <a:r>
+              <a:rPr lang="en-US" sz="1300" dirty="0">
+                <a:solidFill>
+                  <a:srgbClr val="A89A8C"/>
+                </a:solidFill>
+                <a:latin typeface="Calibri" pitchFamily="34" charset="0"/>
+                <a:ea typeface="Calibri" pitchFamily="34" charset="-122"/>
+                <a:cs typeface="Calibri" pitchFamily="34" charset="-120"/>
+              </a:rPr>
+              <a:t>2 Co 3.18</a:t>
+            </a:r>
+            <a:endParaRPr lang="en-US" sz="1600" dirty="0"/>
+          </a:p>
         </p:txBody>
       </p:sp>
       <p:sp>

</xml_diff>

<commit_message>
Enregistre les retouches en cours de la présentation (diapos 3 et 4)
État du .pptx enregistré dans PowerPoint le 2026-09-30 à 8 h 44, commité tel quel avant la mise à jour des notes : Tselem / eikôn (diapo 3); Morale - Éthique, Communion, icônes centrées et légende « Relation Divine » sur le schéma Trinité (diapo 4).

Co-Authored-By: Claude Opus 5.5 <noreply@anthropic.com>
</commit_message>
<xml_diff>
--- a/Presentation-A-l-image-de-Christ.pptx
+++ b/Presentation-A-l-image-de-Christ.pptx
@@ -124,7 +124,7 @@
 <file path=ppt/revisionInfo.xml><?xml version="1.0" encoding="utf-8"?>
 <p1510:revInfo xmlns:a="http://schemas.openxmlformats.org/drawingml/2006/main" xmlns:r="http://schemas.openxmlformats.org/officeDocument/2006/relationships" xmlns:p1510="http://schemas.microsoft.com/office/powerpoint/2015/10/main">
   <p1510:revLst>
-    <p1510:client id="{E0A287C0-9FC5-4D7A-B26A-5C34583FEB53}" v="2" dt="2026-09-29T08:54:51.492"/>
+    <p1510:client id="{E0A287C0-9FC5-4D7A-B26A-5C34583FEB53}" v="4" dt="2026-09-30T12:24:07.535"/>
   </p1510:revLst>
 </p1510:revInfo>
 </file>
@@ -134,7 +134,7 @@
   <pc:docChgLst>
     <pc:chgData name="André-Guy Bruneau" userId="c9f3b82d5570fc32" providerId="LiveId" clId="{C4496A7D-9A64-4B82-9835-F710A7718518}"/>
     <pc:docChg chg="undo custSel addSld delSld modSld">
-      <pc:chgData name="André-Guy Bruneau" userId="c9f3b82d5570fc32" providerId="LiveId" clId="{C4496A7D-9A64-4B82-9835-F710A7718518}" dt="2026-09-29T09:45:25.643" v="886" actId="20577"/>
+      <pc:chgData name="André-Guy Bruneau" userId="c9f3b82d5570fc32" providerId="LiveId" clId="{C4496A7D-9A64-4B82-9835-F710A7718518}" dt="2026-09-30T12:44:02.224" v="1018" actId="6549"/>
       <pc:docMkLst>
         <pc:docMk/>
       </pc:docMkLst>
@@ -1365,7 +1365,7 @@
         </pc:sldMkLst>
       </pc:sldChg>
       <pc:sldChg chg="modSp add mod">
-        <pc:chgData name="André-Guy Bruneau" userId="c9f3b82d5570fc32" providerId="LiveId" clId="{C4496A7D-9A64-4B82-9835-F710A7718518}" dt="2026-09-29T09:22:01.640" v="650" actId="6549"/>
+        <pc:chgData name="André-Guy Bruneau" userId="c9f3b82d5570fc32" providerId="LiveId" clId="{C4496A7D-9A64-4B82-9835-F710A7718518}" dt="2026-09-30T12:44:02.224" v="1018" actId="6549"/>
         <pc:sldMkLst>
           <pc:docMk/>
           <pc:sldMk cId="867302485" sldId="286"/>
@@ -1378,9 +1378,17 @@
             <ac:spMk id="4" creationId="{00000000-0000-0000-0000-000000000000}"/>
           </ac:spMkLst>
         </pc:spChg>
+        <pc:spChg chg="mod">
+          <ac:chgData name="André-Guy Bruneau" userId="c9f3b82d5570fc32" providerId="LiveId" clId="{C4496A7D-9A64-4B82-9835-F710A7718518}" dt="2026-09-30T12:44:02.224" v="1018" actId="6549"/>
+          <ac:spMkLst>
+            <pc:docMk/>
+            <pc:sldMk cId="867302485" sldId="286"/>
+            <ac:spMk id="10" creationId="{00000000-0000-0000-0000-000000000000}"/>
+          </ac:spMkLst>
+        </pc:spChg>
       </pc:sldChg>
-      <pc:sldChg chg="modSp add mod">
-        <pc:chgData name="André-Guy Bruneau" userId="c9f3b82d5570fc32" providerId="LiveId" clId="{C4496A7D-9A64-4B82-9835-F710A7718518}" dt="2026-09-29T09:45:25.643" v="886" actId="20577"/>
+      <pc:sldChg chg="addSp delSp modSp add mod">
+        <pc:chgData name="André-Guy Bruneau" userId="c9f3b82d5570fc32" providerId="LiveId" clId="{C4496A7D-9A64-4B82-9835-F710A7718518}" dt="2026-09-30T12:34:11.640" v="1003" actId="20577"/>
         <pc:sldMkLst>
           <pc:docMk/>
           <pc:sldMk cId="2225491804" sldId="287"/>
@@ -1394,7 +1402,15 @@
           </ac:spMkLst>
         </pc:spChg>
         <pc:spChg chg="mod">
-          <ac:chgData name="André-Guy Bruneau" userId="c9f3b82d5570fc32" providerId="LiveId" clId="{C4496A7D-9A64-4B82-9835-F710A7718518}" dt="2026-09-29T09:45:07.618" v="869" actId="20577"/>
+          <ac:chgData name="André-Guy Bruneau" userId="c9f3b82d5570fc32" providerId="LiveId" clId="{C4496A7D-9A64-4B82-9835-F710A7718518}" dt="2026-09-30T12:24:43.361" v="927"/>
+          <ac:spMkLst>
+            <pc:docMk/>
+            <pc:sldMk cId="2225491804" sldId="287"/>
+            <ac:spMk id="15" creationId="{00000000-0000-0000-0000-000000000000}"/>
+          </ac:spMkLst>
+        </pc:spChg>
+        <pc:spChg chg="mod">
+          <ac:chgData name="André-Guy Bruneau" userId="c9f3b82d5570fc32" providerId="LiveId" clId="{C4496A7D-9A64-4B82-9835-F710A7718518}" dt="2026-09-30T12:22:17.151" v="924" actId="122"/>
           <ac:spMkLst>
             <pc:docMk/>
             <pc:sldMk cId="2225491804" sldId="287"/>
@@ -1410,7 +1426,15 @@
           </ac:spMkLst>
         </pc:spChg>
         <pc:spChg chg="mod">
-          <ac:chgData name="André-Guy Bruneau" userId="c9f3b82d5570fc32" providerId="LiveId" clId="{C4496A7D-9A64-4B82-9835-F710A7718518}" dt="2026-09-29T09:45:17.442" v="878" actId="20577"/>
+          <ac:chgData name="André-Guy Bruneau" userId="c9f3b82d5570fc32" providerId="LiveId" clId="{C4496A7D-9A64-4B82-9835-F710A7718518}" dt="2026-09-30T12:24:43.361" v="929"/>
+          <ac:spMkLst>
+            <pc:docMk/>
+            <pc:sldMk cId="2225491804" sldId="287"/>
+            <ac:spMk id="20" creationId="{00000000-0000-0000-0000-000000000000}"/>
+          </ac:spMkLst>
+        </pc:spChg>
+        <pc:spChg chg="mod">
+          <ac:chgData name="André-Guy Bruneau" userId="c9f3b82d5570fc32" providerId="LiveId" clId="{C4496A7D-9A64-4B82-9835-F710A7718518}" dt="2026-09-30T12:22:19.371" v="925" actId="122"/>
           <ac:spMkLst>
             <pc:docMk/>
             <pc:sldMk cId="2225491804" sldId="287"/>
@@ -1426,7 +1450,15 @@
           </ac:spMkLst>
         </pc:spChg>
         <pc:spChg chg="mod">
-          <ac:chgData name="André-Guy Bruneau" userId="c9f3b82d5570fc32" providerId="LiveId" clId="{C4496A7D-9A64-4B82-9835-F710A7718518}" dt="2026-09-29T09:45:25.643" v="886" actId="20577"/>
+          <ac:chgData name="André-Guy Bruneau" userId="c9f3b82d5570fc32" providerId="LiveId" clId="{C4496A7D-9A64-4B82-9835-F710A7718518}" dt="2026-09-30T12:24:43.361" v="931"/>
+          <ac:spMkLst>
+            <pc:docMk/>
+            <pc:sldMk cId="2225491804" sldId="287"/>
+            <ac:spMk id="25" creationId="{00000000-0000-0000-0000-000000000000}"/>
+          </ac:spMkLst>
+        </pc:spChg>
+        <pc:spChg chg="mod">
+          <ac:chgData name="André-Guy Bruneau" userId="c9f3b82d5570fc32" providerId="LiveId" clId="{C4496A7D-9A64-4B82-9835-F710A7718518}" dt="2026-09-30T12:22:21.644" v="926" actId="122"/>
           <ac:spMkLst>
             <pc:docMk/>
             <pc:sldMk cId="2225491804" sldId="287"/>
@@ -1441,6 +1473,70 @@
             <ac:spMk id="28" creationId="{00000000-0000-0000-0000-000000000000}"/>
           </ac:spMkLst>
         </pc:spChg>
+        <pc:spChg chg="mod">
+          <ac:chgData name="André-Guy Bruneau" userId="c9f3b82d5570fc32" providerId="LiveId" clId="{C4496A7D-9A64-4B82-9835-F710A7718518}" dt="2026-09-30T12:31:32.600" v="933" actId="14100"/>
+          <ac:spMkLst>
+            <pc:docMk/>
+            <pc:sldMk cId="2225491804" sldId="287"/>
+            <ac:spMk id="50" creationId="{58E43F81-CDF3-49D0-95E5-8EC85AF8BE78}"/>
+          </ac:spMkLst>
+        </pc:spChg>
+        <pc:spChg chg="add mod">
+          <ac:chgData name="André-Guy Bruneau" userId="c9f3b82d5570fc32" providerId="LiveId" clId="{C4496A7D-9A64-4B82-9835-F710A7718518}" dt="2026-09-30T12:34:11.640" v="1003" actId="20577"/>
+          <ac:spMkLst>
+            <pc:docMk/>
+            <pc:sldMk cId="2225491804" sldId="287"/>
+            <ac:spMk id="55" creationId="{DC1F5BE0-5C8D-E461-DE32-3D57EAE8D1EA}"/>
+          </ac:spMkLst>
+        </pc:spChg>
+        <pc:grpChg chg="mod">
+          <ac:chgData name="André-Guy Bruneau" userId="c9f3b82d5570fc32" providerId="LiveId" clId="{C4496A7D-9A64-4B82-9835-F710A7718518}" dt="2026-09-30T12:33:12.881" v="946" actId="14100"/>
+          <ac:grpSpMkLst>
+            <pc:docMk/>
+            <pc:sldMk cId="2225491804" sldId="287"/>
+            <ac:grpSpMk id="51" creationId="{01BA40E9-A651-A83A-2936-A9B01F4B384F}"/>
+          </ac:grpSpMkLst>
+        </pc:grpChg>
+        <pc:picChg chg="mod">
+          <ac:chgData name="André-Guy Bruneau" userId="c9f3b82d5570fc32" providerId="LiveId" clId="{C4496A7D-9A64-4B82-9835-F710A7718518}" dt="2026-09-30T12:33:30.557" v="967" actId="1038"/>
+          <ac:picMkLst>
+            <pc:docMk/>
+            <pc:sldMk cId="2225491804" sldId="287"/>
+            <ac:picMk id="11" creationId="{00000000-0000-0000-0000-000000000000}"/>
+          </ac:picMkLst>
+        </pc:picChg>
+        <pc:picChg chg="mod">
+          <ac:chgData name="André-Guy Bruneau" userId="c9f3b82d5570fc32" providerId="LiveId" clId="{C4496A7D-9A64-4B82-9835-F710A7718518}" dt="2026-09-30T12:24:43.361" v="928"/>
+          <ac:picMkLst>
+            <pc:docMk/>
+            <pc:sldMk cId="2225491804" sldId="287"/>
+            <ac:picMk id="16" creationId="{00000000-0000-0000-0000-000000000000}"/>
+          </ac:picMkLst>
+        </pc:picChg>
+        <pc:picChg chg="mod">
+          <ac:chgData name="André-Guy Bruneau" userId="c9f3b82d5570fc32" providerId="LiveId" clId="{C4496A7D-9A64-4B82-9835-F710A7718518}" dt="2026-09-30T12:24:43.361" v="930"/>
+          <ac:picMkLst>
+            <pc:docMk/>
+            <pc:sldMk cId="2225491804" sldId="287"/>
+            <ac:picMk id="21" creationId="{00000000-0000-0000-0000-000000000000}"/>
+          </ac:picMkLst>
+        </pc:picChg>
+        <pc:picChg chg="mod">
+          <ac:chgData name="André-Guy Bruneau" userId="c9f3b82d5570fc32" providerId="LiveId" clId="{C4496A7D-9A64-4B82-9835-F710A7718518}" dt="2026-09-30T12:24:43.361" v="932"/>
+          <ac:picMkLst>
+            <pc:docMk/>
+            <pc:sldMk cId="2225491804" sldId="287"/>
+            <ac:picMk id="26" creationId="{00000000-0000-0000-0000-000000000000}"/>
+          </ac:picMkLst>
+        </pc:picChg>
+        <pc:picChg chg="add del mod">
+          <ac:chgData name="André-Guy Bruneau" userId="c9f3b82d5570fc32" providerId="LiveId" clId="{C4496A7D-9A64-4B82-9835-F710A7718518}" dt="2026-09-30T12:33:50.531" v="970" actId="931"/>
+          <ac:picMkLst>
+            <pc:docMk/>
+            <pc:sldMk cId="2225491804" sldId="287"/>
+            <ac:picMk id="53" creationId="{62E394E2-F5B1-FCD7-5E30-97475B681B17}"/>
+          </ac:picMkLst>
+        </pc:picChg>
       </pc:sldChg>
       <pc:sldChg chg="modSp add mod">
         <pc:chgData name="André-Guy Bruneau" userId="c9f3b82d5570fc32" providerId="LiveId" clId="{C4496A7D-9A64-4B82-9835-F710A7718518}" dt="2026-09-29T09:23:57.659" v="657" actId="6549"/>
@@ -8703,6 +8799,17 @@
               <a:buNone/>
             </a:pPr>
             <a:r>
+              <a:rPr lang="fr-CA" sz="1700" b="1" i="1" dirty="0" err="1">
+                <a:solidFill>
+                  <a:srgbClr val="E8742A"/>
+                </a:solidFill>
+                <a:latin typeface="Calibri" pitchFamily="34" charset="0"/>
+                <a:ea typeface="Calibri" pitchFamily="34" charset="-122"/>
+                <a:cs typeface="Calibri" pitchFamily="34" charset="-120"/>
+              </a:rPr>
+              <a:t>Tselem</a:t>
+            </a:r>
+            <a:r>
               <a:rPr lang="fr-CA" sz="1700" b="1" i="1" dirty="0">
                 <a:solidFill>
                   <a:srgbClr val="E8742A"/>
@@ -8711,7 +8818,29 @@
                 <a:ea typeface="Calibri" pitchFamily="34" charset="-122"/>
                 <a:cs typeface="Calibri" pitchFamily="34" charset="-120"/>
               </a:rPr>
-              <a:t>tselem</a:t>
+              <a:t> / </a:t>
+            </a:r>
+            <a:r>
+              <a:rPr lang="fr-CA" sz="1700" b="1" i="1" dirty="0" err="1">
+                <a:solidFill>
+                  <a:srgbClr val="E8742A"/>
+                </a:solidFill>
+                <a:latin typeface="Calibri" pitchFamily="34" charset="0"/>
+                <a:ea typeface="Calibri" pitchFamily="34" charset="-122"/>
+                <a:cs typeface="Calibri" pitchFamily="34" charset="-120"/>
+              </a:rPr>
+              <a:t>eikôn</a:t>
+            </a:r>
+            <a:r>
+              <a:rPr lang="fr-CA" sz="1700">
+                <a:solidFill>
+                  <a:srgbClr val="A89A8C"/>
+                </a:solidFill>
+                <a:latin typeface="Calibri" pitchFamily="34" charset="0"/>
+                <a:ea typeface="Calibri" pitchFamily="34" charset="-122"/>
+                <a:cs typeface="Calibri" pitchFamily="34" charset="-120"/>
+              </a:rPr>
+              <a:t> : </a:t>
             </a:r>
             <a:r>
               <a:rPr lang="fr-CA" sz="1700" dirty="0">
@@ -8722,7 +8851,7 @@
                 <a:ea typeface="Calibri" pitchFamily="34" charset="-122"/>
                 <a:cs typeface="Calibri" pitchFamily="34" charset="-120"/>
               </a:rPr>
-              <a:t> : image, effigie</a:t>
+              <a:t>image, effigie</a:t>
             </a:r>
             <a:endParaRPr lang="fr-CA" sz="1700" dirty="0"/>
           </a:p>
@@ -10523,7 +10652,7 @@
         </p:nvSpPr>
         <p:spPr>
           <a:xfrm>
-            <a:off x="4937760" y="2560320"/>
+            <a:off x="5509260" y="2560320"/>
             <a:ext cx="640080" cy="640080"/>
           </a:xfrm>
           <a:prstGeom prst="ellipse">
@@ -10563,7 +10692,7 @@
         </p:blipFill>
         <p:spPr>
           <a:xfrm>
-            <a:off x="5065776" y="2688336"/>
+            <a:off x="5637276" y="2688336"/>
             <a:ext cx="384048" cy="384048"/>
           </a:xfrm>
           <a:prstGeom prst="rect">
@@ -10592,7 +10721,7 @@
           <a:bodyPr wrap="square" lIns="0" tIns="0" rIns="0" bIns="0" rtlCol="0" anchor="t"/>
           <a:lstStyle/>
           <a:p>
-            <a:pPr marL="0" indent="0">
+            <a:pPr marL="0" indent="0" algn="ctr">
               <a:buNone/>
             </a:pPr>
             <a:r>
@@ -10691,7 +10820,7 @@
         </p:nvSpPr>
         <p:spPr>
           <a:xfrm>
-            <a:off x="7315200" y="2560320"/>
+            <a:off x="7886700" y="2560320"/>
             <a:ext cx="640080" cy="640080"/>
           </a:xfrm>
           <a:prstGeom prst="ellipse">
@@ -10731,7 +10860,7 @@
         </p:blipFill>
         <p:spPr>
           <a:xfrm>
-            <a:off x="7443216" y="2688336"/>
+            <a:off x="8014716" y="2688336"/>
             <a:ext cx="384048" cy="384048"/>
           </a:xfrm>
           <a:prstGeom prst="rect">
@@ -10760,7 +10889,7 @@
           <a:bodyPr wrap="square" lIns="0" tIns="0" rIns="0" bIns="0" rtlCol="0" anchor="t"/>
           <a:lstStyle/>
           <a:p>
-            <a:pPr marL="0" indent="0">
+            <a:pPr marL="0" indent="0" algn="ctr">
               <a:buNone/>
             </a:pPr>
             <a:r>
@@ -10772,7 +10901,7 @@
                 <a:ea typeface="Calibri" pitchFamily="34" charset="-122"/>
                 <a:cs typeface="Calibri" pitchFamily="34" charset="-120"/>
               </a:rPr>
-              <a:t>Morale - Valeur</a:t>
+              <a:t>Morale - Éthique</a:t>
             </a:r>
             <a:endParaRPr lang="fr-CA" sz="2000" dirty="0"/>
           </a:p>
@@ -10859,7 +10988,7 @@
         </p:nvSpPr>
         <p:spPr>
           <a:xfrm>
-            <a:off x="9692640" y="2560320"/>
+            <a:off x="10264140" y="2560320"/>
             <a:ext cx="640080" cy="640080"/>
           </a:xfrm>
           <a:prstGeom prst="ellipse">
@@ -10899,7 +11028,7 @@
         </p:blipFill>
         <p:spPr>
           <a:xfrm>
-            <a:off x="9820656" y="2688336"/>
+            <a:off x="10392156" y="2688336"/>
             <a:ext cx="384048" cy="384048"/>
           </a:xfrm>
           <a:prstGeom prst="rect">
@@ -10928,7 +11057,7 @@
           <a:bodyPr wrap="square" lIns="0" tIns="0" rIns="0" bIns="0" rtlCol="0" anchor="t"/>
           <a:lstStyle/>
           <a:p>
-            <a:pPr marL="0" indent="0">
+            <a:pPr marL="0" indent="0" algn="ctr">
               <a:buNone/>
             </a:pPr>
             <a:r>
@@ -10940,7 +11069,7 @@
                 <a:ea typeface="Calibri" pitchFamily="34" charset="-122"/>
                 <a:cs typeface="Calibri" pitchFamily="34" charset="-120"/>
               </a:rPr>
-              <a:t>Relation - Amour</a:t>
+              <a:t> Communion</a:t>
             </a:r>
             <a:endParaRPr lang="fr-CA" sz="2000" dirty="0"/>
           </a:p>
@@ -11884,10 +12013,10 @@
         </p:nvGrpSpPr>
         <p:grpSpPr>
           <a:xfrm>
-            <a:off x="0" y="1343472"/>
-            <a:ext cx="4754880" cy="4279392"/>
-            <a:chOff x="0" y="1521272"/>
-            <a:chExt cx="4754880" cy="4279392"/>
+            <a:off x="97100" y="1595065"/>
+            <a:ext cx="4476036" cy="4027800"/>
+            <a:chOff x="260370" y="1913435"/>
+            <a:chExt cx="4319144" cy="3887229"/>
           </a:xfrm>
         </p:grpSpPr>
         <p:pic>
@@ -11906,8 +12035,8 @@
           </p:blipFill>
           <p:spPr>
             <a:xfrm>
-              <a:off x="0" y="1521272"/>
-              <a:ext cx="4754880" cy="4279392"/>
+              <a:off x="260370" y="1913435"/>
+              <a:ext cx="4319144" cy="3887229"/>
             </a:xfrm>
             <a:prstGeom prst="rect">
               <a:avLst/>
@@ -11929,7 +12058,7 @@
           <p:spPr>
             <a:xfrm>
               <a:off x="1104900" y="5195530"/>
-              <a:ext cx="2540000" cy="304800"/>
+              <a:ext cx="2540000" cy="468670"/>
             </a:xfrm>
             <a:prstGeom prst="rect">
               <a:avLst/>
@@ -11964,6 +12093,48 @@
           </p:txBody>
         </p:sp>
       </p:grpSp>
+      <p:sp>
+        <p:nvSpPr>
+          <p:cNvPr id="55" name="Légende : Périchorèse">
+            <a:extLst>
+              <a:ext uri="{FF2B5EF4-FFF2-40B4-BE49-F238E27FC236}">
+                <a16:creationId xmlns:a16="http://schemas.microsoft.com/office/drawing/2014/main" id="{DC1F5BE0-5C8D-E461-DE32-3D57EAE8D1EA}"/>
+              </a:ext>
+            </a:extLst>
+          </p:cNvPr>
+          <p:cNvSpPr txBox="1"/>
+          <p:nvPr/>
+        </p:nvSpPr>
+        <p:spPr>
+          <a:xfrm>
+            <a:off x="1013230" y="1691272"/>
+            <a:ext cx="2632265" cy="485618"/>
+          </a:xfrm>
+          <a:prstGeom prst="rect">
+            <a:avLst/>
+          </a:prstGeom>
+          <a:noFill/>
+        </p:spPr>
+        <p:txBody>
+          <a:bodyPr vertOverflow="overflow" vert="horz" wrap="none" rtlCol="0" anchor="ctr" anchorCtr="0">
+            <a:noAutofit/>
+          </a:bodyPr>
+          <a:lstStyle/>
+          <a:p>
+            <a:pPr algn="ctr"/>
+            <a:r>
+              <a:rPr lang="fr-CA" sz="2400" b="1" i="1" dirty="0">
+                <a:solidFill>
+                  <a:srgbClr val="E8742A"/>
+                </a:solidFill>
+                <a:latin typeface="Cambria"/>
+                <a:ea typeface="Cambria"/>
+              </a:rPr>
+              <a:t>Relation Divine</a:t>
+            </a:r>
+          </a:p>
+        </p:txBody>
+      </p:sp>
     </p:spTree>
     <p:extLst>
       <p:ext uri="{BB962C8B-B14F-4D97-AF65-F5344CB8AC3E}">
@@ -20839,7 +21010,7 @@
 
 <file path=ppt/webextensions/taskpanes.xml><?xml version="1.0" encoding="utf-8"?>
 <wetp:taskpanes xmlns:wetp="http://schemas.microsoft.com/office/webextensions/taskpanes/2010/11">
-  <wetp:taskpane dockstate="right" visibility="0" width="438" row="1">
+  <wetp:taskpane dockstate="right" visibility="0" width="438" row="0">
     <wetp:webextensionref xmlns:r="http://schemas.openxmlformats.org/officeDocument/2006/relationships" r:id="rId1"/>
   </wetp:taskpane>
 </wetp:taskpanes>

</xml_diff>

<commit_message>
Restructure les notes de la présentation selon le plan et la recherche
Chaque diapositive suit le même gabarit : durée et texte, phrase clé,
sections A/B/C titrées comme dans le plan, puis Application, Transition
et À éviter (les pièges du plan, placés sur leur diapositive).

Ajouts pour conformité au plan : Genèse 5.1-2 (I), trois dimensions de
l'image reliées au cœur du point V, Éphésiens 1.4 et la chaîne de
Romains 8.29-30 (III), 1 Jean 3.2 (IV), détail des trois dimensions du
cœur (V), « Christ, la Parole » et l'appel complet (conclusion),
lecture recommandée (Rappel), but et phrase à retenir (titre).

Seules les notes du .pptx changent (injectées sans toucher aux
diapositives); deck.js porte les mêmes notes.

Co-Authored-By: Claude Opus 5.5 <noreply@anthropic.com>
</commit_message>
<xml_diff>
--- a/Presentation-A-l-image-de-Christ.pptx
+++ b/Presentation-A-l-image-de-Christ.pptx
@@ -1850,6 +1850,18 @@
           <a:bodyPr/>
           <a:lstStyle/>
           <a:p>
+            <a:pPr marL="0" indent="0">
+              <a:spcBef>
+                <a:spcPts val="600"/>
+              </a:spcBef>
+              <a:buNone/>
+            </a:pPr>
+            <a:r>
+              <a:rPr lang="fr-CA" sz="1400" b="1" dirty="0"/>
+              <a:t>Avant de commencer</a:t>
+            </a:r>
+          </a:p>
+          <a:p>
             <a:pPr marL="228600" indent="-228600">
               <a:spcBef>
                 <a:spcPts val="300"/>
@@ -1881,6 +1893,57 @@
             <a:r>
               <a:rPr lang="fr-CA" sz="1400" dirty="0"/>
               <a:t>45 minutes.</a:t>
+            </a:r>
+          </a:p>
+          <a:p>
+            <a:pPr marL="228600" indent="-228600">
+              <a:spcBef>
+                <a:spcPts val="300"/>
+              </a:spcBef>
+              <a:buFont typeface="Arial"/>
+              <a:buChar char="•"/>
+            </a:pPr>
+            <a:r>
+              <a:rPr lang="fr-CA" sz="1400" b="1" dirty="0"/>
+              <a:t>Phrase à faire retenir : </a:t>
+            </a:r>
+            <a:r>
+              <a:rPr lang="fr-CA" sz="1400" dirty="0"/>
+              <a:t>Créés à son image, restaurés en Christ, transformés par l'Esprit, envoyés en son nom.</a:t>
+            </a:r>
+          </a:p>
+          <a:p>
+            <a:pPr marL="228600" indent="-228600">
+              <a:spcBef>
+                <a:spcPts val="300"/>
+              </a:spcBef>
+              <a:buFont typeface="Arial"/>
+              <a:buChar char="•"/>
+            </a:pPr>
+            <a:r>
+              <a:rPr lang="fr-CA" sz="1400" b="1" dirty="0"/>
+              <a:t>But : </a:t>
+            </a:r>
+            <a:r>
+              <a:rPr lang="fr-CA" sz="1400" dirty="0"/>
+              <a:t>que l'incroyant voie qu'il porte une image qu'il ne peut restaurer et un commandement qu'il n'a jamais accompli, et se tourne vers Christ; que le croyant repose sa sanctification sur le dessein de Dieu et l'œuvre de l'Esprit, contemple Christ dans la Parole et fasse des disciples.</a:t>
+            </a:r>
+          </a:p>
+          <a:p>
+            <a:pPr marL="228600" indent="-228600">
+              <a:spcBef>
+                <a:spcPts val="300"/>
+              </a:spcBef>
+              <a:buFont typeface="Arial"/>
+              <a:buChar char="•"/>
+            </a:pPr>
+            <a:r>
+              <a:rPr lang="fr-CA" sz="1400" b="1" dirty="0"/>
+              <a:t>Citations : </a:t>
+            </a:r>
+            <a:r>
+              <a:rPr lang="fr-CA" sz="1400" dirty="0"/>
+              <a:t>NEG79; Jérémie 31.33 en NBS.</a:t>
             </a:r>
           </a:p>
         </p:txBody>
@@ -1973,7 +2036,19 @@
             </a:pPr>
             <a:r>
               <a:rPr lang="fr-CA" sz="1400" b="1" dirty="0"/>
-              <a:t>3 min.</a:t>
+              <a:t>3 min · 2 Corinthiens 3.18</a:t>
+            </a:r>
+          </a:p>
+          <a:p>
+            <a:pPr marL="0" indent="0">
+              <a:spcBef>
+                <a:spcPts val="600"/>
+              </a:spcBef>
+              <a:buNone/>
+            </a:pPr>
+            <a:r>
+              <a:rPr lang="fr-CA" sz="1400" b="1" dirty="0"/>
+              <a:t>Récapitulation</a:t>
             </a:r>
           </a:p>
           <a:p>
@@ -1985,78 +2060,8 @@
               <a:buChar char="•"/>
             </a:pPr>
             <a:r>
-              <a:rPr lang="fr-CA" sz="1400" b="1" dirty="0"/>
-              <a:t>Récapitulation :</a:t>
-            </a:r>
-          </a:p>
-          <a:p>
-            <a:pPr marL="457200" indent="-228600">
-              <a:buFont typeface="Arial"/>
-              <a:buChar char="–"/>
-            </a:pPr>
-            <a:r>
               <a:rPr lang="fr-CA" sz="1400" dirty="0"/>
-              <a:t>créés à son image,</a:t>
-            </a:r>
-          </a:p>
-          <a:p>
-            <a:pPr marL="457200" indent="-228600">
-              <a:buFont typeface="Arial"/>
-              <a:buChar char="–"/>
-            </a:pPr>
-            <a:r>
-              <a:rPr lang="fr-CA" sz="1400" dirty="0"/>
-              <a:t>ternis par le péché,</a:t>
-            </a:r>
-          </a:p>
-          <a:p>
-            <a:pPr marL="457200" indent="-228600">
-              <a:buFont typeface="Arial"/>
-              <a:buChar char="–"/>
-            </a:pPr>
-            <a:r>
-              <a:rPr lang="fr-CA" sz="1400" dirty="0"/>
-              <a:t>restaurés en Christ,</a:t>
-            </a:r>
-          </a:p>
-          <a:p>
-            <a:pPr marL="457200" indent="-228600">
-              <a:buFont typeface="Arial"/>
-              <a:buChar char="–"/>
-            </a:pPr>
-            <a:r>
-              <a:rPr lang="fr-CA" sz="1400" dirty="0"/>
-              <a:t>promis à sa ressemblance,</a:t>
-            </a:r>
-          </a:p>
-          <a:p>
-            <a:pPr marL="457200" indent="-228600">
-              <a:buFont typeface="Arial"/>
-              <a:buChar char="–"/>
-            </a:pPr>
-            <a:r>
-              <a:rPr lang="fr-CA" sz="1400" dirty="0"/>
-              <a:t>transformés par l'Esprit,</a:t>
-            </a:r>
-          </a:p>
-          <a:p>
-            <a:pPr marL="457200" indent="-228600">
-              <a:buFont typeface="Arial"/>
-              <a:buChar char="–"/>
-            </a:pPr>
-            <a:r>
-              <a:rPr lang="fr-CA" sz="1400" dirty="0"/>
-              <a:t>renouvelés au cœur,</a:t>
-            </a:r>
-          </a:p>
-          <a:p>
-            <a:pPr marL="457200" indent="-228600">
-              <a:buFont typeface="Arial"/>
-              <a:buChar char="–"/>
-            </a:pPr>
-            <a:r>
-              <a:rPr lang="fr-CA" sz="1400" dirty="0"/>
-              <a:t>envoyés en son nom.</a:t>
+              <a:t>créés à son image (Gn 1.26-27),</a:t>
             </a:r>
           </a:p>
           <a:p>
@@ -2069,7 +2074,156 @@
             </a:pPr>
             <a:r>
               <a:rPr lang="fr-CA" sz="1400" dirty="0"/>
-              <a:t>Appel à l'incroyant, puis au croyant.</a:t>
+              <a:t>ternis par le péché (Gn 5.3),</a:t>
+            </a:r>
+          </a:p>
+          <a:p>
+            <a:pPr marL="228600" indent="-228600">
+              <a:spcBef>
+                <a:spcPts val="300"/>
+              </a:spcBef>
+              <a:buFont typeface="Arial"/>
+              <a:buChar char="•"/>
+            </a:pPr>
+            <a:r>
+              <a:rPr lang="fr-CA" sz="1400" dirty="0"/>
+              <a:t>restaurés en Christ (Col 1.15),</a:t>
+            </a:r>
+          </a:p>
+          <a:p>
+            <a:pPr marL="228600" indent="-228600">
+              <a:spcBef>
+                <a:spcPts val="300"/>
+              </a:spcBef>
+              <a:buFont typeface="Arial"/>
+              <a:buChar char="•"/>
+            </a:pPr>
+            <a:r>
+              <a:rPr lang="fr-CA" sz="1400" dirty="0"/>
+              <a:t>promis à sa ressemblance (Rm 8.29),</a:t>
+            </a:r>
+          </a:p>
+          <a:p>
+            <a:pPr marL="228600" indent="-228600">
+              <a:spcBef>
+                <a:spcPts val="300"/>
+              </a:spcBef>
+              <a:buFont typeface="Arial"/>
+              <a:buChar char="•"/>
+            </a:pPr>
+            <a:r>
+              <a:rPr lang="fr-CA" sz="1400" dirty="0"/>
+              <a:t>transformés par l'Esprit (2 Co 3.18),</a:t>
+            </a:r>
+          </a:p>
+          <a:p>
+            <a:pPr marL="228600" indent="-228600">
+              <a:spcBef>
+                <a:spcPts val="300"/>
+              </a:spcBef>
+              <a:buFont typeface="Arial"/>
+              <a:buChar char="•"/>
+            </a:pPr>
+            <a:r>
+              <a:rPr lang="fr-CA" sz="1400" dirty="0"/>
+              <a:t>renouvelés au cœur (Jr 31.33),</a:t>
+            </a:r>
+          </a:p>
+          <a:p>
+            <a:pPr marL="228600" indent="-228600">
+              <a:spcBef>
+                <a:spcPts val="300"/>
+              </a:spcBef>
+              <a:buFont typeface="Arial"/>
+              <a:buChar char="•"/>
+            </a:pPr>
+            <a:r>
+              <a:rPr lang="fr-CA" sz="1400" dirty="0"/>
+              <a:t>aimés et envoyés en son nom (Mt 22.37-40; 28.19).</a:t>
+            </a:r>
+          </a:p>
+          <a:p>
+            <a:pPr marL="0" indent="0">
+              <a:spcBef>
+                <a:spcPts val="600"/>
+              </a:spcBef>
+              <a:buNone/>
+            </a:pPr>
+            <a:r>
+              <a:rPr lang="fr-CA" sz="1400" b="1" dirty="0"/>
+              <a:t>Christ, la Parole</a:t>
+            </a:r>
+          </a:p>
+          <a:p>
+            <a:pPr marL="228600" indent="-228600">
+              <a:spcBef>
+                <a:spcPts val="300"/>
+              </a:spcBef>
+              <a:buFont typeface="Arial"/>
+              <a:buChar char="•"/>
+            </a:pPr>
+            <a:r>
+              <a:rPr lang="fr-CA" sz="1400" dirty="0"/>
+              <a:t>Le Dieu qui a soufflé l'Écriture (Rappel) se fait voir en son Fils, le Logos (Jn 1.1).</a:t>
+            </a:r>
+          </a:p>
+          <a:p>
+            <a:pPr marL="228600" indent="-228600">
+              <a:spcBef>
+                <a:spcPts val="300"/>
+              </a:spcBef>
+              <a:buFont typeface="Arial"/>
+              <a:buChar char="•"/>
+            </a:pPr>
+            <a:r>
+              <a:rPr lang="fr-CA" sz="1400" dirty="0"/>
+              <a:t>C'est dans la Parole qu'on le contemple, et l'Esprit transforme en son image, de gloire en gloire.</a:t>
+            </a:r>
+          </a:p>
+          <a:p>
+            <a:pPr marL="0" indent="0">
+              <a:spcBef>
+                <a:spcPts val="600"/>
+              </a:spcBef>
+              <a:buNone/>
+            </a:pPr>
+            <a:r>
+              <a:rPr lang="fr-CA" sz="1400" b="1" dirty="0"/>
+              <a:t>Appel</a:t>
+            </a:r>
+          </a:p>
+          <a:p>
+            <a:pPr marL="228600" indent="-228600">
+              <a:spcBef>
+                <a:spcPts val="300"/>
+              </a:spcBef>
+              <a:buFont typeface="Arial"/>
+              <a:buChar char="•"/>
+            </a:pPr>
+            <a:r>
+              <a:rPr lang="fr-CA" sz="1400" b="1" dirty="0"/>
+              <a:t>À l'incroyant : </a:t>
+            </a:r>
+            <a:r>
+              <a:rPr lang="fr-CA" sz="1400" dirty="0"/>
+              <a:t>vous portez l'image de Dieu, et vous n'avez jamais aimé Dieu de tout votre cœur. Christ seul pardonne et restaure : repentez-vous, croyez en lui et soumettez-vous à lui comme Seigneur.</a:t>
+            </a:r>
+          </a:p>
+          <a:p>
+            <a:pPr marL="228600" indent="-228600">
+              <a:spcBef>
+                <a:spcPts val="300"/>
+              </a:spcBef>
+              <a:buFont typeface="Arial"/>
+              <a:buChar char="•"/>
+            </a:pPr>
+            <a:r>
+              <a:rPr lang="fr-CA" sz="1400" b="1" dirty="0"/>
+              <a:t>Au croyant : </a:t>
+            </a:r>
+            <a:r>
+              <a:rPr lang="fr-CA" sz="1400" dirty="0"/>
+              <a:t>Dieu achèvera en vous ce qu'il a décidé avant la fondation du monde; nous serons semblables à lui (1 Jn 3.2). Contemplez Christ dans sa Parole; c'est ainsi que l'Esprit vous transforme. Et allez : faites des disciples.</a:t>
             </a:r>
           </a:p>
         </p:txBody>
@@ -2162,7 +2316,7 @@
             </a:pPr>
             <a:r>
               <a:rPr lang="fr-CA" sz="1400" b="1" dirty="0"/>
-              <a:t>2 min.</a:t>
+              <a:t>2 min · 2 Timothée 3.16-17</a:t>
             </a:r>
           </a:p>
           <a:p>
@@ -2174,8 +2328,12 @@
               <a:buChar char="•"/>
             </a:pPr>
             <a:r>
+              <a:rPr lang="fr-CA" sz="1400" b="1" dirty="0"/>
+              <a:t>Lire </a:t>
+            </a:r>
+            <a:r>
               <a:rPr lang="fr-CA" sz="1400" dirty="0"/>
-              <a:t>Lire 2 Timothée 3.16-17.</a:t>
+              <a:t>2 Timothée 3.16-17.</a:t>
             </a:r>
           </a:p>
           <a:p>
@@ -2192,7 +2350,7 @@
             </a:r>
             <a:r>
               <a:rPr lang="fr-CA" sz="1400" dirty="0"/>
-              <a:t>« soufflée par Dieu ».</a:t>
+              <a:t>« soufflée par Dieu ». « Ce que l'Écriture dit, Dieu le dit » (55-17).</a:t>
             </a:r>
           </a:p>
           <a:p>
@@ -2204,8 +2362,12 @@
               <a:buChar char="•"/>
             </a:pPr>
             <a:r>
+              <a:rPr lang="fr-CA" sz="1400" b="1" dirty="0"/>
+              <a:t>Quatre œuvres : </a:t>
+            </a:r>
+            <a:r>
               <a:rPr lang="fr-CA" sz="1400" dirty="0"/>
-              <a:t>« Ce que l'Écriture dit, Dieu le dit » (55-17).</a:t>
+              <a:t>enseigner, convaincre, corriger, instruire dans la justice (55-19).</a:t>
             </a:r>
           </a:p>
           <a:p>
@@ -2217,8 +2379,12 @@
               <a:buChar char="•"/>
             </a:pPr>
             <a:r>
+              <a:rPr lang="fr-CA" sz="1400" b="1" dirty="0"/>
+              <a:t>But : </a:t>
+            </a:r>
+            <a:r>
               <a:rPr lang="fr-CA" sz="1400" dirty="0"/>
-              <a:t>Enseigner, convaincre, corriger, instruire dans la justice (55-19).</a:t>
+              <a:t>que l'homme de Dieu soit propre non à la plupart des bonnes œuvres, mais à toutes (55-19).</a:t>
             </a:r>
           </a:p>
           <a:p>
@@ -2231,11 +2397,28 @@
             </a:pPr>
             <a:r>
               <a:rPr lang="fr-CA" sz="1400" b="1" dirty="0"/>
-              <a:t>Pierre d'attente : </a:t>
+              <a:t>Lecture recommandée : </a:t>
             </a:r>
             <a:r>
               <a:rPr lang="fr-CA" sz="1400" dirty="0"/>
-              <a:t>au point IV, l'Écriture est le miroir.</a:t>
+              <a:t>Stephen Yuille, Le sentier de la vie. La richesse du Psaume 119 (Europresse).</a:t>
+            </a:r>
+          </a:p>
+          <a:p>
+            <a:pPr marL="228600" indent="-228600">
+              <a:spcBef>
+                <a:spcPts val="300"/>
+              </a:spcBef>
+              <a:buFont typeface="Arial"/>
+              <a:buChar char="•"/>
+            </a:pPr>
+            <a:r>
+              <a:rPr lang="fr-CA" sz="1400" b="1" dirty="0"/>
+              <a:t>Pierre d'attente → IV : </a:t>
+            </a:r>
+            <a:r>
+              <a:rPr lang="fr-CA" sz="1400" dirty="0"/>
+              <a:t>l'Écriture est le miroir.</a:t>
             </a:r>
           </a:p>
         </p:txBody>
@@ -2328,7 +2511,19 @@
             </a:pPr>
             <a:r>
               <a:rPr lang="fr-CA" sz="1400" b="1" dirty="0"/>
-              <a:t>3 min.</a:t>
+              <a:t>3 min · Genèse 1.27</a:t>
+            </a:r>
+          </a:p>
+          <a:p>
+            <a:pPr marL="0" indent="0">
+              <a:spcBef>
+                <a:spcPts val="600"/>
+              </a:spcBef>
+              <a:buNone/>
+            </a:pPr>
+            <a:r>
+              <a:rPr lang="fr-CA" sz="1400" b="1" dirty="0"/>
+              <a:t>Accroche</a:t>
             </a:r>
           </a:p>
           <a:p>
@@ -2347,21 +2542,29 @@
           <a:p>
             <a:pPr marL="457200" indent="-228600">
               <a:buFont typeface="Arial"/>
-              <a:buChar char="–"/>
-            </a:pPr>
+              <a:buChar char="•"/>
+            </a:pPr>
+            <a:r>
+              <a:rPr lang="fr-CA" sz="1400" b="1" dirty="0"/>
+              <a:t>Égypte : </a:t>
+            </a:r>
             <a:r>
               <a:rPr lang="fr-CA" sz="1400" dirty="0"/>
-              <a:t>Toutânkhamon signifie « image vivante d'Amon »;</a:t>
+              <a:t>le pharaon en portait le titre; Toutânkhamon signifie « image vivante d'Amon ».</a:t>
             </a:r>
           </a:p>
           <a:p>
             <a:pPr marL="457200" indent="-228600">
               <a:buFont typeface="Arial"/>
-              <a:buChar char="–"/>
-            </a:pPr>
+              <a:buChar char="•"/>
+            </a:pPr>
+            <a:r>
+              <a:rPr lang="fr-CA" sz="1400" b="1" dirty="0"/>
+              <a:t>Mésopotamie : </a:t>
+            </a:r>
             <a:r>
               <a:rPr lang="fr-CA" sz="1400" dirty="0"/>
-              <a:t>en Mésopotamie, le roi dressait son effigie aux confins de ses territoires.</a:t>
+              <a:t>le roi dressait son effigie aux confins de ses territoires pour y marquer sa souveraineté.</a:t>
             </a:r>
           </a:p>
           <a:p>
@@ -2386,8 +2589,24 @@
               <a:buChar char="•"/>
             </a:pPr>
             <a:r>
+              <a:rPr lang="fr-CA" sz="1400" b="1" dirty="0"/>
+              <a:t>Tselem </a:t>
+            </a:r>
+            <a:r>
               <a:rPr lang="fr-CA" sz="1400" dirty="0"/>
-              <a:t>Tselem désigne ailleurs les statues cultuelles.</a:t>
+              <a:t>(eikôn dans la Septante) désigne ailleurs les statues cultuelles (Nb 33.52; 2 R 11.18).</a:t>
+            </a:r>
+          </a:p>
+          <a:p>
+            <a:pPr marL="0" indent="0">
+              <a:spcBef>
+                <a:spcPts val="600"/>
+              </a:spcBef>
+              <a:buNone/>
+            </a:pPr>
+            <a:r>
+              <a:rPr lang="fr-CA" sz="1400" b="1" dirty="0"/>
+              <a:t>Question</a:t>
             </a:r>
           </a:p>
           <a:p>
@@ -2399,28 +2618,46 @@
               <a:buChar char="•"/>
             </a:pPr>
             <a:r>
-              <a:rPr lang="fr-CA" sz="1400" b="1" dirty="0"/>
-              <a:t>Question :</a:t>
-            </a:r>
-          </a:p>
-          <a:p>
-            <a:pPr marL="457200" indent="-228600">
+              <a:rPr lang="fr-CA" sz="1400" dirty="0"/>
+              <a:t>Vous aussi, vous portez une image. Laquelle?</a:t>
+            </a:r>
+          </a:p>
+          <a:p>
+            <a:pPr marL="228600" indent="-228600">
+              <a:spcBef>
+                <a:spcPts val="300"/>
+              </a:spcBef>
               <a:buFont typeface="Arial"/>
-              <a:buChar char="–"/>
-            </a:pPr>
-            <a:r>
-              <a:rPr lang="fr-CA" sz="1400" dirty="0"/>
-              <a:t>vous aussi, vous portez une image. Laquelle?</a:t>
-            </a:r>
-          </a:p>
-          <a:p>
-            <a:pPr marL="457200" indent="-228600">
-              <a:buFont typeface="Arial"/>
-              <a:buChar char="–"/>
+              <a:buChar char="•"/>
             </a:pPr>
             <a:r>
               <a:rPr lang="fr-CA" sz="1400" dirty="0"/>
               <a:t>Qu'est-il arrivé à cette image, et que Dieu en fait-il?</a:t>
+            </a:r>
+          </a:p>
+          <a:p>
+            <a:pPr marL="0" indent="0">
+              <a:spcBef>
+                <a:spcPts val="600"/>
+              </a:spcBef>
+              <a:buNone/>
+            </a:pPr>
+            <a:r>
+              <a:rPr lang="fr-CA" sz="1400" b="1" dirty="0"/>
+              <a:t>Parcours</a:t>
+            </a:r>
+          </a:p>
+          <a:p>
+            <a:pPr marL="228600" indent="-228600">
+              <a:spcBef>
+                <a:spcPts val="300"/>
+              </a:spcBef>
+              <a:buFont typeface="Arial"/>
+              <a:buChar char="•"/>
+            </a:pPr>
+            <a:r>
+              <a:rPr lang="fr-CA" sz="1400" dirty="0"/>
+              <a:t>Six étapes, un seul arc : l'image créée, parfaite, promise, transformée, qui aime, envoyée.</a:t>
             </a:r>
           </a:p>
         </p:txBody>
@@ -2513,19 +2750,7 @@
             </a:pPr>
             <a:r>
               <a:rPr lang="fr-CA" sz="1400" b="1" dirty="0"/>
-              <a:t>8 min.</a:t>
-            </a:r>
-          </a:p>
-          <a:p>
-            <a:pPr marL="0" indent="0">
-              <a:spcBef>
-                <a:spcPts val="600"/>
-              </a:spcBef>
-              <a:buNone/>
-            </a:pPr>
-            <a:r>
-              <a:rPr lang="fr-CA" sz="1400" b="1" dirty="0"/>
-              <a:t>A.</a:t>
+              <a:t>8 min · Genèse 1.26-27; 5.1-2</a:t>
             </a:r>
           </a:p>
           <a:p>
@@ -2537,8 +2762,24 @@
               <a:buChar char="•"/>
             </a:pPr>
             <a:r>
+              <a:rPr lang="fr-CA" sz="1400" b="1" dirty="0"/>
+              <a:t>Phrase clé : </a:t>
+            </a:r>
+            <a:r>
               <a:rPr lang="fr-CA" sz="1400" dirty="0"/>
-              <a:t>« Faisons » : jusqu'au verset 24, Dieu commande; au verset 26, « jamais Dieu n'a parlé au pluriel » (90-218).</a:t>
+              <a:t>l'homme est fait à l'image d'un Dieu qui n'a jamais été seul.</a:t>
+            </a:r>
+          </a:p>
+          <a:p>
+            <a:pPr marL="0" indent="0">
+              <a:spcBef>
+                <a:spcPts val="600"/>
+              </a:spcBef>
+              <a:buNone/>
+            </a:pPr>
+            <a:r>
+              <a:rPr lang="fr-CA" sz="1400" b="1" dirty="0"/>
+              <a:t>A. Le Dieu qui dit « Faisons » (1.26)</a:t>
             </a:r>
           </a:p>
           <a:p>
@@ -2551,7 +2792,7 @@
             </a:pPr>
             <a:r>
               <a:rPr lang="fr-CA" sz="1400" dirty="0"/>
-              <a:t>Première indication claire de la Trinité (3.22; 11.7).</a:t>
+              <a:t>Jusqu'au verset 24, Dieu commande : « Que la terre produise ». Au verset 26, « jamais Dieu n'a parlé au pluriel » (90-218). Puis il agit au singulier (1.27).</a:t>
             </a:r>
           </a:p>
           <a:p>
@@ -2563,12 +2804,8 @@
               <a:buChar char="•"/>
             </a:pPr>
             <a:r>
-              <a:rPr lang="fr-CA" sz="1400" b="1" dirty="0"/>
-              <a:t>Périchorèse </a:t>
-            </a:r>
-            <a:r>
               <a:rPr lang="fr-CA" sz="1400" dirty="0"/>
-              <a:t>(Jn 14.10-11; 17.21) : le mot nomme, il ne spécule pas.</a:t>
+              <a:t>Première indication claire de la Trinité (3.22; 11.7) : un seul Dieu, trois personnes en communion parfaite.</a:t>
             </a:r>
           </a:p>
           <a:p>
@@ -2580,20 +2817,12 @@
               <a:buChar char="•"/>
             </a:pPr>
             <a:r>
+              <a:rPr lang="fr-CA" sz="1400" b="1" dirty="0"/>
+              <a:t>Périchorèse </a:t>
+            </a:r>
+            <a:r>
               <a:rPr lang="fr-CA" sz="1400" dirty="0"/>
-              <a:t>Ce conseil exécute un dessein arrêté avant la fondation du monde (Ép 1.4) : pierre d'attente du point III.</a:t>
-            </a:r>
-          </a:p>
-          <a:p>
-            <a:pPr marL="0" indent="0">
-              <a:spcBef>
-                <a:spcPts val="600"/>
-              </a:spcBef>
-              <a:buNone/>
-            </a:pPr>
-            <a:r>
-              <a:rPr lang="fr-CA" sz="1400" b="1" dirty="0"/>
-              <a:t>B.</a:t>
+              <a:t>(Jn 14.10-11; 17.21) : l'habitation mutuelle des trois personnes; le mot nomme, il ne spécule pas.</a:t>
             </a:r>
           </a:p>
           <a:p>
@@ -2605,8 +2834,24 @@
               <a:buChar char="•"/>
             </a:pPr>
             <a:r>
+              <a:rPr lang="fr-CA" sz="1400" b="1" dirty="0"/>
+              <a:t>Pierre d'attente → III : </a:t>
+            </a:r>
+            <a:r>
               <a:rPr lang="fr-CA" sz="1400" dirty="0"/>
-              <a:t>Tselem et demuth sont synonymes (90-218).</a:t>
+              <a:t>ce conseil exécute un dessein arrêté avant la fondation du monde (Ép 1.4).</a:t>
+            </a:r>
+          </a:p>
+          <a:p>
+            <a:pPr marL="0" indent="0">
+              <a:spcBef>
+                <a:spcPts val="600"/>
+              </a:spcBef>
+              <a:buNone/>
+            </a:pPr>
+            <a:r>
+              <a:rPr lang="fr-CA" sz="1400" b="1" dirty="0"/>
+              <a:t>B. Ce qu'est l'image</a:t>
             </a:r>
           </a:p>
           <a:p>
@@ -2618,8 +2863,12 @@
               <a:buChar char="•"/>
             </a:pPr>
             <a:r>
+              <a:rPr lang="fr-CA" sz="1400" b="1" dirty="0"/>
+              <a:t>Tselem et demuth : </a:t>
+            </a:r>
+            <a:r>
               <a:rPr lang="fr-CA" sz="1400" dirty="0"/>
-              <a:t>Par la raison, l'homme est comme Dieu; moralement, il était comme Dieu.</a:t>
+              <a:t>« synonymes », répétés pour insister (90-218).</a:t>
             </a:r>
           </a:p>
           <a:p>
@@ -2632,11 +2881,53 @@
             </a:pPr>
             <a:r>
               <a:rPr lang="fr-CA" sz="1400" b="1" dirty="0"/>
-              <a:t>Centre : </a:t>
+              <a:t>Trois dimensions </a:t>
             </a:r>
             <a:r>
               <a:rPr lang="fr-CA" sz="1400" dirty="0"/>
-              <a:t>« la capacité de relations personnelles et, par-dessus tout, d'une relation personnelle avec Dieu » (90-218) : pierre d'attente du point V.</a:t>
+              <a:t>(note sur Gn 1.26; 90-218) :</a:t>
+            </a:r>
+          </a:p>
+          <a:p>
+            <a:pPr marL="457200" indent="-228600">
+              <a:buFont typeface="Arial"/>
+              <a:buChar char="•"/>
+            </a:pPr>
+            <a:r>
+              <a:rPr lang="fr-CA" sz="1400" b="1" dirty="0"/>
+              <a:t>Raison : </a:t>
+            </a:r>
+            <a:r>
+              <a:rPr lang="fr-CA" sz="1400" dirty="0"/>
+              <a:t>l'homme est comme Dieu; il pense, veut et ressent, fait pour recevoir la Parole du Dieu qui parle (Jn 1.1).</a:t>
+            </a:r>
+          </a:p>
+          <a:p>
+            <a:pPr marL="457200" indent="-228600">
+              <a:buFont typeface="Arial"/>
+              <a:buChar char="•"/>
+            </a:pPr>
+            <a:r>
+              <a:rPr lang="fr-CA" sz="1400" b="1" dirty="0"/>
+              <a:t>Morale : </a:t>
+            </a:r>
+            <a:r>
+              <a:rPr lang="fr-CA" sz="1400" dirty="0"/>
+              <a:t>il était comme Dieu, bon et sans péché.</a:t>
+            </a:r>
+          </a:p>
+          <a:p>
+            <a:pPr marL="457200" indent="-228600">
+              <a:buFont typeface="Arial"/>
+              <a:buChar char="•"/>
+            </a:pPr>
+            <a:r>
+              <a:rPr lang="fr-CA" sz="1400" b="1" dirty="0"/>
+              <a:t>Relation : </a:t>
+            </a:r>
+            <a:r>
+              <a:rPr lang="fr-CA" sz="1400" dirty="0"/>
+              <a:t>le centre, « la capacité de relations personnelles et, par-dessus tout, d'une relation personnelle avec Dieu » (90-218).</a:t>
             </a:r>
           </a:p>
           <a:p>
@@ -2648,20 +2939,12 @@
               <a:buChar char="•"/>
             </a:pPr>
             <a:r>
+              <a:rPr lang="fr-CA" sz="1400" b="1" dirty="0"/>
+              <a:t>Pierre d'attente → V : </a:t>
+            </a:r>
+            <a:r>
               <a:rPr lang="fr-CA" sz="1400" dirty="0"/>
-              <a:t>Bara' trois fois au verset 27 : Dieu seul crée, et l'homme est le seul être vivant fait sur le modèle divin (90-219).</a:t>
-            </a:r>
-          </a:p>
-          <a:p>
-            <a:pPr marL="0" indent="0">
-              <a:spcBef>
-                <a:spcPts val="600"/>
-              </a:spcBef>
-              <a:buNone/>
-            </a:pPr>
-            <a:r>
-              <a:rPr lang="fr-CA" sz="1400" b="1" dirty="0"/>
-              <a:t>C.</a:t>
+              <a:t>ces trois dimensions sont celles du cœur que Dieu renouvelle.</a:t>
             </a:r>
           </a:p>
           <a:p>
@@ -2674,11 +2957,23 @@
             </a:pPr>
             <a:r>
               <a:rPr lang="fr-CA" sz="1400" b="1" dirty="0"/>
-              <a:t>Domination : </a:t>
+              <a:t>Bara' </a:t>
             </a:r>
             <a:r>
               <a:rPr lang="fr-CA" sz="1400" dirty="0"/>
-              <a:t>roi de la terre, chargé de la cultiver et de la garder (90-219; Ps 8.7-9).</a:t>
+              <a:t>trois fois au verset 27 : Dieu seul crée, et l'homme est le seul être vivant fait sur le modèle divin (90-219).</a:t>
+            </a:r>
+          </a:p>
+          <a:p>
+            <a:pPr marL="0" indent="0">
+              <a:spcBef>
+                <a:spcPts val="600"/>
+              </a:spcBef>
+              <a:buNone/>
+            </a:pPr>
+            <a:r>
+              <a:rPr lang="fr-CA" sz="1400" b="1" dirty="0"/>
+              <a:t>C. La vocation de l'image (1.26-28)</a:t>
             </a:r>
           </a:p>
           <a:p>
@@ -2690,8 +2985,12 @@
               <a:buChar char="•"/>
             </a:pPr>
             <a:r>
+              <a:rPr lang="fr-CA" sz="1400" b="1" dirty="0"/>
+              <a:t>Domination : </a:t>
+            </a:r>
+            <a:r>
               <a:rPr lang="fr-CA" sz="1400" dirty="0"/>
-              <a:t>Homme et femme égaux en dignité, rôles distincts (Gn 2.18-23; 1 Tm 2.13); montrer le pluriel « qu'ils dominent » que la NEG79 efface.</a:t>
+              <a:t>représentant de Dieu, « roi de la terre », chargé de la cultiver et de la garder (90-219; Ps 8.7-9).</a:t>
             </a:r>
           </a:p>
           <a:p>
@@ -2704,11 +3003,11 @@
             </a:pPr>
             <a:r>
               <a:rPr lang="fr-CA" sz="1400" b="1" dirty="0"/>
-              <a:t>Application : </a:t>
+              <a:t>Homme et femme : </a:t>
             </a:r>
             <a:r>
               <a:rPr lang="fr-CA" sz="1400" dirty="0"/>
-              <a:t>la dignité repose sur l'acte créateur, non sur l'utilité.</a:t>
+              <a:t>égaux en dignité, ils dominent ensemble; rôles distincts selon l'ordre de la création (Gn 2.18-23; 1 Tm 2.13).</a:t>
             </a:r>
           </a:p>
           <a:p>
@@ -2721,37 +3020,151 @@
             </a:pPr>
             <a:r>
               <a:rPr lang="fr-CA" sz="1400" b="1" dirty="0"/>
-              <a:t>Transition, l'image ternie :</a:t>
-            </a:r>
-          </a:p>
-          <a:p>
-            <a:pPr marL="457200" indent="-228600">
+              <a:t>À montrer : </a:t>
+            </a:r>
+            <a:r>
+              <a:rPr lang="fr-CA" sz="1400" dirty="0"/>
+              <a:t>la NEG79 efface le pluriel hébreu (« qu'ils dominent », « il les créa mâle et femelle »).</a:t>
+            </a:r>
+          </a:p>
+          <a:p>
+            <a:pPr marL="0" indent="0">
+              <a:spcBef>
+                <a:spcPts val="600"/>
+              </a:spcBef>
+              <a:buNone/>
+            </a:pPr>
+            <a:r>
+              <a:rPr lang="fr-CA" sz="1400" b="1" dirty="0"/>
+              <a:t>Application</a:t>
+            </a:r>
+          </a:p>
+          <a:p>
+            <a:pPr marL="228600" indent="-228600">
+              <a:spcBef>
+                <a:spcPts val="300"/>
+              </a:spcBef>
               <a:buFont typeface="Arial"/>
-              <a:buChar char="–"/>
+              <a:buChar char="•"/>
             </a:pPr>
             <a:r>
               <a:rPr lang="fr-CA" sz="1400" dirty="0"/>
-              <a:t>Adam déchu engendre « à sa ressemblance » (Gn 5.3);</a:t>
-            </a:r>
-          </a:p>
-          <a:p>
-            <a:pPr marL="457200" indent="-228600">
+              <a:t>La dignité repose sur l'acte créateur, non sur l'utilité : l'enfant à naître, la personne handicapée, l'aîné atteint de démence portent l'image.</a:t>
+            </a:r>
+          </a:p>
+          <a:p>
+            <a:pPr marL="0" indent="0">
+              <a:spcBef>
+                <a:spcPts val="600"/>
+              </a:spcBef>
+              <a:buNone/>
+            </a:pPr>
+            <a:r>
+              <a:rPr lang="fr-CA" sz="1400" b="1" dirty="0"/>
+              <a:t>Transition : l'image ternie</a:t>
+            </a:r>
+          </a:p>
+          <a:p>
+            <a:pPr marL="228600" indent="-228600">
+              <a:spcBef>
+                <a:spcPts val="300"/>
+              </a:spcBef>
               <a:buFont typeface="Arial"/>
-              <a:buChar char="–"/>
+              <a:buChar char="•"/>
             </a:pPr>
             <a:r>
               <a:rPr lang="fr-CA" sz="1400" dirty="0"/>
-              <a:t>l'image demeure (Gn 9.6; Jc 3.9), mais la ressemblance morale est perdue et l'homme ne peut la restaurer.</a:t>
-            </a:r>
-          </a:p>
-          <a:p>
-            <a:pPr marL="457200" indent="-228600">
+              <a:t>Genèse 5.1-2 reprend 1.27 : Dieu avait fait l'homme « à la ressemblance de Dieu ».</a:t>
+            </a:r>
+          </a:p>
+          <a:p>
+            <a:pPr marL="228600" indent="-228600">
+              <a:spcBef>
+                <a:spcPts val="300"/>
+              </a:spcBef>
               <a:buFont typeface="Arial"/>
-              <a:buChar char="–"/>
+              <a:buChar char="•"/>
+            </a:pPr>
+            <a:r>
+              <a:rPr lang="fr-CA" sz="1400" dirty="0"/>
+              <a:t>Aussitôt après, Adam déchu engendre « à sa ressemblance » (Gn 5.3).</a:t>
+            </a:r>
+          </a:p>
+          <a:p>
+            <a:pPr marL="228600" indent="-228600">
+              <a:spcBef>
+                <a:spcPts val="300"/>
+              </a:spcBef>
+              <a:buFont typeface="Arial"/>
+              <a:buChar char="•"/>
+            </a:pPr>
+            <a:r>
+              <a:rPr lang="fr-CA" sz="1400" dirty="0"/>
+              <a:t>L'image demeure (Gn 9.6; Jc 3.9), mais la ressemblance morale est perdue et l'homme ne peut la restaurer.</a:t>
+            </a:r>
+          </a:p>
+          <a:p>
+            <a:pPr marL="228600" indent="-228600">
+              <a:spcBef>
+                <a:spcPts val="300"/>
+              </a:spcBef>
+              <a:buFont typeface="Arial"/>
+              <a:buChar char="•"/>
             </a:pPr>
             <a:r>
               <a:rPr lang="fr-CA" sz="1400" dirty="0"/>
               <a:t>Où voir encore l'image telle que Dieu l'a voulue?</a:t>
+            </a:r>
+          </a:p>
+          <a:p>
+            <a:pPr marL="0" indent="0">
+              <a:spcBef>
+                <a:spcPts val="600"/>
+              </a:spcBef>
+              <a:buNone/>
+            </a:pPr>
+            <a:r>
+              <a:rPr lang="fr-CA" sz="1400" b="1" dirty="0"/>
+              <a:t>À éviter</a:t>
+            </a:r>
+          </a:p>
+          <a:p>
+            <a:pPr marL="228600" indent="-228600">
+              <a:spcBef>
+                <a:spcPts val="300"/>
+              </a:spcBef>
+              <a:buFont typeface="Arial"/>
+              <a:buChar char="•"/>
+            </a:pPr>
+            <a:r>
+              <a:rPr lang="fr-CA" sz="1400" dirty="0"/>
+              <a:t>Spéculer sur la périchorèse : le mot nomme la communion trinitaire, il ne remplace pas le texte.</a:t>
+            </a:r>
+          </a:p>
+          <a:p>
+            <a:pPr marL="228600" indent="-228600">
+              <a:spcBef>
+                <a:spcPts val="300"/>
+              </a:spcBef>
+              <a:buFont typeface="Arial"/>
+              <a:buChar char="•"/>
+            </a:pPr>
+            <a:r>
+              <a:rPr lang="fr-CA" sz="1400" dirty="0"/>
+              <a:t>Faire de la domination une écologie moralisante ou une licence d'exploiter.</a:t>
+            </a:r>
+          </a:p>
+          <a:p>
+            <a:pPr marL="228600" indent="-228600">
+              <a:spcBef>
+                <a:spcPts val="300"/>
+              </a:spcBef>
+              <a:buFont typeface="Arial"/>
+              <a:buChar char="•"/>
+            </a:pPr>
+            <a:r>
+              <a:rPr lang="fr-CA" sz="1400" dirty="0"/>
+              <a:t>Opposer l'égalité de l'homme et de la femme et leurs rôles distincts.</a:t>
             </a:r>
           </a:p>
         </p:txBody>
@@ -2844,7 +3257,7 @@
             </a:pPr>
             <a:r>
               <a:rPr lang="fr-CA" sz="1400" b="1" dirty="0"/>
-              <a:t>6 min.</a:t>
+              <a:t>6 min · Colossiens 1.15; Philippiens 2.6-7</a:t>
             </a:r>
           </a:p>
           <a:p>
@@ -2856,8 +3269,24 @@
               <a:buChar char="•"/>
             </a:pPr>
             <a:r>
+              <a:rPr lang="fr-CA" sz="1400" b="1" dirty="0"/>
+              <a:t>Phrase clé : </a:t>
+            </a:r>
+            <a:r>
               <a:rPr lang="fr-CA" sz="1400" dirty="0"/>
-              <a:t>La Septante rend l'image de Gn 1.27 par eikôn, le mot que Paul applique à Christ (aussi 2 Co 4.4).</a:t>
+              <a:t>Christ est ce que l'homme n'est plus.</a:t>
+            </a:r>
+          </a:p>
+          <a:p>
+            <a:pPr marL="0" indent="0">
+              <a:spcBef>
+                <a:spcPts val="600"/>
+              </a:spcBef>
+              <a:buNone/>
+            </a:pPr>
+            <a:r>
+              <a:rPr lang="fr-CA" sz="1400" b="1" dirty="0"/>
+              <a:t>A. L'Image incréée</a:t>
             </a:r>
           </a:p>
           <a:p>
@@ -2869,28 +3298,12 @@
               <a:buChar char="•"/>
             </a:pPr>
             <a:r>
+              <a:rPr lang="fr-CA" sz="1400" b="1" dirty="0"/>
+              <a:t>Eikôn : </a:t>
+            </a:r>
+            <a:r>
               <a:rPr lang="fr-CA" sz="1400" dirty="0"/>
-              <a:t>Mais en un autre sens :</a:t>
-            </a:r>
-          </a:p>
-          <a:p>
-            <a:pPr marL="457200" indent="-228600">
-              <a:buFont typeface="Arial"/>
-              <a:buChar char="–"/>
-            </a:pPr>
-            <a:r>
-              <a:rPr lang="fr-CA" sz="1400" dirty="0"/>
-              <a:t>l'homme porte l'image comme créature;</a:t>
-            </a:r>
-          </a:p>
-          <a:p>
-            <a:pPr marL="457200" indent="-228600">
-              <a:buFont typeface="Arial"/>
-              <a:buChar char="–"/>
-            </a:pPr>
-            <a:r>
-              <a:rPr lang="fr-CA" sz="1400" dirty="0"/>
-              <a:t>Christ est, de toute éternité, la ressemblance parfaite de Dieu, une reproduction exacte, sans rien de manquant ni d'altéré (2135; Hé 1.3; Ph 2.6; Jn 14.9).</a:t>
+              <a:t>la Septante rend l'image de Gn 1.27 par eikôn, le mot que Paul applique à Christ (aussi 2 Co 4.4).</a:t>
             </a:r>
           </a:p>
           <a:p>
@@ -2903,31 +3316,27 @@
             </a:pPr>
             <a:r>
               <a:rPr lang="fr-CA" sz="1400" b="1" dirty="0"/>
-              <a:t>Kénose (Ph 2.6-7) : </a:t>
-            </a:r>
-            <a:r>
-              <a:rPr lang="fr-CA" sz="1400" dirty="0"/>
-              <a:t>« il s'est dépouillé lui-même, en prenant une forme de serviteur »;</a:t>
+              <a:t>Mais en un autre sens :</a:t>
             </a:r>
           </a:p>
           <a:p>
             <a:pPr marL="457200" indent="-228600">
               <a:buFont typeface="Arial"/>
-              <a:buChar char="–"/>
+              <a:buChar char="•"/>
             </a:pPr>
             <a:r>
               <a:rPr lang="fr-CA" sz="1400" dirty="0"/>
-              <a:t>non de sa divinité, « il n'a jamais cessé d'être Dieu » (50-16),</a:t>
+              <a:t>l'homme porte l'image comme créature;</a:t>
             </a:r>
           </a:p>
           <a:p>
             <a:pPr marL="457200" indent="-228600">
               <a:buFont typeface="Arial"/>
-              <a:buChar char="–"/>
+              <a:buChar char="•"/>
             </a:pPr>
             <a:r>
               <a:rPr lang="fr-CA" sz="1400" dirty="0"/>
-              <a:t>mais de sa gloire céleste et de l'usage volontaire de ses prérogatives.</a:t>
+              <a:t>Christ est, de toute éternité, la ressemblance parfaite de Dieu, sa représentation et sa manifestation (Ph 2.6; Jn 14.9), une reproduction exacte, sans rien de manquant ni d'altéré (2135; Hé 1.3).</a:t>
             </a:r>
           </a:p>
           <a:p>
@@ -2940,11 +3349,43 @@
             </a:pPr>
             <a:r>
               <a:rPr lang="fr-CA" sz="1400" b="1" dirty="0"/>
-              <a:t>Premier-né : </a:t>
+              <a:t>Kénose (Ph 2.6-7) : </a:t>
             </a:r>
             <a:r>
               <a:rPr lang="fr-CA" sz="1400" dirty="0"/>
-              <a:t>le rang d'héritier, non la naissance (Ex 4.22; Jr 31.9, Éphraïm avant Manassé).</a:t>
+              <a:t>existant en forme de Dieu, « il s'est dépouillé lui-même, en prenant une forme de serviteur »;</a:t>
+            </a:r>
+          </a:p>
+          <a:p>
+            <a:pPr marL="457200" indent="-228600">
+              <a:buFont typeface="Arial"/>
+              <a:buChar char="•"/>
+            </a:pPr>
+            <a:r>
+              <a:rPr lang="fr-CA" sz="1400" dirty="0"/>
+              <a:t>non de sa divinité : « il n'a jamais cessé d'être Dieu » (50-16);</a:t>
+            </a:r>
+          </a:p>
+          <a:p>
+            <a:pPr marL="457200" indent="-228600">
+              <a:buFont typeface="Arial"/>
+              <a:buChar char="•"/>
+            </a:pPr>
+            <a:r>
+              <a:rPr lang="fr-CA" sz="1400" dirty="0"/>
+              <a:t>mais de sa gloire céleste et de l'usage volontaire de ses prérogatives.</a:t>
+            </a:r>
+          </a:p>
+          <a:p>
+            <a:pPr marL="0" indent="0">
+              <a:spcBef>
+                <a:spcPts val="600"/>
+              </a:spcBef>
+              <a:buNone/>
+            </a:pPr>
+            <a:r>
+              <a:rPr lang="fr-CA" sz="1400" b="1" dirty="0"/>
+              <a:t>B. Premier-né : le rang, non la naissance</a:t>
             </a:r>
           </a:p>
           <a:p>
@@ -2957,7 +3398,7 @@
             </a:pPr>
             <a:r>
               <a:rPr lang="fr-CA" sz="1400" dirty="0"/>
-              <a:t>Il a créé toutes choses (1.16).</a:t>
+              <a:t>Le premier-né est l'héritier, qu'il soit l'aîné ou non (Ex 4.22; Jr 31.9, Éphraïm avant Manassé).</a:t>
             </a:r>
           </a:p>
           <a:p>
@@ -2969,28 +3410,20 @@
               <a:buChar char="•"/>
             </a:pPr>
             <a:r>
+              <a:rPr lang="fr-CA" sz="1400" dirty="0"/>
+              <a:t>Christ n'est pas la première créature : il a créé toutes choses (1.16); il a la prééminence et le droit d'héritage (1.18; Hé 1.2).</a:t>
+            </a:r>
+          </a:p>
+          <a:p>
+            <a:pPr marL="0" indent="0">
+              <a:spcBef>
+                <a:spcPts val="600"/>
+              </a:spcBef>
+              <a:buNone/>
+            </a:pPr>
+            <a:r>
               <a:rPr lang="fr-CA" sz="1400" b="1" dirty="0"/>
-              <a:t>Application :</a:t>
-            </a:r>
-          </a:p>
-          <a:p>
-            <a:pPr marL="457200" indent="-228600">
-              <a:buFont typeface="Arial"/>
-              <a:buChar char="–"/>
-            </a:pPr>
-            <a:r>
-              <a:rPr lang="fr-CA" sz="1400" dirty="0"/>
-              <a:t>qui veut savoir ce qu'est l'homme tel que Dieu l'a voulu regarde Christ;</a:t>
-            </a:r>
-          </a:p>
-          <a:p>
-            <a:pPr marL="457200" indent="-228600">
-              <a:buFont typeface="Arial"/>
-              <a:buChar char="–"/>
-            </a:pPr>
-            <a:r>
-              <a:rPr lang="fr-CA" sz="1400" dirty="0"/>
-              <a:t>qui veut connaître Dieu le voit en Christ, sans intermédiaire.</a:t>
+              <a:t>Application</a:t>
             </a:r>
           </a:p>
           <a:p>
@@ -3002,12 +3435,97 @@
               <a:buChar char="•"/>
             </a:pPr>
             <a:r>
+              <a:rPr lang="fr-CA" sz="1400" dirty="0"/>
+              <a:t>Qui veut savoir ce qu'est l'homme tel que Dieu l'a voulu regarde Christ.</a:t>
+            </a:r>
+          </a:p>
+          <a:p>
+            <a:pPr marL="228600" indent="-228600">
+              <a:spcBef>
+                <a:spcPts val="300"/>
+              </a:spcBef>
+              <a:buFont typeface="Arial"/>
+              <a:buChar char="•"/>
+            </a:pPr>
+            <a:r>
+              <a:rPr lang="fr-CA" sz="1400" dirty="0"/>
+              <a:t>Qui veut connaître Dieu n'a besoin d'aucun intermédiaire : il le voit en Christ.</a:t>
+            </a:r>
+          </a:p>
+          <a:p>
+            <a:pPr marL="0" indent="0">
+              <a:spcBef>
+                <a:spcPts val="600"/>
+              </a:spcBef>
+              <a:buNone/>
+            </a:pPr>
+            <a:r>
               <a:rPr lang="fr-CA" sz="1400" b="1" dirty="0"/>
-              <a:t>Transition : </a:t>
-            </a:r>
+              <a:t>Transition</a:t>
+            </a:r>
+          </a:p>
+          <a:p>
+            <a:pPr marL="228600" indent="-228600">
+              <a:spcBef>
+                <a:spcPts val="300"/>
+              </a:spcBef>
+              <a:buFont typeface="Arial"/>
+              <a:buChar char="•"/>
+            </a:pPr>
             <a:r>
               <a:rPr lang="fr-CA" sz="1400" dirty="0"/>
-              <a:t>si Christ est l'image parfaite, que Dieu fait-il de ceux qu'il sauve?</a:t>
+              <a:t>Si Christ est l'image parfaite, que Dieu fait-il de ceux qu'il sauve?</a:t>
+            </a:r>
+          </a:p>
+          <a:p>
+            <a:pPr marL="0" indent="0">
+              <a:spcBef>
+                <a:spcPts val="600"/>
+              </a:spcBef>
+              <a:buNone/>
+            </a:pPr>
+            <a:r>
+              <a:rPr lang="fr-CA" sz="1400" b="1" dirty="0"/>
+              <a:t>À éviter</a:t>
+            </a:r>
+          </a:p>
+          <a:p>
+            <a:pPr marL="228600" indent="-228600">
+              <a:spcBef>
+                <a:spcPts val="300"/>
+              </a:spcBef>
+              <a:buFont typeface="Arial"/>
+              <a:buChar char="•"/>
+            </a:pPr>
+            <a:r>
+              <a:rPr lang="fr-CA" sz="1400" dirty="0"/>
+              <a:t>Projeter « l'image de Christ » sur Moïse : montrer le chemin tselem → eikôn → Col 1.15 → Rm 8.29 → 2 Co 3.18.</a:t>
+            </a:r>
+          </a:p>
+          <a:p>
+            <a:pPr marL="228600" indent="-228600">
+              <a:spcBef>
+                <a:spcPts val="300"/>
+              </a:spcBef>
+              <a:buFont typeface="Arial"/>
+              <a:buChar char="•"/>
+            </a:pPr>
+            <a:r>
+              <a:rPr lang="fr-CA" sz="1400" dirty="0"/>
+              <a:t>Présenter « premier-né » comme un ordre de naissance.</a:t>
+            </a:r>
+          </a:p>
+          <a:p>
+            <a:pPr marL="228600" indent="-228600">
+              <a:spcBef>
+                <a:spcPts val="300"/>
+              </a:spcBef>
+              <a:buFont typeface="Arial"/>
+              <a:buChar char="•"/>
+            </a:pPr>
+            <a:r>
+              <a:rPr lang="fr-CA" sz="1400" dirty="0"/>
+              <a:t>Faire de la kénose un abandon de la divinité (50-16).</a:t>
             </a:r>
           </a:p>
         </p:txBody>
@@ -3100,7 +3618,7 @@
             </a:pPr>
             <a:r>
               <a:rPr lang="fr-CA" sz="1400" b="1" dirty="0"/>
-              <a:t>5 min.</a:t>
+              <a:t>5 min · Romains 8.29; Éphésiens 1.4</a:t>
             </a:r>
           </a:p>
           <a:p>
@@ -3113,11 +3631,23 @@
             </a:pPr>
             <a:r>
               <a:rPr lang="fr-CA" sz="1400" b="1" dirty="0"/>
-              <a:t>« Connus d'avance » : </a:t>
+              <a:t>Phrase clé : </a:t>
             </a:r>
             <a:r>
               <a:rPr lang="fr-CA" sz="1400" dirty="0"/>
-              <a:t>non une simple prévision de qui croirait, mais le choix d'aimer, l'élection (Ac 2.23; 1 P 1.2, 20).</a:t>
+              <a:t>Dieu a décidé d'avance la fin de votre salut, et cette fin, c'est Christ en vous.</a:t>
+            </a:r>
+          </a:p>
+          <a:p>
+            <a:pPr marL="0" indent="0">
+              <a:spcBef>
+                <a:spcPts val="600"/>
+              </a:spcBef>
+              <a:buNone/>
+            </a:pPr>
+            <a:r>
+              <a:rPr lang="fr-CA" sz="1400" b="1" dirty="0"/>
+              <a:t>Trois expressions du verset 29</a:t>
             </a:r>
           </a:p>
           <a:p>
@@ -3129,8 +3659,22 @@
               <a:buChar char="•"/>
             </a:pPr>
             <a:r>
+              <a:rPr lang="fr-CA" sz="1400" b="1" dirty="0"/>
+              <a:t>« Connus d'avance » : </a:t>
+            </a:r>
+            <a:r>
               <a:rPr lang="fr-CA" sz="1400" dirty="0"/>
-              <a:t>Le même conseil éternel que le « Faisons ».</a:t>
+              <a:t>non une simple prévision de qui croirait, mais le choix d'aimer, l'élection (note sur Rm 8.29; Ac 2.23; 1 P 1.2, 20).</a:t>
+            </a:r>
+          </a:p>
+          <a:p>
+            <a:pPr marL="457200" indent="-228600">
+              <a:buFont typeface="Arial"/>
+              <a:buChar char="•"/>
+            </a:pPr>
+            <a:r>
+              <a:rPr lang="fr-CA" sz="1400" dirty="0"/>
+              <a:t>Le même conseil éternel que le « Faisons » : « En lui Dieu nous a élus avant la fondation du monde » (Ép 1.4).</a:t>
             </a:r>
           </a:p>
           <a:p>
@@ -3142,8 +3686,22 @@
               <a:buChar char="•"/>
             </a:pPr>
             <a:r>
+              <a:rPr lang="fr-CA" sz="1400" b="1" dirty="0"/>
+              <a:t>« Prédestinés à être semblables à l'image de son Fils » : </a:t>
+            </a:r>
+            <a:r>
               <a:rPr lang="fr-CA" sz="1400" dirty="0"/>
               <a:t>« Le but de votre salut était que vous soyez rendus semblables à l'image de son Fils » (90-180).</a:t>
+            </a:r>
+          </a:p>
+          <a:p>
+            <a:pPr marL="457200" indent="-228600">
+              <a:buFont typeface="Arial"/>
+              <a:buChar char="•"/>
+            </a:pPr>
+            <a:r>
+              <a:rPr lang="fr-CA" sz="1400" dirty="0"/>
+              <a:t>Sainteté maintenant, corps glorifié à la fin (Ph 3.21).</a:t>
             </a:r>
           </a:p>
           <a:p>
@@ -3156,11 +3714,23 @@
             </a:pPr>
             <a:r>
               <a:rPr lang="fr-CA" sz="1400" b="1" dirty="0"/>
-              <a:t>Premier-né de beaucoup de frères : </a:t>
+              <a:t>« Premier-né de beaucoup de frères » : </a:t>
             </a:r>
             <a:r>
               <a:rPr lang="fr-CA" sz="1400" dirty="0"/>
-              <a:t>la fin dernière est la gloire du Fils.</a:t>
+              <a:t>la fin dernière du salut est la gloire du Fils; ses frères lui ressemblent sans jamais être ses égaux.</a:t>
+            </a:r>
+          </a:p>
+          <a:p>
+            <a:pPr marL="0" indent="0">
+              <a:spcBef>
+                <a:spcPts val="600"/>
+              </a:spcBef>
+              <a:buNone/>
+            </a:pPr>
+            <a:r>
+              <a:rPr lang="fr-CA" sz="1400" b="1" dirty="0"/>
+              <a:t>Application</a:t>
             </a:r>
           </a:p>
           <a:p>
@@ -3172,28 +3742,8 @@
               <a:buChar char="•"/>
             </a:pPr>
             <a:r>
-              <a:rPr lang="fr-CA" sz="1400" b="1" dirty="0"/>
-              <a:t>Application :</a:t>
-            </a:r>
-          </a:p>
-          <a:p>
-            <a:pPr marL="457200" indent="-228600">
-              <a:buFont typeface="Arial"/>
-              <a:buChar char="–"/>
-            </a:pPr>
-            <a:r>
               <a:rPr lang="fr-CA" sz="1400" dirty="0"/>
-              <a:t>ce que Dieu a décrété, il l'achèvera (8.30);</a:t>
-            </a:r>
-          </a:p>
-          <a:p>
-            <a:pPr marL="457200" indent="-228600">
-              <a:buFont typeface="Arial"/>
-              <a:buChar char="–"/>
-            </a:pPr>
-            <a:r>
-              <a:rPr lang="fr-CA" sz="1400" dirty="0"/>
-              <a:t>les épreuves de 8.28 servent ce but.</a:t>
+              <a:t>Connus d'avance, prédestinés, appelés, justifiés, glorifiés (8.29-30) : aucun maillon ne manque.</a:t>
             </a:r>
           </a:p>
           <a:p>
@@ -3205,28 +3755,84 @@
               <a:buChar char="•"/>
             </a:pPr>
             <a:r>
+              <a:rPr lang="fr-CA" sz="1400" dirty="0"/>
+              <a:t>Ce que Dieu a décrété, il l'achèvera : c'est la sécurité du croyant.</a:t>
+            </a:r>
+          </a:p>
+          <a:p>
+            <a:pPr marL="228600" indent="-228600">
+              <a:spcBef>
+                <a:spcPts val="300"/>
+              </a:spcBef>
+              <a:buFont typeface="Arial"/>
+              <a:buChar char="•"/>
+            </a:pPr>
+            <a:r>
+              <a:rPr lang="fr-CA" sz="1400" dirty="0"/>
+              <a:t>Les épreuves de 8.28 servent ce but.</a:t>
+            </a:r>
+          </a:p>
+          <a:p>
+            <a:pPr marL="0" indent="0">
+              <a:spcBef>
+                <a:spcPts val="600"/>
+              </a:spcBef>
+              <a:buNone/>
+            </a:pPr>
+            <a:r>
               <a:rPr lang="fr-CA" sz="1400" b="1" dirty="0"/>
-              <a:t>Transition :</a:t>
-            </a:r>
-          </a:p>
-          <a:p>
-            <a:pPr marL="457200" indent="-228600">
+              <a:t>Transition</a:t>
+            </a:r>
+          </a:p>
+          <a:p>
+            <a:pPr marL="228600" indent="-228600">
+              <a:spcBef>
+                <a:spcPts val="300"/>
+              </a:spcBef>
               <a:buFont typeface="Arial"/>
-              <a:buChar char="–"/>
+              <a:buChar char="•"/>
             </a:pPr>
             <a:r>
               <a:rPr lang="fr-CA" sz="1400" dirty="0"/>
-              <a:t>nous ne voyons pas encore cette ressemblance achevée.</a:t>
-            </a:r>
-          </a:p>
-          <a:p>
-            <a:pPr marL="457200" indent="-228600">
+              <a:t>Nous ne voyons pas encore cette ressemblance achevée. Comment Dieu nous y conduit-il, aujourd'hui?</a:t>
+            </a:r>
+          </a:p>
+          <a:p>
+            <a:pPr marL="0" indent="0">
+              <a:spcBef>
+                <a:spcPts val="600"/>
+              </a:spcBef>
+              <a:buNone/>
+            </a:pPr>
+            <a:r>
+              <a:rPr lang="fr-CA" sz="1400" b="1" dirty="0"/>
+              <a:t>À éviter</a:t>
+            </a:r>
+          </a:p>
+          <a:p>
+            <a:pPr marL="228600" indent="-228600">
+              <a:spcBef>
+                <a:spcPts val="300"/>
+              </a:spcBef>
               <a:buFont typeface="Arial"/>
-              <a:buChar char="–"/>
+              <a:buChar char="•"/>
             </a:pPr>
             <a:r>
               <a:rPr lang="fr-CA" sz="1400" dirty="0"/>
-              <a:t>Comment Dieu nous y conduit-il, aujourd'hui?</a:t>
+              <a:t>Contourner l'élection pour ne garder qu'un « imitez Jésus ».</a:t>
+            </a:r>
+          </a:p>
+          <a:p>
+            <a:pPr marL="228600" indent="-228600">
+              <a:spcBef>
+                <a:spcPts val="300"/>
+              </a:spcBef>
+              <a:buFont typeface="Arial"/>
+              <a:buChar char="•"/>
+            </a:pPr>
+            <a:r>
+              <a:rPr lang="fr-CA" sz="1400" dirty="0"/>
+              <a:t>Laisser entendre que le croyant deviendra ce que Christ est par essence : Christ est l'image par nature, le croyant y est transformé par grâce.</a:t>
             </a:r>
           </a:p>
         </p:txBody>
@@ -3319,19 +3925,7 @@
             </a:pPr>
             <a:r>
               <a:rPr lang="fr-CA" sz="1400" b="1" dirty="0"/>
-              <a:t>6 min.</a:t>
-            </a:r>
-          </a:p>
-          <a:p>
-            <a:pPr marL="0" indent="0">
-              <a:spcBef>
-                <a:spcPts val="600"/>
-              </a:spcBef>
-              <a:buNone/>
-            </a:pPr>
-            <a:r>
-              <a:rPr lang="fr-CA" sz="1400" b="1" dirty="0"/>
-              <a:t>A.</a:t>
+              <a:t>6 min · 2 Corinthiens 3.18</a:t>
             </a:r>
           </a:p>
           <a:p>
@@ -3343,8 +3937,24 @@
               <a:buChar char="•"/>
             </a:pPr>
             <a:r>
+              <a:rPr lang="fr-CA" sz="1400" b="1" dirty="0"/>
+              <a:t>Phrase clé : </a:t>
+            </a:r>
+            <a:r>
               <a:rPr lang="fr-CA" sz="1400" dirty="0"/>
-              <a:t>Moïse voilait son visage (Ex 34.29-35); en Christ, le voile est ôté.</a:t>
+              <a:t>on devient semblable à ce que l'on contemple.</a:t>
+            </a:r>
+          </a:p>
+          <a:p>
+            <a:pPr marL="0" indent="0">
+              <a:spcBef>
+                <a:spcPts val="600"/>
+              </a:spcBef>
+              <a:buNone/>
+            </a:pPr>
+            <a:r>
+              <a:rPr lang="fr-CA" sz="1400" b="1" dirty="0"/>
+              <a:t>A. Le visage découvert</a:t>
             </a:r>
           </a:p>
           <a:p>
@@ -3357,19 +3967,7 @@
             </a:pPr>
             <a:r>
               <a:rPr lang="fr-CA" sz="1400" dirty="0"/>
-              <a:t>« Nous tous » : tous les croyants (47-22).</a:t>
-            </a:r>
-          </a:p>
-          <a:p>
-            <a:pPr marL="0" indent="0">
-              <a:spcBef>
-                <a:spcPts val="600"/>
-              </a:spcBef>
-              <a:buNone/>
-            </a:pPr>
-            <a:r>
-              <a:rPr lang="fr-CA" sz="1400" b="1" dirty="0"/>
-              <a:t>B.</a:t>
+              <a:t>Moïse voilait son visage (Ex 34.29-35); en Christ, le voile est ôté (3.14-16).</a:t>
             </a:r>
           </a:p>
           <a:p>
@@ -3381,8 +3979,24 @@
               <a:buChar char="•"/>
             </a:pPr>
             <a:r>
+              <a:rPr lang="fr-CA" sz="1400" b="1" dirty="0"/>
+              <a:t>« Nous tous » : </a:t>
+            </a:r>
+            <a:r>
               <a:rPr lang="fr-CA" sz="1400" dirty="0"/>
-              <a:t>La NEG79 dit « reflète »; le grec, avec la S21, la LSG, Darby et la KJF, dit contempler comme dans un miroir.</a:t>
+              <a:t>tous les croyants; rien ne s'interpose plus entre eux et la vision du Seigneur (47-22).</a:t>
+            </a:r>
+          </a:p>
+          <a:p>
+            <a:pPr marL="0" indent="0">
+              <a:spcBef>
+                <a:spcPts val="600"/>
+              </a:spcBef>
+              <a:buNone/>
+            </a:pPr>
+            <a:r>
+              <a:rPr lang="fr-CA" sz="1400" b="1" dirty="0"/>
+              <a:t>B. Contempler dans le miroir</a:t>
             </a:r>
           </a:p>
           <a:p>
@@ -3394,8 +4008,12 @@
               <a:buChar char="•"/>
             </a:pPr>
             <a:r>
+              <a:rPr lang="fr-CA" sz="1400" b="1" dirty="0"/>
+              <a:t>À montrer : </a:t>
+            </a:r>
+            <a:r>
               <a:rPr lang="fr-CA" sz="1400" dirty="0"/>
-              <a:t>Le miroir, c'est l'Écriture, où la gloire de Dieu se voit sur la face de Jésus-Christ (90-75; 4.6).</a:t>
+              <a:t>la NEG79 dit « reflète »; le grec, avec la S21, la LSG, Darby et la KJF, dit contempler comme dans un miroir.</a:t>
             </a:r>
           </a:p>
           <a:p>
@@ -3408,19 +4026,7 @@
             </a:pPr>
             <a:r>
               <a:rPr lang="fr-CA" sz="1400" dirty="0"/>
-              <a:t>Relier au Rappel.</a:t>
-            </a:r>
-          </a:p>
-          <a:p>
-            <a:pPr marL="0" indent="0">
-              <a:spcBef>
-                <a:spcPts val="600"/>
-              </a:spcBef>
-              <a:buNone/>
-            </a:pPr>
-            <a:r>
-              <a:rPr lang="fr-CA" sz="1400" b="1" dirty="0"/>
-              <a:t>C.</a:t>
+              <a:t>On ne reflète que ce qu'on contemple.</a:t>
             </a:r>
           </a:p>
           <a:p>
@@ -3432,8 +4038,24 @@
               <a:buChar char="•"/>
             </a:pPr>
             <a:r>
+              <a:rPr lang="fr-CA" sz="1400" b="1" dirty="0"/>
+              <a:t>Le miroir, c'est l'Écriture : </a:t>
+            </a:r>
+            <a:r>
               <a:rPr lang="fr-CA" sz="1400" dirty="0"/>
-              <a:t>Metamorphoô, présent passif : « une action de transformation continue et progressive » (47-21).</a:t>
+              <a:t>la gloire de Dieu s'y voit sur la face de Jésus-Christ (90-75; 4.6). Relier au Rappel.</a:t>
+            </a:r>
+          </a:p>
+          <a:p>
+            <a:pPr marL="0" indent="0">
+              <a:spcBef>
+                <a:spcPts val="600"/>
+              </a:spcBef>
+              <a:buNone/>
+            </a:pPr>
+            <a:r>
+              <a:rPr lang="fr-CA" sz="1400" b="1" dirty="0"/>
+              <a:t>C. Transformés par l'Esprit</a:t>
             </a:r>
           </a:p>
           <a:p>
@@ -3445,8 +4067,12 @@
               <a:buChar char="•"/>
             </a:pPr>
             <a:r>
+              <a:rPr lang="fr-CA" sz="1400" b="1" dirty="0"/>
+              <a:t>Metamorphoô : </a:t>
+            </a:r>
+            <a:r>
               <a:rPr lang="fr-CA" sz="1400" dirty="0"/>
-              <a:t>« C'est là toute la sanctification progressive » (90-75).</a:t>
+              <a:t>présent passif, « une action de transformation continue et progressive » (47-21). Nous ne nous transformons pas; nous sommes transformés.</a:t>
             </a:r>
           </a:p>
           <a:p>
@@ -3458,12 +4084,8 @@
               <a:buChar char="•"/>
             </a:pPr>
             <a:r>
-              <a:rPr lang="fr-CA" sz="1400" b="1" dirty="0"/>
-              <a:t>Le terme : </a:t>
-            </a:r>
-            <a:r>
               <a:rPr lang="fr-CA" sz="1400" dirty="0"/>
-              <a:t>« Le dessein salvateur de Dieu était de créer une humanité rachetée qui serait semblable à son Fils » (47-21).</a:t>
+              <a:t>« C'est là toute la sanctification progressive […] passer d'un degré de gloire au suivant en contemplant la gloire du Seigneur » (90-75).</a:t>
             </a:r>
           </a:p>
           <a:p>
@@ -3476,27 +4098,23 @@
             </a:pPr>
             <a:r>
               <a:rPr lang="fr-CA" sz="1400" b="1" dirty="0"/>
-              <a:t>Application :</a:t>
-            </a:r>
-          </a:p>
-          <a:p>
-            <a:pPr marL="457200" indent="-228600">
-              <a:buFont typeface="Arial"/>
-              <a:buChar char="–"/>
-            </a:pPr>
+              <a:t>Le terme : </a:t>
+            </a:r>
             <a:r>
               <a:rPr lang="fr-CA" sz="1400" dirty="0"/>
-              <a:t>contempler Christ dans sa Parole, et l'Esprit fait l'œuvre;</a:t>
-            </a:r>
-          </a:p>
-          <a:p>
-            <a:pPr marL="457200" indent="-228600">
-              <a:buFont typeface="Arial"/>
-              <a:buChar char="–"/>
-            </a:pPr>
-            <a:r>
-              <a:rPr lang="fr-CA" sz="1400" dirty="0"/>
-              <a:t>celui qui délaisse l'Écriture se prive du miroir.</a:t>
+              <a:t>« Le dessein salvateur de Dieu était de créer une humanité rachetée qui serait semblable à son Fils » (47-21), jusqu'à ce que nous lui soyons semblables (1 Jn 3.2).</a:t>
+            </a:r>
+          </a:p>
+          <a:p>
+            <a:pPr marL="0" indent="0">
+              <a:spcBef>
+                <a:spcPts val="600"/>
+              </a:spcBef>
+              <a:buNone/>
+            </a:pPr>
+            <a:r>
+              <a:rPr lang="fr-CA" sz="1400" b="1" dirty="0"/>
+              <a:t>Application</a:t>
             </a:r>
           </a:p>
           <a:p>
@@ -3508,28 +4126,71 @@
               <a:buChar char="•"/>
             </a:pPr>
             <a:r>
+              <a:rPr lang="fr-CA" sz="1400" dirty="0"/>
+              <a:t>Le moyen est fixé : contempler Christ dans sa Parole, et l'Esprit fait l'œuvre.</a:t>
+            </a:r>
+          </a:p>
+          <a:p>
+            <a:pPr marL="228600" indent="-228600">
+              <a:spcBef>
+                <a:spcPts val="300"/>
+              </a:spcBef>
+              <a:buFont typeface="Arial"/>
+              <a:buChar char="•"/>
+            </a:pPr>
+            <a:r>
+              <a:rPr lang="fr-CA" sz="1400" dirty="0"/>
+              <a:t>Celui qui délaisse l'Écriture se prive du miroir.</a:t>
+            </a:r>
+          </a:p>
+          <a:p>
+            <a:pPr marL="0" indent="0">
+              <a:spcBef>
+                <a:spcPts val="600"/>
+              </a:spcBef>
+              <a:buNone/>
+            </a:pPr>
+            <a:r>
               <a:rPr lang="fr-CA" sz="1400" b="1" dirty="0"/>
-              <a:t>Transition :</a:t>
-            </a:r>
-          </a:p>
-          <a:p>
-            <a:pPr marL="457200" indent="-228600">
+              <a:t>Transition</a:t>
+            </a:r>
+          </a:p>
+          <a:p>
+            <a:pPr marL="228600" indent="-228600">
+              <a:spcBef>
+                <a:spcPts val="300"/>
+              </a:spcBef>
               <a:buFont typeface="Arial"/>
-              <a:buChar char="–"/>
+              <a:buChar char="•"/>
             </a:pPr>
             <a:r>
               <a:rPr lang="fr-CA" sz="1400" dirty="0"/>
-              <a:t>à quoi reconnaît-on cette image qui grandit?</a:t>
-            </a:r>
-          </a:p>
-          <a:p>
-            <a:pPr marL="457200" indent="-228600">
+              <a:t>À quoi reconnaît-on cette image qui grandit? À ce que Dieu avait mis au centre : le cœur qui aime.</a:t>
+            </a:r>
+          </a:p>
+          <a:p>
+            <a:pPr marL="0" indent="0">
+              <a:spcBef>
+                <a:spcPts val="600"/>
+              </a:spcBef>
+              <a:buNone/>
+            </a:pPr>
+            <a:r>
+              <a:rPr lang="fr-CA" sz="1400" b="1" dirty="0"/>
+              <a:t>À éviter</a:t>
+            </a:r>
+          </a:p>
+          <a:p>
+            <a:pPr marL="228600" indent="-228600">
+              <a:spcBef>
+                <a:spcPts val="300"/>
+              </a:spcBef>
               <a:buFont typeface="Arial"/>
-              <a:buChar char="–"/>
+              <a:buChar char="•"/>
             </a:pPr>
             <a:r>
               <a:rPr lang="fr-CA" sz="1400" dirty="0"/>
-              <a:t>À ce que Dieu avait mis au centre : le cœur qui aime.</a:t>
+              <a:t>Laisser le « reflète » de la NEG79 effacer le moyen : le croyant reflète Christ parce qu'il le contemple dans la Parole.</a:t>
             </a:r>
           </a:p>
         </p:txBody>
@@ -3622,19 +4283,7 @@
             </a:pPr>
             <a:r>
               <a:rPr lang="fr-CA" sz="1400" b="1" dirty="0"/>
-              <a:t>7 min.</a:t>
-            </a:r>
-          </a:p>
-          <a:p>
-            <a:pPr marL="0" indent="0">
-              <a:spcBef>
-                <a:spcPts val="600"/>
-              </a:spcBef>
-              <a:buNone/>
-            </a:pPr>
-            <a:r>
-              <a:rPr lang="fr-CA" sz="1400" b="1" dirty="0"/>
-              <a:t>A.</a:t>
+              <a:t>7 min · Matthieu 22.37-40; Jérémie 31.33</a:t>
             </a:r>
           </a:p>
           <a:p>
@@ -3646,8 +4295,24 @@
               <a:buChar char="•"/>
             </a:pPr>
             <a:r>
+              <a:rPr lang="fr-CA" sz="1400" b="1" dirty="0"/>
+              <a:t>Phrase clé : </a:t>
+            </a:r>
+            <a:r>
               <a:rPr lang="fr-CA" sz="1400" dirty="0"/>
-              <a:t>Le piège des 613 commandements; Jésus répond par le Shema (Dt 6.5) et Lv 19.18 (2358).</a:t>
+              <a:t>la loi que je ne peux accomplir, Dieu l'écrit sur mon cœur.</a:t>
+            </a:r>
+          </a:p>
+          <a:p>
+            <a:pPr marL="0" indent="0">
+              <a:spcBef>
+                <a:spcPts val="600"/>
+              </a:spcBef>
+              <a:buNone/>
+            </a:pPr>
+            <a:r>
+              <a:rPr lang="fr-CA" sz="1400" b="1" dirty="0"/>
+              <a:t>A. Le commandement que tous connaissaient</a:t>
             </a:r>
           </a:p>
           <a:p>
@@ -3660,19 +4325,7 @@
             </a:pPr>
             <a:r>
               <a:rPr lang="fr-CA" sz="1400" dirty="0"/>
-              <a:t>« Quand vous aimez Dieu comme il faut, vous aimez les gens comme il faut » (2358).</a:t>
-            </a:r>
-          </a:p>
-          <a:p>
-            <a:pPr marL="0" indent="0">
-              <a:spcBef>
-                <a:spcPts val="600"/>
-              </a:spcBef>
-              <a:buNone/>
-            </a:pPr>
-            <a:r>
-              <a:rPr lang="fr-CA" sz="1400" b="1" dirty="0"/>
-              <a:t>B.</a:t>
+              <a:t>Le piège des 613 commandements; Jésus répond par le Shema, récité matin et soir (Dt 6.5), et par Lv 19.18 (2358).</a:t>
             </a:r>
           </a:p>
           <a:p>
@@ -3684,20 +4337,12 @@
               <a:buChar char="•"/>
             </a:pPr>
             <a:r>
+              <a:rPr lang="fr-CA" sz="1400" b="1" dirty="0"/>
+              <a:t>« Tu aimeras » : </a:t>
+            </a:r>
+            <a:r>
               <a:rPr lang="fr-CA" sz="1400" dirty="0"/>
-              <a:t>« Parce que nous n'avons pas aimé ainsi, nous avons besoin du pardon, et parce que nous ne pouvons pas aimer ainsi, nous avons besoin d'une capacité nouvelle » (2358).</a:t>
-            </a:r>
-          </a:p>
-          <a:p>
-            <a:pPr marL="0" indent="0">
-              <a:spcBef>
-                <a:spcPts val="600"/>
-              </a:spcBef>
-              <a:buNone/>
-            </a:pPr>
-            <a:r>
-              <a:rPr lang="fr-CA" sz="1400" b="1" dirty="0"/>
-              <a:t>C.</a:t>
+              <a:t>l'amour de la volonté, de tout l'être.</a:t>
             </a:r>
           </a:p>
           <a:p>
@@ -3710,7 +4355,19 @@
             </a:pPr>
             <a:r>
               <a:rPr lang="fr-CA" sz="1400" dirty="0"/>
-              <a:t>Lire Jérémie 31.33 (NBS).</a:t>
+              <a:t>Le second découle du premier : « Quand vous aimez Dieu comme il faut, vous aimez les gens comme il faut » (2358).</a:t>
+            </a:r>
+          </a:p>
+          <a:p>
+            <a:pPr marL="0" indent="0">
+              <a:spcBef>
+                <a:spcPts val="600"/>
+              </a:spcBef>
+              <a:buNone/>
+            </a:pPr>
+            <a:r>
+              <a:rPr lang="fr-CA" sz="1400" b="1" dirty="0"/>
+              <a:t>B. Le commandement qui accuse</a:t>
             </a:r>
           </a:p>
           <a:p>
@@ -3722,12 +4379,8 @@
               <a:buChar char="•"/>
             </a:pPr>
             <a:r>
-              <a:rPr lang="fr-CA" sz="1400" b="1" dirty="0"/>
-              <a:t>La nouvelle alliance : </a:t>
-            </a:r>
-            <a:r>
               <a:rPr lang="fr-CA" sz="1400" dirty="0"/>
-              <a:t>« le pardon de tous nos péchés et l'écriture de la loi de Dieu sur nos cœurs » (80-286).</a:t>
+              <a:t>Personne n'a aimé Dieu ainsi.</a:t>
             </a:r>
           </a:p>
           <a:p>
@@ -3740,7 +4393,19 @@
             </a:pPr>
             <a:r>
               <a:rPr lang="fr-CA" sz="1400" dirty="0"/>
-              <a:t>Le cœur (1 Ch 28.9) : rationnel, moral, relationnel.</a:t>
+              <a:t>« Parce que nous n'avons pas aimé ainsi, nous avons besoin du pardon, et parce que nous ne pouvons pas aimer ainsi, nous avons besoin d'une capacité nouvelle » (2358).</a:t>
+            </a:r>
+          </a:p>
+          <a:p>
+            <a:pPr marL="0" indent="0">
+              <a:spcBef>
+                <a:spcPts val="600"/>
+              </a:spcBef>
+              <a:buNone/>
+            </a:pPr>
+            <a:r>
+              <a:rPr lang="fr-CA" sz="1400" b="1" dirty="0"/>
+              <a:t>C. La loi écrite sur le cœur</a:t>
             </a:r>
           </a:p>
           <a:p>
@@ -3753,27 +4418,11 @@
             </a:pPr>
             <a:r>
               <a:rPr lang="fr-CA" sz="1400" b="1" dirty="0"/>
-              <a:t>Application :</a:t>
-            </a:r>
-          </a:p>
-          <a:p>
-            <a:pPr marL="457200" indent="-228600">
-              <a:buFont typeface="Arial"/>
-              <a:buChar char="–"/>
-            </a:pPr>
+              <a:t>Lire </a:t>
+            </a:r>
             <a:r>
               <a:rPr lang="fr-CA" sz="1400" dirty="0"/>
-              <a:t>nous l'aimons parce qu'il nous a aimés le premier (1 Jn 4.19),</a:t>
-            </a:r>
-          </a:p>
-          <a:p>
-            <a:pPr marL="457200" indent="-228600">
-              <a:buFont typeface="Arial"/>
-              <a:buChar char="–"/>
-            </a:pPr>
-            <a:r>
-              <a:rPr lang="fr-CA" sz="1400" dirty="0"/>
-              <a:t>et cet amour se prouve par l'obéissance (Jn 14.15).</a:t>
+              <a:t>Jérémie 31.33 (NBS).</a:t>
             </a:r>
           </a:p>
           <a:p>
@@ -3786,11 +4435,145 @@
             </a:pPr>
             <a:r>
               <a:rPr lang="fr-CA" sz="1400" b="1" dirty="0"/>
-              <a:t>Transition : </a:t>
+              <a:t>La nouvelle alliance : </a:t>
             </a:r>
             <a:r>
               <a:rPr lang="fr-CA" sz="1400" dirty="0"/>
-              <a:t>et le prochain que nous aimons, que lui devons-nous d'abord?</a:t>
+              <a:t>« le pardon de tous nos péchés et l'écriture de la loi de Dieu sur nos cœurs » (80-286).</a:t>
+            </a:r>
+          </a:p>
+          <a:p>
+            <a:pPr marL="228600" indent="-228600">
+              <a:spcBef>
+                <a:spcPts val="300"/>
+              </a:spcBef>
+              <a:buFont typeface="Arial"/>
+              <a:buChar char="•"/>
+            </a:pPr>
+            <a:r>
+              <a:rPr lang="fr-CA" sz="1400" b="1" dirty="0"/>
+              <a:t>Le cœur, c'est la personne intérieure </a:t>
+            </a:r>
+            <a:r>
+              <a:rPr lang="fr-CA" sz="1400" dirty="0"/>
+              <a:t>(1 Ch 28.9); ses trois dimensions sont celles de l'image (point I.B) :</a:t>
+            </a:r>
+          </a:p>
+          <a:p>
+            <a:pPr marL="457200" indent="-228600">
+              <a:buFont typeface="Arial"/>
+              <a:buChar char="•"/>
+            </a:pPr>
+            <a:r>
+              <a:rPr lang="fr-CA" sz="1400" b="1" dirty="0"/>
+              <a:t>Rationnel </a:t>
+            </a:r>
+            <a:r>
+              <a:rPr lang="fr-CA" sz="1400" dirty="0"/>
+              <a:t>(Jn 1.1; 1 Jn 1.1) : le cœur qui pense; Dieu parle en Christ, le Logos (43-2), et renouvelle la pensée.</a:t>
+            </a:r>
+          </a:p>
+          <a:p>
+            <a:pPr marL="457200" indent="-228600">
+              <a:buFont typeface="Arial"/>
+              <a:buChar char="•"/>
+            </a:pPr>
+            <a:r>
+              <a:rPr lang="fr-CA" sz="1400" b="1" dirty="0"/>
+              <a:t>Moral </a:t>
+            </a:r>
+            <a:r>
+              <a:rPr lang="fr-CA" sz="1400" dirty="0"/>
+              <a:t>(Ps 51.12) : le cœur pur qui juge le bien et le mal; le cœur est tortueux (Jr 17.9), Dieu seul en crée un pur.</a:t>
+            </a:r>
+          </a:p>
+          <a:p>
+            <a:pPr marL="457200" indent="-228600">
+              <a:buFont typeface="Arial"/>
+              <a:buChar char="•"/>
+            </a:pPr>
+            <a:r>
+              <a:rPr lang="fr-CA" sz="1400" b="1" dirty="0"/>
+              <a:t>Relationnel </a:t>
+            </a:r>
+            <a:r>
+              <a:rPr lang="fr-CA" sz="1400" dirty="0"/>
+              <a:t>(Mt 22.37-40) : le cœur qui aime; Dieu répand son amour dans nos cœurs par l'Esprit (Rm 5.5).</a:t>
+            </a:r>
+          </a:p>
+          <a:p>
+            <a:pPr marL="0" indent="0">
+              <a:spcBef>
+                <a:spcPts val="600"/>
+              </a:spcBef>
+              <a:buNone/>
+            </a:pPr>
+            <a:r>
+              <a:rPr lang="fr-CA" sz="1400" b="1" dirty="0"/>
+              <a:t>Application</a:t>
+            </a:r>
+          </a:p>
+          <a:p>
+            <a:pPr marL="228600" indent="-228600">
+              <a:spcBef>
+                <a:spcPts val="300"/>
+              </a:spcBef>
+              <a:buFont typeface="Arial"/>
+              <a:buChar char="•"/>
+            </a:pPr>
+            <a:r>
+              <a:rPr lang="fr-CA" sz="1400" dirty="0"/>
+              <a:t>Nous l'aimons parce qu'il nous a aimés le premier (1 Jn 4.19), et cet amour se prouve par l'obéissance (Jn 14.15).</a:t>
+            </a:r>
+          </a:p>
+          <a:p>
+            <a:pPr marL="0" indent="0">
+              <a:spcBef>
+                <a:spcPts val="600"/>
+              </a:spcBef>
+              <a:buNone/>
+            </a:pPr>
+            <a:r>
+              <a:rPr lang="fr-CA" sz="1400" b="1" dirty="0"/>
+              <a:t>Transition</a:t>
+            </a:r>
+          </a:p>
+          <a:p>
+            <a:pPr marL="228600" indent="-228600">
+              <a:spcBef>
+                <a:spcPts val="300"/>
+              </a:spcBef>
+              <a:buFont typeface="Arial"/>
+              <a:buChar char="•"/>
+            </a:pPr>
+            <a:r>
+              <a:rPr lang="fr-CA" sz="1400" dirty="0"/>
+              <a:t>Et le prochain que nous aimons, que lui devons-nous d'abord?</a:t>
+            </a:r>
+          </a:p>
+          <a:p>
+            <a:pPr marL="0" indent="0">
+              <a:spcBef>
+                <a:spcPts val="600"/>
+              </a:spcBef>
+              <a:buNone/>
+            </a:pPr>
+            <a:r>
+              <a:rPr lang="fr-CA" sz="1400" b="1" dirty="0"/>
+              <a:t>À éviter</a:t>
+            </a:r>
+          </a:p>
+          <a:p>
+            <a:pPr marL="228600" indent="-228600">
+              <a:spcBef>
+                <a:spcPts val="300"/>
+              </a:spcBef>
+              <a:buFont typeface="Arial"/>
+              <a:buChar char="•"/>
+            </a:pPr>
+            <a:r>
+              <a:rPr lang="fr-CA" sz="1400" dirty="0"/>
+              <a:t>Prêcher une exhortation à aimer davantage, sans la loi qui accuse, la croix qui pardonne et l'Esprit qui écrit la loi sur le cœur.</a:t>
             </a:r>
           </a:p>
         </p:txBody>
@@ -3883,7 +4666,7 @@
             </a:pPr>
             <a:r>
               <a:rPr lang="fr-CA" sz="1400" b="1" dirty="0"/>
-              <a:t>5 min.</a:t>
+              <a:t>5 min · Matthieu 28.19-20</a:t>
             </a:r>
           </a:p>
           <a:p>
@@ -3896,11 +4679,23 @@
             </a:pPr>
             <a:r>
               <a:rPr lang="fr-CA" sz="1400" b="1" dirty="0"/>
-              <a:t>Un seul impératif : </a:t>
+              <a:t>Phrase clé : </a:t>
             </a:r>
             <a:r>
               <a:rPr lang="fr-CA" sz="1400" dirty="0"/>
-              <a:t>« faites des disciples »; aller, baptiser, enseigner en décrivent le chemin (2405).</a:t>
+              <a:t>ceux que Dieu restaure à son image, il les envoie.</a:t>
+            </a:r>
+          </a:p>
+          <a:p>
+            <a:pPr marL="0" indent="0">
+              <a:spcBef>
+                <a:spcPts val="600"/>
+              </a:spcBef>
+              <a:buNone/>
+            </a:pPr>
+            <a:r>
+              <a:rPr lang="fr-CA" sz="1400" b="1" dirty="0"/>
+              <a:t>Le mandat</a:t>
             </a:r>
           </a:p>
           <a:p>
@@ -3913,31 +4708,11 @@
             </a:pPr>
             <a:r>
               <a:rPr lang="fr-CA" sz="1400" b="1" dirty="0"/>
-              <a:t>Le disciple : </a:t>
+              <a:t>Un seul impératif : </a:t>
             </a:r>
             <a:r>
               <a:rPr lang="fr-CA" sz="1400" dirty="0"/>
-              <a:t>« un croyant qui apprend »;</a:t>
-            </a:r>
-          </a:p>
-          <a:p>
-            <a:pPr marL="457200" indent="-228600">
-              <a:buFont typeface="Arial"/>
-              <a:buChar char="–"/>
-            </a:pPr>
-            <a:r>
-              <a:rPr lang="fr-CA" sz="1400" dirty="0"/>
-              <a:t>« on ne peut être disciple de Christ sans un cœur obéissant » (2405);</a:t>
-            </a:r>
-          </a:p>
-          <a:p>
-            <a:pPr marL="457200" indent="-228600">
-              <a:buFont typeface="Arial"/>
-              <a:buChar char="–"/>
-            </a:pPr>
-            <a:r>
-              <a:rPr lang="fr-CA" sz="1400" dirty="0"/>
-              <a:t>la foi salvatrice se soumet à Christ comme Seigneur.</a:t>
+              <a:t>« faites des disciples »; aller, baptiser, enseigner en décrivent le chemin (2405).</a:t>
             </a:r>
           </a:p>
           <a:p>
@@ -3950,11 +4725,31 @@
             </a:pPr>
             <a:r>
               <a:rPr lang="fr-CA" sz="1400" b="1" dirty="0"/>
-              <a:t>« Au nom » : </a:t>
+              <a:t>Le disciple : </a:t>
             </a:r>
             <a:r>
               <a:rPr lang="fr-CA" sz="1400" dirty="0"/>
-              <a:t>« un seul nom et trois personnes » (2405); le Dieu du « Faisons ».</a:t>
+              <a:t>« un croyant qui apprend »;</a:t>
+            </a:r>
+          </a:p>
+          <a:p>
+            <a:pPr marL="457200" indent="-228600">
+              <a:buFont typeface="Arial"/>
+              <a:buChar char="•"/>
+            </a:pPr>
+            <a:r>
+              <a:rPr lang="fr-CA" sz="1400" dirty="0"/>
+              <a:t>« on ne peut être disciple de Christ sans un cœur obéissant » (2405);</a:t>
+            </a:r>
+          </a:p>
+          <a:p>
+            <a:pPr marL="457200" indent="-228600">
+              <a:buFont typeface="Arial"/>
+              <a:buChar char="•"/>
+            </a:pPr>
+            <a:r>
+              <a:rPr lang="fr-CA" sz="1400" dirty="0"/>
+              <a:t>la foi salvatrice se soumet à Christ comme Seigneur.</a:t>
             </a:r>
           </a:p>
           <a:p>
@@ -3966,6 +4761,20 @@
               <a:buChar char="•"/>
             </a:pPr>
             <a:r>
+              <a:rPr lang="fr-CA" sz="1400" b="1" dirty="0"/>
+              <a:t>« Au nom » : </a:t>
+            </a:r>
+            <a:r>
+              <a:rPr lang="fr-CA" sz="1400" dirty="0"/>
+              <a:t>« un seul nom et trois personnes » (2405); le Dieu du « Faisons ».</a:t>
+            </a:r>
+          </a:p>
+          <a:p>
+            <a:pPr marL="457200" indent="-228600">
+              <a:buFont typeface="Arial"/>
+              <a:buChar char="•"/>
+            </a:pPr>
+            <a:r>
               <a:rPr lang="fr-CA" sz="1400" dirty="0"/>
               <a:t>Le baptême, signe extérieur d'une foi déjà reçue.</a:t>
             </a:r>
@@ -3979,8 +4788,12 @@
               <a:buChar char="•"/>
             </a:pPr>
             <a:r>
+              <a:rPr lang="fr-CA" sz="1400" b="1" dirty="0"/>
+              <a:t>« Tout ce que je vous ai prescrit » : </a:t>
+            </a:r>
+            <a:r>
               <a:rPr lang="fr-CA" sz="1400" dirty="0"/>
-              <a:t>« Tout ce que je vous ai prescrit » inclut le grand commandement : faire des disciples, c'est former d'autres porteurs de l'image restaurée.</a:t>
+              <a:t>y compris le grand commandement; faire des disciples, c'est former d'autres porteurs de l'image restaurée.</a:t>
             </a:r>
           </a:p>
           <a:p>
@@ -3992,8 +4805,24 @@
               <a:buChar char="•"/>
             </a:pPr>
             <a:r>
+              <a:rPr lang="fr-CA" sz="1400" b="1" dirty="0"/>
+              <a:t>« Je suis avec vous tous les jours » : </a:t>
+            </a:r>
+            <a:r>
               <a:rPr lang="fr-CA" sz="1400" dirty="0"/>
-              <a:t>« Je suis avec vous tous les jours » : jusqu'à son retour (2405).</a:t>
+              <a:t>jusqu'à son retour (2405).</a:t>
+            </a:r>
+          </a:p>
+          <a:p>
+            <a:pPr marL="0" indent="0">
+              <a:spcBef>
+                <a:spcPts val="600"/>
+              </a:spcBef>
+              <a:buNone/>
+            </a:pPr>
+            <a:r>
+              <a:rPr lang="fr-CA" sz="1400" b="1" dirty="0"/>
+              <a:t>Application</a:t>
             </a:r>
           </a:p>
           <a:p>
@@ -4005,12 +4834,46 @@
               <a:buChar char="•"/>
             </a:pPr>
             <a:r>
+              <a:rPr lang="fr-CA" sz="1400" dirty="0"/>
+              <a:t>Aimer son prochain, c'est d'abord lui annoncer Christ.</a:t>
+            </a:r>
+          </a:p>
+          <a:p>
+            <a:pPr marL="228600" indent="-228600">
+              <a:spcBef>
+                <a:spcPts val="300"/>
+              </a:spcBef>
+              <a:buFont typeface="Arial"/>
+              <a:buChar char="•"/>
+            </a:pPr>
+            <a:r>
+              <a:rPr lang="fr-CA" sz="1400" dirty="0"/>
+              <a:t>Qui, cette semaine, entendra de vous l'Évangile?</a:t>
+            </a:r>
+          </a:p>
+          <a:p>
+            <a:pPr marL="0" indent="0">
+              <a:spcBef>
+                <a:spcPts val="600"/>
+              </a:spcBef>
+              <a:buNone/>
+            </a:pPr>
+            <a:r>
               <a:rPr lang="fr-CA" sz="1400" b="1" dirty="0"/>
-              <a:t>Application : </a:t>
-            </a:r>
+              <a:t>À éviter</a:t>
+            </a:r>
+          </a:p>
+          <a:p>
+            <a:pPr marL="228600" indent="-228600">
+              <a:spcBef>
+                <a:spcPts val="300"/>
+              </a:spcBef>
+              <a:buFont typeface="Arial"/>
+              <a:buChar char="•"/>
+            </a:pPr>
             <a:r>
               <a:rPr lang="fr-CA" sz="1400" dirty="0"/>
-              <a:t>aimer son prochain, c'est d'abord lui annoncer Christ.</a:t>
+              <a:t>Réduire l'envoi à un appel aux missionnaires : il concerne tout disciple.</a:t>
             </a:r>
           </a:p>
         </p:txBody>

</xml_diff>

<commit_message>
Retient « Morale – Éthique » et « Communion – Affection » (point I.B)
- Plan : les deux étiquettes alignées sur la diapositive 4; PDF régénéré.
- Présentation : libellé « Communion - Affection » sur la diapositive 4;
  les trois libellés de carte passent de 20 à 16 pt, élargis à la carte,
  pour que le plus long tienne sur une ligne (vérifié au rendu).
- Notes et deck.js : mêmes étiquettes.

Co-Authored-By: Claude Opus 5.5 <noreply@anthropic.com>
</commit_message>
<xml_diff>
--- a/Presentation-A-l-image-de-Christ.pptx
+++ b/Presentation-A-l-image-de-Christ.pptx
@@ -2895,7 +2895,7 @@
             </a:pPr>
             <a:r>
               <a:rPr lang="fr-CA" sz="1400" b="1" dirty="0"/>
-              <a:t>Raison : </a:t>
+              <a:t>Raison – Logos : </a:t>
             </a:r>
             <a:r>
               <a:rPr lang="fr-CA" sz="1400" dirty="0"/>
@@ -2909,7 +2909,7 @@
             </a:pPr>
             <a:r>
               <a:rPr lang="fr-CA" sz="1400" b="1" dirty="0"/>
-              <a:t>Morale : </a:t>
+              <a:t>Morale – Éthique : </a:t>
             </a:r>
             <a:r>
               <a:rPr lang="fr-CA" sz="1400" dirty="0"/>
@@ -2923,7 +2923,7 @@
             </a:pPr>
             <a:r>
               <a:rPr lang="fr-CA" sz="1400" b="1" dirty="0"/>
-              <a:t>Relation : </a:t>
+              <a:t>Communion – Affection : </a:t>
             </a:r>
             <a:r>
               <a:rPr lang="fr-CA" sz="1400" dirty="0"/>
@@ -11571,8 +11571,8 @@
         </p:nvSpPr>
         <p:spPr>
           <a:xfrm>
-            <a:off x="4937760" y="3310128"/>
-            <a:ext cx="1828800" cy="365760"/>
+            <a:off x="4800600" y="3310128"/>
+            <a:ext cx="2057400" cy="365760"/>
           </a:xfrm>
           <a:prstGeom prst="rect">
             <a:avLst/>
@@ -11588,7 +11588,7 @@
               <a:buNone/>
             </a:pPr>
             <a:r>
-              <a:rPr lang="fr-CA" sz="2000" b="1" dirty="0">
+              <a:rPr lang="fr-CA" sz="1600" b="1" dirty="0">
                 <a:solidFill>
                   <a:srgbClr val="F4EDE4"/>
                 </a:solidFill>
@@ -11598,7 +11598,7 @@
               </a:rPr>
               <a:t>Raison - Logos</a:t>
             </a:r>
-            <a:endParaRPr lang="fr-CA" sz="2000" dirty="0"/>
+            <a:endParaRPr lang="fr-CA" sz="1600" dirty="0"/>
           </a:p>
         </p:txBody>
       </p:sp>
@@ -11739,8 +11739,8 @@
         </p:nvSpPr>
         <p:spPr>
           <a:xfrm>
-            <a:off x="7315200" y="3310128"/>
-            <a:ext cx="1828800" cy="365760"/>
+            <a:off x="7178040" y="3310128"/>
+            <a:ext cx="2057400" cy="365760"/>
           </a:xfrm>
           <a:prstGeom prst="rect">
             <a:avLst/>
@@ -11756,7 +11756,7 @@
               <a:buNone/>
             </a:pPr>
             <a:r>
-              <a:rPr lang="fr-CA" sz="2000" b="1" dirty="0">
+              <a:rPr lang="fr-CA" sz="1600" b="1" dirty="0">
                 <a:solidFill>
                   <a:srgbClr val="F4EDE4"/>
                 </a:solidFill>
@@ -11766,7 +11766,7 @@
               </a:rPr>
               <a:t>Morale - Éthique</a:t>
             </a:r>
-            <a:endParaRPr lang="fr-CA" sz="2000" dirty="0"/>
+            <a:endParaRPr lang="fr-CA" sz="1600" dirty="0"/>
           </a:p>
         </p:txBody>
       </p:sp>
@@ -11907,8 +11907,8 @@
         </p:nvSpPr>
         <p:spPr>
           <a:xfrm>
-            <a:off x="9692640" y="3310128"/>
-            <a:ext cx="1828800" cy="365760"/>
+            <a:off x="9555480" y="3310128"/>
+            <a:ext cx="2057400" cy="365760"/>
           </a:xfrm>
           <a:prstGeom prst="rect">
             <a:avLst/>
@@ -11924,7 +11924,7 @@
               <a:buNone/>
             </a:pPr>
             <a:r>
-              <a:rPr lang="fr-CA" sz="2000" b="1" dirty="0">
+              <a:rPr lang="fr-CA" sz="1600" b="1" dirty="0">
                 <a:solidFill>
                   <a:srgbClr val="F4EDE4"/>
                 </a:solidFill>
@@ -11932,9 +11932,9 @@
                 <a:ea typeface="Calibri" pitchFamily="34" charset="-122"/>
                 <a:cs typeface="Calibri" pitchFamily="34" charset="-120"/>
               </a:rPr>
-              <a:t> Communion</a:t>
-            </a:r>
-            <a:endParaRPr lang="fr-CA" sz="2000" dirty="0"/>
+              <a:t>Communion - Affection</a:t>
+            </a:r>
+            <a:endParaRPr lang="fr-CA" sz="1600" dirty="0"/>
           </a:p>
         </p:txBody>
       </p:sp>

</xml_diff>

<commit_message>
Enregistre les retouches de la diapositive 2 (couverture de Communion with God)
État du .pptx enregistré dans PowerPoint le 2026-09-30 à 9 h 08, commité tel quel avant l'ajout de la diapositive 11 : mise en page resserrée et seconde couverture (John Owen).

Co-Authored-By: Claude Opus 5.5 <noreply@anthropic.com>
</commit_message>
<xml_diff>
--- a/Presentation-A-l-image-de-Christ.pptx
+++ b/Presentation-A-l-image-de-Christ.pptx
@@ -124,7 +124,7 @@
 <file path=ppt/revisionInfo.xml><?xml version="1.0" encoding="utf-8"?>
 <p1510:revInfo xmlns:a="http://schemas.openxmlformats.org/drawingml/2006/main" xmlns:r="http://schemas.openxmlformats.org/officeDocument/2006/relationships" xmlns:p1510="http://schemas.microsoft.com/office/powerpoint/2015/10/main">
   <p1510:revLst>
-    <p1510:client id="{E0A287C0-9FC5-4D7A-B26A-5C34583FEB53}" v="4" dt="2026-09-30T12:24:07.535"/>
+    <p1510:client id="{E0A287C0-9FC5-4D7A-B26A-5C34583FEB53}" v="7" dt="2026-09-30T13:00:57.183"/>
   </p1510:revLst>
 </p1510:revInfo>
 </file>
@@ -134,7 +134,7 @@
   <pc:docChgLst>
     <pc:chgData name="André-Guy Bruneau" userId="c9f3b82d5570fc32" providerId="LiveId" clId="{C4496A7D-9A64-4B82-9835-F710A7718518}"/>
     <pc:docChg chg="undo custSel addSld delSld modSld">
-      <pc:chgData name="André-Guy Bruneau" userId="c9f3b82d5570fc32" providerId="LiveId" clId="{C4496A7D-9A64-4B82-9835-F710A7718518}" dt="2026-09-30T12:44:02.224" v="1018" actId="6549"/>
+      <pc:chgData name="André-Guy Bruneau" userId="c9f3b82d5570fc32" providerId="LiveId" clId="{C4496A7D-9A64-4B82-9835-F710A7718518}" dt="2026-09-30T13:08:07.107" v="1219" actId="1036"/>
       <pc:docMkLst>
         <pc:docMk/>
       </pc:docMkLst>
@@ -1357,12 +1357,172 @@
           <pc:sldMk cId="3461408040" sldId="284"/>
         </pc:sldMkLst>
       </pc:sldChg>
-      <pc:sldChg chg="add">
-        <pc:chgData name="André-Guy Bruneau" userId="c9f3b82d5570fc32" providerId="LiveId" clId="{C4496A7D-9A64-4B82-9835-F710A7718518}" dt="2026-09-29T09:15:59.934" v="575"/>
+      <pc:sldChg chg="addSp delSp modSp add mod">
+        <pc:chgData name="André-Guy Bruneau" userId="c9f3b82d5570fc32" providerId="LiveId" clId="{C4496A7D-9A64-4B82-9835-F710A7718518}" dt="2026-09-30T13:08:07.107" v="1219" actId="1036"/>
         <pc:sldMkLst>
           <pc:docMk/>
           <pc:sldMk cId="792893114" sldId="285"/>
         </pc:sldMkLst>
+        <pc:spChg chg="mod">
+          <ac:chgData name="André-Guy Bruneau" userId="c9f3b82d5570fc32" providerId="LiveId" clId="{C4496A7D-9A64-4B82-9835-F710A7718518}" dt="2026-09-30T13:01:49.706" v="1032"/>
+          <ac:spMkLst>
+            <pc:docMk/>
+            <pc:sldMk cId="792893114" sldId="285"/>
+            <ac:spMk id="6" creationId="{00000000-0000-0000-0000-000000000000}"/>
+          </ac:spMkLst>
+        </pc:spChg>
+        <pc:spChg chg="mod">
+          <ac:chgData name="André-Guy Bruneau" userId="c9f3b82d5570fc32" providerId="LiveId" clId="{C4496A7D-9A64-4B82-9835-F710A7718518}" dt="2026-09-30T13:01:49.709" v="1049"/>
+          <ac:spMkLst>
+            <pc:docMk/>
+            <pc:sldMk cId="792893114" sldId="285"/>
+            <ac:spMk id="7" creationId="{00000000-0000-0000-0000-000000000000}"/>
+          </ac:spMkLst>
+        </pc:spChg>
+        <pc:spChg chg="mod">
+          <ac:chgData name="André-Guy Bruneau" userId="c9f3b82d5570fc32" providerId="LiveId" clId="{C4496A7D-9A64-4B82-9835-F710A7718518}" dt="2026-09-30T13:01:49.706" v="1033"/>
+          <ac:spMkLst>
+            <pc:docMk/>
+            <pc:sldMk cId="792893114" sldId="285"/>
+            <ac:spMk id="8" creationId="{00000000-0000-0000-0000-000000000000}"/>
+          </ac:spMkLst>
+        </pc:spChg>
+        <pc:spChg chg="mod">
+          <ac:chgData name="André-Guy Bruneau" userId="c9f3b82d5570fc32" providerId="LiveId" clId="{C4496A7D-9A64-4B82-9835-F710A7718518}" dt="2026-09-30T13:01:49.706" v="1034"/>
+          <ac:spMkLst>
+            <pc:docMk/>
+            <pc:sldMk cId="792893114" sldId="285"/>
+            <ac:spMk id="9" creationId="{00000000-0000-0000-0000-000000000000}"/>
+          </ac:spMkLst>
+        </pc:spChg>
+        <pc:spChg chg="mod">
+          <ac:chgData name="André-Guy Bruneau" userId="c9f3b82d5570fc32" providerId="LiveId" clId="{C4496A7D-9A64-4B82-9835-F710A7718518}" dt="2026-09-30T13:01:49.707" v="1036"/>
+          <ac:spMkLst>
+            <pc:docMk/>
+            <pc:sldMk cId="792893114" sldId="285"/>
+            <ac:spMk id="10" creationId="{00000000-0000-0000-0000-000000000000}"/>
+          </ac:spMkLst>
+        </pc:spChg>
+        <pc:spChg chg="mod">
+          <ac:chgData name="André-Guy Bruneau" userId="c9f3b82d5570fc32" providerId="LiveId" clId="{C4496A7D-9A64-4B82-9835-F710A7718518}" dt="2026-09-30T13:01:49.707" v="1037"/>
+          <ac:spMkLst>
+            <pc:docMk/>
+            <pc:sldMk cId="792893114" sldId="285"/>
+            <ac:spMk id="11" creationId="{00000000-0000-0000-0000-000000000000}"/>
+          </ac:spMkLst>
+        </pc:spChg>
+        <pc:spChg chg="mod">
+          <ac:chgData name="André-Guy Bruneau" userId="c9f3b82d5570fc32" providerId="LiveId" clId="{C4496A7D-9A64-4B82-9835-F710A7718518}" dt="2026-09-30T13:01:49.707" v="1038"/>
+          <ac:spMkLst>
+            <pc:docMk/>
+            <pc:sldMk cId="792893114" sldId="285"/>
+            <ac:spMk id="12" creationId="{00000000-0000-0000-0000-000000000000}"/>
+          </ac:spMkLst>
+        </pc:spChg>
+        <pc:spChg chg="mod">
+          <ac:chgData name="André-Guy Bruneau" userId="c9f3b82d5570fc32" providerId="LiveId" clId="{C4496A7D-9A64-4B82-9835-F710A7718518}" dt="2026-09-30T13:01:49.708" v="1040"/>
+          <ac:spMkLst>
+            <pc:docMk/>
+            <pc:sldMk cId="792893114" sldId="285"/>
+            <ac:spMk id="13" creationId="{00000000-0000-0000-0000-000000000000}"/>
+          </ac:spMkLst>
+        </pc:spChg>
+        <pc:spChg chg="mod">
+          <ac:chgData name="André-Guy Bruneau" userId="c9f3b82d5570fc32" providerId="LiveId" clId="{C4496A7D-9A64-4B82-9835-F710A7718518}" dt="2026-09-30T13:01:49.708" v="1041"/>
+          <ac:spMkLst>
+            <pc:docMk/>
+            <pc:sldMk cId="792893114" sldId="285"/>
+            <ac:spMk id="14" creationId="{00000000-0000-0000-0000-000000000000}"/>
+          </ac:spMkLst>
+        </pc:spChg>
+        <pc:spChg chg="mod">
+          <ac:chgData name="André-Guy Bruneau" userId="c9f3b82d5570fc32" providerId="LiveId" clId="{C4496A7D-9A64-4B82-9835-F710A7718518}" dt="2026-09-30T13:01:49.708" v="1042"/>
+          <ac:spMkLst>
+            <pc:docMk/>
+            <pc:sldMk cId="792893114" sldId="285"/>
+            <ac:spMk id="15" creationId="{00000000-0000-0000-0000-000000000000}"/>
+          </ac:spMkLst>
+        </pc:spChg>
+        <pc:spChg chg="mod">
+          <ac:chgData name="André-Guy Bruneau" userId="c9f3b82d5570fc32" providerId="LiveId" clId="{C4496A7D-9A64-4B82-9835-F710A7718518}" dt="2026-09-30T13:01:49.708" v="1044"/>
+          <ac:spMkLst>
+            <pc:docMk/>
+            <pc:sldMk cId="792893114" sldId="285"/>
+            <ac:spMk id="16" creationId="{00000000-0000-0000-0000-000000000000}"/>
+          </ac:spMkLst>
+        </pc:spChg>
+        <pc:spChg chg="mod">
+          <ac:chgData name="André-Guy Bruneau" userId="c9f3b82d5570fc32" providerId="LiveId" clId="{C4496A7D-9A64-4B82-9835-F710A7718518}" dt="2026-09-30T13:01:49.708" v="1045"/>
+          <ac:spMkLst>
+            <pc:docMk/>
+            <pc:sldMk cId="792893114" sldId="285"/>
+            <ac:spMk id="17" creationId="{00000000-0000-0000-0000-000000000000}"/>
+          </ac:spMkLst>
+        </pc:spChg>
+        <pc:spChg chg="mod">
+          <ac:chgData name="André-Guy Bruneau" userId="c9f3b82d5570fc32" providerId="LiveId" clId="{C4496A7D-9A64-4B82-9835-F710A7718518}" dt="2026-09-30T13:01:49.709" v="1046"/>
+          <ac:spMkLst>
+            <pc:docMk/>
+            <pc:sldMk cId="792893114" sldId="285"/>
+            <ac:spMk id="18" creationId="{00000000-0000-0000-0000-000000000000}"/>
+          </ac:spMkLst>
+        </pc:spChg>
+        <pc:spChg chg="mod">
+          <ac:chgData name="André-Guy Bruneau" userId="c9f3b82d5570fc32" providerId="LiveId" clId="{C4496A7D-9A64-4B82-9835-F710A7718518}" dt="2026-09-30T13:01:49.709" v="1048"/>
+          <ac:spMkLst>
+            <pc:docMk/>
+            <pc:sldMk cId="792893114" sldId="285"/>
+            <ac:spMk id="19" creationId="{00000000-0000-0000-0000-000000000000}"/>
+          </ac:spMkLst>
+        </pc:spChg>
+        <pc:spChg chg="mod">
+          <ac:chgData name="André-Guy Bruneau" userId="c9f3b82d5570fc32" providerId="LiveId" clId="{C4496A7D-9A64-4B82-9835-F710A7718518}" dt="2026-09-30T13:01:49.710" v="1051"/>
+          <ac:spMkLst>
+            <pc:docMk/>
+            <pc:sldMk cId="792893114" sldId="285"/>
+            <ac:spMk id="20" creationId="{00000000-0000-0000-0000-000000000000}"/>
+          </ac:spMkLst>
+        </pc:spChg>
+        <pc:spChg chg="mod">
+          <ac:chgData name="André-Guy Bruneau" userId="c9f3b82d5570fc32" providerId="LiveId" clId="{C4496A7D-9A64-4B82-9835-F710A7718518}" dt="2026-09-30T13:01:49.710" v="1053"/>
+          <ac:spMkLst>
+            <pc:docMk/>
+            <pc:sldMk cId="792893114" sldId="285"/>
+            <ac:spMk id="21" creationId="{00000000-0000-0000-0000-000000000000}"/>
+          </ac:spMkLst>
+        </pc:spChg>
+        <pc:spChg chg="add del mod">
+          <ac:chgData name="André-Guy Bruneau" userId="c9f3b82d5570fc32" providerId="LiveId" clId="{C4496A7D-9A64-4B82-9835-F710A7718518}" dt="2026-09-30T13:07:12.833" v="1063"/>
+          <ac:spMkLst>
+            <pc:docMk/>
+            <pc:sldMk cId="792893114" sldId="285"/>
+            <ac:spMk id="34" creationId="{75642AFE-B939-E334-3000-8E1EE1CF2CCE}"/>
+          </ac:spMkLst>
+        </pc:spChg>
+        <pc:picChg chg="mod">
+          <ac:chgData name="André-Guy Bruneau" userId="c9f3b82d5570fc32" providerId="LiveId" clId="{C4496A7D-9A64-4B82-9835-F710A7718518}" dt="2026-09-30T13:01:49.705" v="1029"/>
+          <ac:picMkLst>
+            <pc:docMk/>
+            <pc:sldMk cId="792893114" sldId="285"/>
+            <ac:picMk id="5" creationId="{00000000-0000-0000-0000-000000000000}"/>
+          </ac:picMkLst>
+        </pc:picChg>
+        <pc:picChg chg="mod">
+          <ac:chgData name="André-Guy Bruneau" userId="c9f3b82d5570fc32" providerId="LiveId" clId="{C4496A7D-9A64-4B82-9835-F710A7718518}" dt="2026-09-30T13:08:07.107" v="1219" actId="1036"/>
+          <ac:picMkLst>
+            <pc:docMk/>
+            <pc:sldMk cId="792893114" sldId="285"/>
+            <ac:picMk id="24" creationId="{C0C717DF-1736-21F3-CB87-A7DCC964D2E4}"/>
+          </ac:picMkLst>
+        </pc:picChg>
+        <pc:picChg chg="add mod">
+          <ac:chgData name="André-Guy Bruneau" userId="c9f3b82d5570fc32" providerId="LiveId" clId="{C4496A7D-9A64-4B82-9835-F710A7718518}" dt="2026-09-30T13:08:07.107" v="1219" actId="1036"/>
+          <ac:picMkLst>
+            <pc:docMk/>
+            <pc:sldMk cId="792893114" sldId="285"/>
+            <ac:picMk id="35" creationId="{450799C4-AA29-2500-533B-78607E5CF1C6}"/>
+          </ac:picMkLst>
+        </pc:picChg>
       </pc:sldChg>
       <pc:sldChg chg="modSp add mod">
         <pc:chgData name="André-Guy Bruneau" userId="c9f3b82d5570fc32" providerId="LiveId" clId="{C4496A7D-9A64-4B82-9835-F710A7718518}" dt="2026-09-30T12:44:02.224" v="1018" actId="6549"/>
@@ -7998,8 +8158,8 @@
         </p:blipFill>
         <p:spPr>
           <a:xfrm>
-            <a:off x="647700" y="2159000"/>
-            <a:ext cx="3048000" cy="3048000"/>
+            <a:off x="774700" y="2311400"/>
+            <a:ext cx="2540000" cy="2540000"/>
           </a:xfrm>
           <a:prstGeom prst="rect">
             <a:avLst/>
@@ -8015,7 +8175,7 @@
         <p:spPr>
           <a:xfrm>
             <a:off x="546100" y="5638800"/>
-            <a:ext cx="3263900" cy="635000"/>
+            <a:ext cx="3009900" cy="635000"/>
           </a:xfrm>
           <a:prstGeom prst="rect">
             <a:avLst/>
@@ -8064,7 +8224,7 @@
         </p:nvSpPr>
         <p:spPr>
           <a:xfrm>
-            <a:off x="4457700" y="2349500"/>
+            <a:off x="3822700" y="2349500"/>
             <a:ext cx="0" cy="2468880"/>
           </a:xfrm>
           <a:prstGeom prst="line">
@@ -8094,7 +8254,7 @@
         </p:nvSpPr>
         <p:spPr>
           <a:xfrm>
-            <a:off x="4191000" y="2070100"/>
+            <a:off x="3556000" y="2070100"/>
             <a:ext cx="548640" cy="548640"/>
           </a:xfrm>
           <a:prstGeom prst="ellipse">
@@ -8126,7 +8286,7 @@
         </p:nvSpPr>
         <p:spPr>
           <a:xfrm>
-            <a:off x="4191000" y="2070100"/>
+            <a:off x="3556000" y="2070100"/>
             <a:ext cx="548640" cy="548640"/>
           </a:xfrm>
           <a:prstGeom prst="rect">
@@ -8165,8 +8325,8 @@
         </p:nvSpPr>
         <p:spPr>
           <a:xfrm>
-            <a:off x="4965700" y="2032000"/>
-            <a:ext cx="4191000" cy="731520"/>
+            <a:off x="4330700" y="2032000"/>
+            <a:ext cx="3810000" cy="731520"/>
           </a:xfrm>
           <a:prstGeom prst="rect">
             <a:avLst/>
@@ -8221,7 +8381,7 @@
         </p:nvSpPr>
         <p:spPr>
           <a:xfrm>
-            <a:off x="4191000" y="2895600"/>
+            <a:off x="3556000" y="2895600"/>
             <a:ext cx="548640" cy="548640"/>
           </a:xfrm>
           <a:prstGeom prst="ellipse">
@@ -8253,7 +8413,7 @@
         </p:nvSpPr>
         <p:spPr>
           <a:xfrm>
-            <a:off x="4191000" y="2895600"/>
+            <a:off x="3556000" y="2895600"/>
             <a:ext cx="548640" cy="548640"/>
           </a:xfrm>
           <a:prstGeom prst="rect">
@@ -8292,8 +8452,8 @@
         </p:nvSpPr>
         <p:spPr>
           <a:xfrm>
-            <a:off x="4965700" y="2857500"/>
-            <a:ext cx="4191000" cy="731520"/>
+            <a:off x="4330700" y="2857500"/>
+            <a:ext cx="3810000" cy="731520"/>
           </a:xfrm>
           <a:prstGeom prst="rect">
             <a:avLst/>
@@ -8348,7 +8508,7 @@
         </p:nvSpPr>
         <p:spPr>
           <a:xfrm>
-            <a:off x="4191000" y="3721100"/>
+            <a:off x="3556000" y="3721100"/>
             <a:ext cx="548640" cy="548640"/>
           </a:xfrm>
           <a:prstGeom prst="ellipse">
@@ -8380,7 +8540,7 @@
         </p:nvSpPr>
         <p:spPr>
           <a:xfrm>
-            <a:off x="4191000" y="3721100"/>
+            <a:off x="3556000" y="3721100"/>
             <a:ext cx="548640" cy="548640"/>
           </a:xfrm>
           <a:prstGeom prst="rect">
@@ -8419,8 +8579,8 @@
         </p:nvSpPr>
         <p:spPr>
           <a:xfrm>
-            <a:off x="4965700" y="3683000"/>
-            <a:ext cx="4191000" cy="731520"/>
+            <a:off x="4330700" y="3683000"/>
+            <a:ext cx="3810000" cy="731520"/>
           </a:xfrm>
           <a:prstGeom prst="rect">
             <a:avLst/>
@@ -8475,7 +8635,7 @@
         </p:nvSpPr>
         <p:spPr>
           <a:xfrm>
-            <a:off x="4191000" y="4546600"/>
+            <a:off x="3556000" y="4546600"/>
             <a:ext cx="548640" cy="548640"/>
           </a:xfrm>
           <a:prstGeom prst="ellipse">
@@ -8507,7 +8667,7 @@
         </p:nvSpPr>
         <p:spPr>
           <a:xfrm>
-            <a:off x="4191000" y="4546600"/>
+            <a:off x="3556000" y="4546600"/>
             <a:ext cx="548640" cy="548640"/>
           </a:xfrm>
           <a:prstGeom prst="rect">
@@ -8546,8 +8706,8 @@
         </p:nvSpPr>
         <p:spPr>
           <a:xfrm>
-            <a:off x="4965700" y="4508500"/>
-            <a:ext cx="4191000" cy="731520"/>
+            <a:off x="4330700" y="4508500"/>
+            <a:ext cx="3810000" cy="731520"/>
           </a:xfrm>
           <a:prstGeom prst="rect">
             <a:avLst/>
@@ -8602,8 +8762,8 @@
         </p:nvSpPr>
         <p:spPr>
           <a:xfrm>
-            <a:off x="4191000" y="5638800"/>
-            <a:ext cx="7416800" cy="635000"/>
+            <a:off x="3556000" y="5638800"/>
+            <a:ext cx="8089900" cy="635000"/>
           </a:xfrm>
           <a:prstGeom prst="roundRect">
             <a:avLst>
@@ -8636,8 +8796,8 @@
         </p:nvSpPr>
         <p:spPr>
           <a:xfrm>
-            <a:off x="4419600" y="5638800"/>
-            <a:ext cx="6959600" cy="635000"/>
+            <a:off x="3784600" y="5638800"/>
+            <a:ext cx="7632700" cy="635000"/>
           </a:xfrm>
           <a:prstGeom prst="rect">
             <a:avLst/>
@@ -8700,8 +8860,8 @@
         </p:blipFill>
         <p:spPr>
           <a:xfrm>
-            <a:off x="9550400" y="1981200"/>
-            <a:ext cx="2057400" cy="3276600"/>
+            <a:off x="7926034" y="2374278"/>
+            <a:ext cx="1741170" cy="2785872"/>
           </a:xfrm>
           <a:prstGeom prst="rect">
             <a:avLst/>
@@ -9269,6 +9429,36 @@
           </p:txBody>
         </p:sp>
       </p:grpSp>
+      <p:pic>
+        <p:nvPicPr>
+          <p:cNvPr id="35" name="Image 34">
+            <a:extLst>
+              <a:ext uri="{FF2B5EF4-FFF2-40B4-BE49-F238E27FC236}">
+                <a16:creationId xmlns:a16="http://schemas.microsoft.com/office/drawing/2014/main" id="{450799C4-AA29-2500-533B-78607E5CF1C6}"/>
+              </a:ext>
+            </a:extLst>
+          </p:cNvPr>
+          <p:cNvPicPr>
+            <a:picLocks noChangeAspect="1"/>
+          </p:cNvPicPr>
+          <p:nvPr/>
+        </p:nvPicPr>
+        <p:blipFill>
+          <a:blip r:embed="rId5"/>
+          <a:stretch>
+            <a:fillRect/>
+          </a:stretch>
+        </p:blipFill>
+        <p:spPr>
+          <a:xfrm>
+            <a:off x="9961476" y="2419248"/>
+            <a:ext cx="1847961" cy="2785872"/>
+          </a:xfrm>
+          <a:prstGeom prst="rect">
+            <a:avLst/>
+          </a:prstGeom>
+        </p:spPr>
+      </p:pic>
     </p:spTree>
     <p:extLst>
       <p:ext uri="{BB962C8B-B14F-4D97-AF65-F5344CB8AC3E}">
@@ -21873,7 +22063,7 @@
 
 <file path=ppt/webextensions/taskpanes.xml><?xml version="1.0" encoding="utf-8"?>
 <wetp:taskpanes xmlns:wetp="http://schemas.microsoft.com/office/webextensions/taskpanes/2010/11">
-  <wetp:taskpane dockstate="right" visibility="0" width="438" row="0">
+  <wetp:taskpane dockstate="right" visibility="0" width="438" row="1">
     <wetp:webextensionref xmlns:r="http://schemas.openxmlformats.org/officeDocument/2006/relationships" r:id="rId1"/>
   </wetp:taskpane>
 </wetp:taskpanes>

</xml_diff>